<commit_message>
fix(docs): route diagrams around unrelated nodes
</commit_message>
<xml_diff>
--- a/docs/presentations/CityPulse-Project-Presentation.pptx
+++ b/docs/presentations/CityPulse-Project-Presentation.pptx
@@ -9017,9 +9017,9 @@
           <p:nvPr/>
         </p:nvCxnSpPr>
         <p:spPr>
-          <a:xfrm>
-            <a:off x="6309359" y="3127248"/>
-            <a:ext cx="2752345" cy="0"/>
+          <a:xfrm flipV="1">
+            <a:off x="5143500" y="2642615"/>
+            <a:ext cx="0" cy="128017"/>
           </a:xfrm>
           <a:prstGeom prst="line">
             <a:avLst/>
@@ -9028,7 +9028,6 @@
             <a:solidFill>
               <a:srgbClr val="67E8F9"/>
             </a:solidFill>
-            <a:tailEnd type="triangle"/>
           </a:ln>
         </p:spPr>
         <p:style>
@@ -9054,8 +9053,8 @@
         </p:nvCxnSpPr>
         <p:spPr>
           <a:xfrm>
-            <a:off x="5143500" y="3483863"/>
-            <a:ext cx="0" cy="160021"/>
+            <a:off x="5143500" y="2642615"/>
+            <a:ext cx="5084064" cy="0"/>
           </a:xfrm>
           <a:prstGeom prst="line">
             <a:avLst/>
@@ -9089,8 +9088,8 @@
         </p:nvCxnSpPr>
         <p:spPr>
           <a:xfrm>
-            <a:off x="5143500" y="3643884"/>
-            <a:ext cx="0" cy="0"/>
+            <a:off x="10227564" y="2642615"/>
+            <a:ext cx="0" cy="128017"/>
           </a:xfrm>
           <a:prstGeom prst="line">
             <a:avLst/>
@@ -9099,6 +9098,7 @@
             <a:solidFill>
               <a:srgbClr val="67E8F9"/>
             </a:solidFill>
+            <a:tailEnd type="triangle"/>
           </a:ln>
         </p:spPr>
         <p:style>
@@ -9124,8 +9124,8 @@
         </p:nvCxnSpPr>
         <p:spPr>
           <a:xfrm>
-            <a:off x="5143500" y="3643884"/>
-            <a:ext cx="0" cy="160020"/>
+            <a:off x="5143500" y="3483863"/>
+            <a:ext cx="0" cy="160021"/>
           </a:xfrm>
           <a:prstGeom prst="line">
             <a:avLst/>
@@ -9134,7 +9134,6 @@
             <a:solidFill>
               <a:srgbClr val="67E8F9"/>
             </a:solidFill>
-            <a:tailEnd type="triangle"/>
           </a:ln>
         </p:spPr>
         <p:style>
@@ -9160,8 +9159,43 @@
         </p:nvCxnSpPr>
         <p:spPr>
           <a:xfrm>
-            <a:off x="6309359" y="4160520"/>
-            <a:ext cx="210312" cy="0"/>
+            <a:off x="5143500" y="3643884"/>
+            <a:ext cx="0" cy="0"/>
+          </a:xfrm>
+          <a:prstGeom prst="line">
+            <a:avLst/>
+          </a:prstGeom>
+          <a:ln w="12700">
+            <a:solidFill>
+              <a:srgbClr val="67E8F9"/>
+            </a:solidFill>
+          </a:ln>
+        </p:spPr>
+        <p:style>
+          <a:lnRef idx="2">
+            <a:schemeClr val="accent1"/>
+          </a:lnRef>
+          <a:fillRef idx="0">
+            <a:schemeClr val="accent1"/>
+          </a:fillRef>
+          <a:effectRef idx="1">
+            <a:schemeClr val="accent1"/>
+          </a:effectRef>
+          <a:fontRef idx="minor">
+            <a:schemeClr val="tx1"/>
+          </a:fontRef>
+        </p:style>
+      </p:cxnSp>
+      <p:cxnSp>
+        <p:nvCxnSpPr>
+          <p:cNvPr id="21" name="Connector 20"/>
+          <p:cNvCxnSpPr/>
+          <p:nvPr/>
+        </p:nvCxnSpPr>
+        <p:spPr>
+          <a:xfrm>
+            <a:off x="5143500" y="3643884"/>
+            <a:ext cx="0" cy="160020"/>
           </a:xfrm>
           <a:prstGeom prst="line">
             <a:avLst/>
@@ -9188,9 +9222,45 @@
           </a:fontRef>
         </p:style>
       </p:cxnSp>
-      <p:sp>
-        <p:nvSpPr>
-          <p:cNvPr id="21" name="Rectangle 20"/>
+      <p:cxnSp>
+        <p:nvCxnSpPr>
+          <p:cNvPr id="22" name="Connector 21"/>
+          <p:cNvCxnSpPr/>
+          <p:nvPr/>
+        </p:nvCxnSpPr>
+        <p:spPr>
+          <a:xfrm>
+            <a:off x="6309359" y="4160520"/>
+            <a:ext cx="210312" cy="0"/>
+          </a:xfrm>
+          <a:prstGeom prst="line">
+            <a:avLst/>
+          </a:prstGeom>
+          <a:ln w="12700">
+            <a:solidFill>
+              <a:srgbClr val="67E8F9"/>
+            </a:solidFill>
+            <a:tailEnd type="triangle"/>
+          </a:ln>
+        </p:spPr>
+        <p:style>
+          <a:lnRef idx="2">
+            <a:schemeClr val="accent1"/>
+          </a:lnRef>
+          <a:fillRef idx="0">
+            <a:schemeClr val="accent1"/>
+          </a:fillRef>
+          <a:effectRef idx="1">
+            <a:schemeClr val="accent1"/>
+          </a:effectRef>
+          <a:fontRef idx="minor">
+            <a:schemeClr val="tx1"/>
+          </a:fontRef>
+        </p:style>
+      </p:cxnSp>
+      <p:sp>
+        <p:nvSpPr>
+          <p:cNvPr id="23" name="Rectangle 22"/>
           <p:cNvSpPr/>
           <p:nvPr/>
         </p:nvSpPr>
@@ -9235,7 +9305,7 @@
       </p:sp>
       <p:sp>
         <p:nvSpPr>
-          <p:cNvPr id="22" name="Diagram label: Browser"/>
+          <p:cNvPr id="24" name="Diagram label: Browser"/>
           <p:cNvSpPr txBox="1"/>
           <p:nvPr/>
         </p:nvSpPr>
@@ -9277,7 +9347,7 @@
       </p:sp>
       <p:sp>
         <p:nvSpPr>
-          <p:cNvPr id="23" name="Rectangle 22"/>
+          <p:cNvPr id="25" name="Rectangle 24"/>
           <p:cNvSpPr/>
           <p:nvPr/>
         </p:nvSpPr>
@@ -9322,7 +9392,7 @@
       </p:sp>
       <p:sp>
         <p:nvSpPr>
-          <p:cNvPr id="24" name="Diagram label: Next.js BFF"/>
+          <p:cNvPr id="26" name="Diagram label: Next.js BFF"/>
           <p:cNvSpPr txBox="1"/>
           <p:nvPr/>
         </p:nvSpPr>
@@ -9364,7 +9434,7 @@
       </p:sp>
       <p:sp>
         <p:nvSpPr>
-          <p:cNvPr id="25" name="Rectangle 24"/>
+          <p:cNvPr id="27" name="Rectangle 26"/>
           <p:cNvSpPr/>
           <p:nvPr/>
         </p:nvSpPr>
@@ -9409,7 +9479,7 @@
       </p:sp>
       <p:sp>
         <p:nvSpPr>
-          <p:cNvPr id="26" name="Diagram label: OIDC provider"/>
+          <p:cNvPr id="28" name="Diagram label: OIDC provider"/>
           <p:cNvSpPr txBox="1"/>
           <p:nvPr/>
         </p:nvSpPr>
@@ -9451,7 +9521,7 @@
       </p:sp>
       <p:sp>
         <p:nvSpPr>
-          <p:cNvPr id="27" name="Rectangle 26"/>
+          <p:cNvPr id="29" name="Rectangle 28"/>
           <p:cNvSpPr/>
           <p:nvPr/>
         </p:nvSpPr>
@@ -9496,7 +9566,7 @@
       </p:sp>
       <p:sp>
         <p:nvSpPr>
-          <p:cNvPr id="28" name="Diagram label: Spring API"/>
+          <p:cNvPr id="30" name="Diagram label: Spring API"/>
           <p:cNvSpPr txBox="1"/>
           <p:nvPr/>
         </p:nvSpPr>
@@ -9538,7 +9608,7 @@
       </p:sp>
       <p:sp>
         <p:nvSpPr>
-          <p:cNvPr id="29" name="Rectangle 28"/>
+          <p:cNvPr id="31" name="Rectangle 30"/>
           <p:cNvSpPr/>
           <p:nvPr/>
         </p:nvSpPr>
@@ -9583,7 +9653,7 @@
       </p:sp>
       <p:sp>
         <p:nvSpPr>
-          <p:cNvPr id="30" name="Diagram label: PostgreSQL/PostGIS"/>
+          <p:cNvPr id="32" name="Diagram label: PostgreSQL/PostGIS"/>
           <p:cNvSpPr txBox="1"/>
           <p:nvPr/>
         </p:nvSpPr>
@@ -9625,7 +9695,7 @@
       </p:sp>
       <p:sp>
         <p:nvSpPr>
-          <p:cNvPr id="31" name="Rectangle 30"/>
+          <p:cNvPr id="33" name="Rectangle 32"/>
           <p:cNvSpPr/>
           <p:nvPr/>
         </p:nvSpPr>
@@ -9670,7 +9740,7 @@
       </p:sp>
       <p:sp>
         <p:nvSpPr>
-          <p:cNvPr id="32" name="Diagram label: Redis"/>
+          <p:cNvPr id="34" name="Diagram label: Redis"/>
           <p:cNvSpPr txBox="1"/>
           <p:nvPr/>
         </p:nvSpPr>
@@ -9712,7 +9782,7 @@
       </p:sp>
       <p:sp>
         <p:nvSpPr>
-          <p:cNvPr id="33" name="Rectangle 32"/>
+          <p:cNvPr id="35" name="Rectangle 34"/>
           <p:cNvSpPr/>
           <p:nvPr/>
         </p:nvSpPr>
@@ -9757,7 +9827,7 @@
       </p:sp>
       <p:sp>
         <p:nvSpPr>
-          <p:cNvPr id="34" name="Diagram label: FastAPI / SciPy"/>
+          <p:cNvPr id="36" name="Diagram label: FastAPI / SciPy"/>
           <p:cNvSpPr txBox="1"/>
           <p:nvPr/>
         </p:nvSpPr>
@@ -9799,7 +9869,7 @@
       </p:sp>
       <p:sp>
         <p:nvSpPr>
-          <p:cNvPr id="35" name="Rectangle 34"/>
+          <p:cNvPr id="37" name="Rectangle 36"/>
           <p:cNvSpPr/>
           <p:nvPr/>
         </p:nvSpPr>
@@ -9844,7 +9914,7 @@
       </p:sp>
       <p:sp>
         <p:nvSpPr>
-          <p:cNvPr id="36" name="Diagram label: AI state and models"/>
+          <p:cNvPr id="38" name="Diagram label: AI state and models"/>
           <p:cNvSpPr txBox="1"/>
           <p:nvPr/>
         </p:nvSpPr>
@@ -9886,7 +9956,7 @@
       </p:sp>
       <p:sp>
         <p:nvSpPr>
-          <p:cNvPr id="37" name="Rectangle 36"/>
+          <p:cNvPr id="39" name="Rectangle 38"/>
           <p:cNvSpPr/>
           <p:nvPr/>
         </p:nvSpPr>
@@ -9931,7 +10001,7 @@
       </p:sp>
       <p:sp>
         <p:nvSpPr>
-          <p:cNvPr id="38" name="Diagram label: Local EVM"/>
+          <p:cNvPr id="40" name="Diagram label: Local EVM"/>
           <p:cNvSpPr txBox="1"/>
           <p:nvPr/>
         </p:nvSpPr>
@@ -11983,9 +12053,9 @@
           <p:nvPr/>
         </p:nvCxnSpPr>
         <p:spPr>
-          <a:xfrm>
-            <a:off x="6309359" y="3127248"/>
-            <a:ext cx="2752345" cy="0"/>
+          <a:xfrm flipV="1">
+            <a:off x="5143500" y="2642615"/>
+            <a:ext cx="0" cy="128017"/>
           </a:xfrm>
           <a:prstGeom prst="line">
             <a:avLst/>
@@ -11994,7 +12064,6 @@
             <a:solidFill>
               <a:srgbClr val="67E8F9"/>
             </a:solidFill>
-            <a:tailEnd type="triangle"/>
           </a:ln>
         </p:spPr>
         <p:style>
@@ -12020,8 +12089,8 @@
         </p:nvCxnSpPr>
         <p:spPr>
           <a:xfrm>
-            <a:off x="5143500" y="2450591"/>
-            <a:ext cx="0" cy="1193292"/>
+            <a:off x="5143500" y="2642615"/>
+            <a:ext cx="5084064" cy="0"/>
           </a:xfrm>
           <a:prstGeom prst="line">
             <a:avLst/>
@@ -12055,8 +12124,8 @@
         </p:nvCxnSpPr>
         <p:spPr>
           <a:xfrm>
-            <a:off x="5143500" y="3643883"/>
-            <a:ext cx="0" cy="0"/>
+            <a:off x="10227564" y="2642615"/>
+            <a:ext cx="0" cy="128017"/>
           </a:xfrm>
           <a:prstGeom prst="line">
             <a:avLst/>
@@ -12065,6 +12134,7 @@
             <a:solidFill>
               <a:srgbClr val="67E8F9"/>
             </a:solidFill>
+            <a:tailEnd type="triangle"/>
           </a:ln>
         </p:spPr>
         <p:style>
@@ -12090,8 +12160,8 @@
         </p:nvCxnSpPr>
         <p:spPr>
           <a:xfrm>
-            <a:off x="5143500" y="3643883"/>
-            <a:ext cx="0" cy="1193292"/>
+            <a:off x="5143500" y="2450591"/>
+            <a:ext cx="0" cy="128017"/>
           </a:xfrm>
           <a:prstGeom prst="line">
             <a:avLst/>
@@ -12100,7 +12170,6 @@
             <a:solidFill>
               <a:srgbClr val="67E8F9"/>
             </a:solidFill>
-            <a:tailEnd type="triangle"/>
           </a:ln>
         </p:spPr>
         <p:style>
@@ -12125,9 +12194,9 @@
           <p:nvPr/>
         </p:nvCxnSpPr>
         <p:spPr>
-          <a:xfrm>
-            <a:off x="5143500" y="2450591"/>
-            <a:ext cx="0" cy="1193292"/>
+          <a:xfrm flipH="1">
+            <a:off x="3849624" y="2578608"/>
+            <a:ext cx="1293876" cy="0"/>
           </a:xfrm>
           <a:prstGeom prst="line">
             <a:avLst/>
@@ -12161,8 +12230,8 @@
         </p:nvCxnSpPr>
         <p:spPr>
           <a:xfrm>
-            <a:off x="5143500" y="3643883"/>
-            <a:ext cx="2542031" cy="0"/>
+            <a:off x="3849624" y="2578608"/>
+            <a:ext cx="0" cy="2130551"/>
           </a:xfrm>
           <a:prstGeom prst="line">
             <a:avLst/>
@@ -12196,8 +12265,8 @@
         </p:nvCxnSpPr>
         <p:spPr>
           <a:xfrm>
-            <a:off x="7685531" y="3643883"/>
-            <a:ext cx="0" cy="1193292"/>
+            <a:off x="3849624" y="4709159"/>
+            <a:ext cx="1293876" cy="0"/>
           </a:xfrm>
           <a:prstGeom prst="line">
             <a:avLst/>
@@ -12206,7 +12275,6 @@
             <a:solidFill>
               <a:srgbClr val="67E8F9"/>
             </a:solidFill>
-            <a:tailEnd type="triangle"/>
           </a:ln>
         </p:spPr>
         <p:style>
@@ -12232,8 +12300,8 @@
         </p:nvCxnSpPr>
         <p:spPr>
           <a:xfrm>
-            <a:off x="5143500" y="2450591"/>
-            <a:ext cx="0" cy="676657"/>
+            <a:off x="5143500" y="4709159"/>
+            <a:ext cx="0" cy="128016"/>
           </a:xfrm>
           <a:prstGeom prst="line">
             <a:avLst/>
@@ -12242,6 +12310,7 @@
             <a:solidFill>
               <a:srgbClr val="67E8F9"/>
             </a:solidFill>
+            <a:tailEnd type="triangle"/>
           </a:ln>
         </p:spPr>
         <p:style>
@@ -12267,8 +12336,8 @@
         </p:nvCxnSpPr>
         <p:spPr>
           <a:xfrm>
-            <a:off x="5143500" y="3127248"/>
-            <a:ext cx="0" cy="0"/>
+            <a:off x="5143500" y="2450591"/>
+            <a:ext cx="0" cy="128017"/>
           </a:xfrm>
           <a:prstGeom prst="line">
             <a:avLst/>
@@ -12301,9 +12370,9 @@
           <p:nvPr/>
         </p:nvCxnSpPr>
         <p:spPr>
-          <a:xfrm>
-            <a:off x="5143500" y="3127248"/>
-            <a:ext cx="0" cy="676656"/>
+          <a:xfrm flipH="1">
+            <a:off x="3849624" y="2578608"/>
+            <a:ext cx="1293876" cy="0"/>
           </a:xfrm>
           <a:prstGeom prst="line">
             <a:avLst/>
@@ -12312,7 +12381,6 @@
             <a:solidFill>
               <a:srgbClr val="67E8F9"/>
             </a:solidFill>
-            <a:tailEnd type="triangle"/>
           </a:ln>
         </p:spPr>
         <p:style>
@@ -12338,8 +12406,8 @@
         </p:nvCxnSpPr>
         <p:spPr>
           <a:xfrm>
-            <a:off x="5143500" y="2450591"/>
-            <a:ext cx="0" cy="676657"/>
+            <a:off x="3849624" y="2578608"/>
+            <a:ext cx="0" cy="2130551"/>
           </a:xfrm>
           <a:prstGeom prst="line">
             <a:avLst/>
@@ -12373,8 +12441,8 @@
         </p:nvCxnSpPr>
         <p:spPr>
           <a:xfrm>
-            <a:off x="5143500" y="3127248"/>
-            <a:ext cx="5084064" cy="0"/>
+            <a:off x="3849624" y="4709159"/>
+            <a:ext cx="3835907" cy="0"/>
           </a:xfrm>
           <a:prstGeom prst="line">
             <a:avLst/>
@@ -12408,8 +12476,8 @@
         </p:nvCxnSpPr>
         <p:spPr>
           <a:xfrm>
-            <a:off x="10227564" y="3127248"/>
-            <a:ext cx="0" cy="676656"/>
+            <a:off x="7685531" y="4709159"/>
+            <a:ext cx="0" cy="128016"/>
           </a:xfrm>
           <a:prstGeom prst="line">
             <a:avLst/>
@@ -12436,9 +12504,361 @@
           </a:fontRef>
         </p:style>
       </p:cxnSp>
-      <p:sp>
-        <p:nvSpPr>
-          <p:cNvPr id="31" name="Rectangle 30"/>
+      <p:cxnSp>
+        <p:nvCxnSpPr>
+          <p:cNvPr id="31" name="Connector 30"/>
+          <p:cNvCxnSpPr/>
+          <p:nvPr/>
+        </p:nvCxnSpPr>
+        <p:spPr>
+          <a:xfrm>
+            <a:off x="5143500" y="2450591"/>
+            <a:ext cx="0" cy="128017"/>
+          </a:xfrm>
+          <a:prstGeom prst="line">
+            <a:avLst/>
+          </a:prstGeom>
+          <a:ln w="12700">
+            <a:solidFill>
+              <a:srgbClr val="67E8F9"/>
+            </a:solidFill>
+          </a:ln>
+        </p:spPr>
+        <p:style>
+          <a:lnRef idx="2">
+            <a:schemeClr val="accent1"/>
+          </a:lnRef>
+          <a:fillRef idx="0">
+            <a:schemeClr val="accent1"/>
+          </a:fillRef>
+          <a:effectRef idx="1">
+            <a:schemeClr val="accent1"/>
+          </a:effectRef>
+          <a:fontRef idx="minor">
+            <a:schemeClr val="tx1"/>
+          </a:fontRef>
+        </p:style>
+      </p:cxnSp>
+      <p:cxnSp>
+        <p:nvCxnSpPr>
+          <p:cNvPr id="32" name="Connector 31"/>
+          <p:cNvCxnSpPr/>
+          <p:nvPr/>
+        </p:nvCxnSpPr>
+        <p:spPr>
+          <a:xfrm flipH="1">
+            <a:off x="3849624" y="2578608"/>
+            <a:ext cx="1293876" cy="0"/>
+          </a:xfrm>
+          <a:prstGeom prst="line">
+            <a:avLst/>
+          </a:prstGeom>
+          <a:ln w="12700">
+            <a:solidFill>
+              <a:srgbClr val="67E8F9"/>
+            </a:solidFill>
+          </a:ln>
+        </p:spPr>
+        <p:style>
+          <a:lnRef idx="2">
+            <a:schemeClr val="accent1"/>
+          </a:lnRef>
+          <a:fillRef idx="0">
+            <a:schemeClr val="accent1"/>
+          </a:fillRef>
+          <a:effectRef idx="1">
+            <a:schemeClr val="accent1"/>
+          </a:effectRef>
+          <a:fontRef idx="minor">
+            <a:schemeClr val="tx1"/>
+          </a:fontRef>
+        </p:style>
+      </p:cxnSp>
+      <p:cxnSp>
+        <p:nvCxnSpPr>
+          <p:cNvPr id="33" name="Connector 32"/>
+          <p:cNvCxnSpPr/>
+          <p:nvPr/>
+        </p:nvCxnSpPr>
+        <p:spPr>
+          <a:xfrm>
+            <a:off x="3849624" y="2578608"/>
+            <a:ext cx="0" cy="1097280"/>
+          </a:xfrm>
+          <a:prstGeom prst="line">
+            <a:avLst/>
+          </a:prstGeom>
+          <a:ln w="12700">
+            <a:solidFill>
+              <a:srgbClr val="67E8F9"/>
+            </a:solidFill>
+          </a:ln>
+        </p:spPr>
+        <p:style>
+          <a:lnRef idx="2">
+            <a:schemeClr val="accent1"/>
+          </a:lnRef>
+          <a:fillRef idx="0">
+            <a:schemeClr val="accent1"/>
+          </a:fillRef>
+          <a:effectRef idx="1">
+            <a:schemeClr val="accent1"/>
+          </a:effectRef>
+          <a:fontRef idx="minor">
+            <a:schemeClr val="tx1"/>
+          </a:fontRef>
+        </p:style>
+      </p:cxnSp>
+      <p:cxnSp>
+        <p:nvCxnSpPr>
+          <p:cNvPr id="34" name="Connector 33"/>
+          <p:cNvCxnSpPr/>
+          <p:nvPr/>
+        </p:nvCxnSpPr>
+        <p:spPr>
+          <a:xfrm>
+            <a:off x="3849624" y="3675888"/>
+            <a:ext cx="1293876" cy="0"/>
+          </a:xfrm>
+          <a:prstGeom prst="line">
+            <a:avLst/>
+          </a:prstGeom>
+          <a:ln w="12700">
+            <a:solidFill>
+              <a:srgbClr val="67E8F9"/>
+            </a:solidFill>
+          </a:ln>
+        </p:spPr>
+        <p:style>
+          <a:lnRef idx="2">
+            <a:schemeClr val="accent1"/>
+          </a:lnRef>
+          <a:fillRef idx="0">
+            <a:schemeClr val="accent1"/>
+          </a:fillRef>
+          <a:effectRef idx="1">
+            <a:schemeClr val="accent1"/>
+          </a:effectRef>
+          <a:fontRef idx="minor">
+            <a:schemeClr val="tx1"/>
+          </a:fontRef>
+        </p:style>
+      </p:cxnSp>
+      <p:cxnSp>
+        <p:nvCxnSpPr>
+          <p:cNvPr id="35" name="Connector 34"/>
+          <p:cNvCxnSpPr/>
+          <p:nvPr/>
+        </p:nvCxnSpPr>
+        <p:spPr>
+          <a:xfrm>
+            <a:off x="5143500" y="3675888"/>
+            <a:ext cx="0" cy="128016"/>
+          </a:xfrm>
+          <a:prstGeom prst="line">
+            <a:avLst/>
+          </a:prstGeom>
+          <a:ln w="12700">
+            <a:solidFill>
+              <a:srgbClr val="67E8F9"/>
+            </a:solidFill>
+            <a:tailEnd type="triangle"/>
+          </a:ln>
+        </p:spPr>
+        <p:style>
+          <a:lnRef idx="2">
+            <a:schemeClr val="accent1"/>
+          </a:lnRef>
+          <a:fillRef idx="0">
+            <a:schemeClr val="accent1"/>
+          </a:fillRef>
+          <a:effectRef idx="1">
+            <a:schemeClr val="accent1"/>
+          </a:effectRef>
+          <a:fontRef idx="minor">
+            <a:schemeClr val="tx1"/>
+          </a:fontRef>
+        </p:style>
+      </p:cxnSp>
+      <p:cxnSp>
+        <p:nvCxnSpPr>
+          <p:cNvPr id="36" name="Connector 35"/>
+          <p:cNvCxnSpPr/>
+          <p:nvPr/>
+        </p:nvCxnSpPr>
+        <p:spPr>
+          <a:xfrm>
+            <a:off x="5143500" y="2450591"/>
+            <a:ext cx="0" cy="128017"/>
+          </a:xfrm>
+          <a:prstGeom prst="line">
+            <a:avLst/>
+          </a:prstGeom>
+          <a:ln w="12700">
+            <a:solidFill>
+              <a:srgbClr val="67E8F9"/>
+            </a:solidFill>
+          </a:ln>
+        </p:spPr>
+        <p:style>
+          <a:lnRef idx="2">
+            <a:schemeClr val="accent1"/>
+          </a:lnRef>
+          <a:fillRef idx="0">
+            <a:schemeClr val="accent1"/>
+          </a:fillRef>
+          <a:effectRef idx="1">
+            <a:schemeClr val="accent1"/>
+          </a:effectRef>
+          <a:fontRef idx="minor">
+            <a:schemeClr val="tx1"/>
+          </a:fontRef>
+        </p:style>
+      </p:cxnSp>
+      <p:cxnSp>
+        <p:nvCxnSpPr>
+          <p:cNvPr id="37" name="Connector 36"/>
+          <p:cNvCxnSpPr/>
+          <p:nvPr/>
+        </p:nvCxnSpPr>
+        <p:spPr>
+          <a:xfrm flipH="1">
+            <a:off x="3849624" y="2578608"/>
+            <a:ext cx="1293876" cy="0"/>
+          </a:xfrm>
+          <a:prstGeom prst="line">
+            <a:avLst/>
+          </a:prstGeom>
+          <a:ln w="12700">
+            <a:solidFill>
+              <a:srgbClr val="67E8F9"/>
+            </a:solidFill>
+          </a:ln>
+        </p:spPr>
+        <p:style>
+          <a:lnRef idx="2">
+            <a:schemeClr val="accent1"/>
+          </a:lnRef>
+          <a:fillRef idx="0">
+            <a:schemeClr val="accent1"/>
+          </a:fillRef>
+          <a:effectRef idx="1">
+            <a:schemeClr val="accent1"/>
+          </a:effectRef>
+          <a:fontRef idx="minor">
+            <a:schemeClr val="tx1"/>
+          </a:fontRef>
+        </p:style>
+      </p:cxnSp>
+      <p:cxnSp>
+        <p:nvCxnSpPr>
+          <p:cNvPr id="38" name="Connector 37"/>
+          <p:cNvCxnSpPr/>
+          <p:nvPr/>
+        </p:nvCxnSpPr>
+        <p:spPr>
+          <a:xfrm>
+            <a:off x="3849624" y="2578608"/>
+            <a:ext cx="0" cy="1097280"/>
+          </a:xfrm>
+          <a:prstGeom prst="line">
+            <a:avLst/>
+          </a:prstGeom>
+          <a:ln w="12700">
+            <a:solidFill>
+              <a:srgbClr val="67E8F9"/>
+            </a:solidFill>
+          </a:ln>
+        </p:spPr>
+        <p:style>
+          <a:lnRef idx="2">
+            <a:schemeClr val="accent1"/>
+          </a:lnRef>
+          <a:fillRef idx="0">
+            <a:schemeClr val="accent1"/>
+          </a:fillRef>
+          <a:effectRef idx="1">
+            <a:schemeClr val="accent1"/>
+          </a:effectRef>
+          <a:fontRef idx="minor">
+            <a:schemeClr val="tx1"/>
+          </a:fontRef>
+        </p:style>
+      </p:cxnSp>
+      <p:cxnSp>
+        <p:nvCxnSpPr>
+          <p:cNvPr id="39" name="Connector 38"/>
+          <p:cNvCxnSpPr/>
+          <p:nvPr/>
+        </p:nvCxnSpPr>
+        <p:spPr>
+          <a:xfrm>
+            <a:off x="3849624" y="3675888"/>
+            <a:ext cx="6377940" cy="0"/>
+          </a:xfrm>
+          <a:prstGeom prst="line">
+            <a:avLst/>
+          </a:prstGeom>
+          <a:ln w="12700">
+            <a:solidFill>
+              <a:srgbClr val="67E8F9"/>
+            </a:solidFill>
+          </a:ln>
+        </p:spPr>
+        <p:style>
+          <a:lnRef idx="2">
+            <a:schemeClr val="accent1"/>
+          </a:lnRef>
+          <a:fillRef idx="0">
+            <a:schemeClr val="accent1"/>
+          </a:fillRef>
+          <a:effectRef idx="1">
+            <a:schemeClr val="accent1"/>
+          </a:effectRef>
+          <a:fontRef idx="minor">
+            <a:schemeClr val="tx1"/>
+          </a:fontRef>
+        </p:style>
+      </p:cxnSp>
+      <p:cxnSp>
+        <p:nvCxnSpPr>
+          <p:cNvPr id="40" name="Connector 39"/>
+          <p:cNvCxnSpPr/>
+          <p:nvPr/>
+        </p:nvCxnSpPr>
+        <p:spPr>
+          <a:xfrm>
+            <a:off x="10227564" y="3675888"/>
+            <a:ext cx="0" cy="128016"/>
+          </a:xfrm>
+          <a:prstGeom prst="line">
+            <a:avLst/>
+          </a:prstGeom>
+          <a:ln w="12700">
+            <a:solidFill>
+              <a:srgbClr val="67E8F9"/>
+            </a:solidFill>
+            <a:tailEnd type="triangle"/>
+          </a:ln>
+        </p:spPr>
+        <p:style>
+          <a:lnRef idx="2">
+            <a:schemeClr val="accent1"/>
+          </a:lnRef>
+          <a:fillRef idx="0">
+            <a:schemeClr val="accent1"/>
+          </a:fillRef>
+          <a:effectRef idx="1">
+            <a:schemeClr val="accent1"/>
+          </a:effectRef>
+          <a:fontRef idx="minor">
+            <a:schemeClr val="tx1"/>
+          </a:fontRef>
+        </p:style>
+      </p:cxnSp>
+      <p:sp>
+        <p:nvSpPr>
+          <p:cNvPr id="41" name="Rectangle 40"/>
           <p:cNvSpPr/>
           <p:nvPr/>
         </p:nvSpPr>
@@ -12483,7 +12903,7 @@
       </p:sp>
       <p:sp>
         <p:nvSpPr>
-          <p:cNvPr id="32" name="Diagram label: tenant / user_account"/>
+          <p:cNvPr id="42" name="Diagram label: tenant / user_account"/>
           <p:cNvSpPr txBox="1"/>
           <p:nvPr/>
         </p:nvSpPr>
@@ -12525,7 +12945,7 @@
       </p:sp>
       <p:sp>
         <p:nvSpPr>
-          <p:cNvPr id="33" name="Rectangle 32"/>
+          <p:cNvPr id="43" name="Rectangle 42"/>
           <p:cNvSpPr/>
           <p:nvPr/>
         </p:nvSpPr>
@@ -12570,7 +12990,7 @@
       </p:sp>
       <p:sp>
         <p:nvSpPr>
-          <p:cNvPr id="34" name="Diagram label: tenant_city / city"/>
+          <p:cNvPr id="44" name="Diagram label: tenant_city / city"/>
           <p:cNvSpPr txBox="1"/>
           <p:nvPr/>
         </p:nvSpPr>
@@ -12612,7 +13032,7 @@
       </p:sp>
       <p:sp>
         <p:nvSpPr>
-          <p:cNvPr id="35" name="Rectangle 34"/>
+          <p:cNvPr id="45" name="Rectangle 44"/>
           <p:cNvSpPr/>
           <p:nvPr/>
         </p:nvSpPr>
@@ -12657,7 +13077,7 @@
       </p:sp>
       <p:sp>
         <p:nvSpPr>
-          <p:cNvPr id="36" name="Diagram label: zone / geographic_area"/>
+          <p:cNvPr id="46" name="Diagram label: zone / geographic_area"/>
           <p:cNvSpPr txBox="1"/>
           <p:nvPr/>
         </p:nvSpPr>
@@ -12718,7 +13138,7 @@
       </p:sp>
       <p:sp>
         <p:nvSpPr>
-          <p:cNvPr id="37" name="Rectangle 36"/>
+          <p:cNvPr id="47" name="Rectangle 46"/>
           <p:cNvSpPr/>
           <p:nvPr/>
         </p:nvSpPr>
@@ -12763,7 +13183,7 @@
       </p:sp>
       <p:sp>
         <p:nvSpPr>
-          <p:cNvPr id="38" name="Diagram label: business"/>
+          <p:cNvPr id="48" name="Diagram label: business"/>
           <p:cNvSpPr txBox="1"/>
           <p:nvPr/>
         </p:nvSpPr>
@@ -12805,7 +13225,7 @@
       </p:sp>
       <p:sp>
         <p:nvSpPr>
-          <p:cNvPr id="39" name="Rectangle 38"/>
+          <p:cNvPr id="49" name="Rectangle 48"/>
           <p:cNvSpPr/>
           <p:nvPr/>
         </p:nvSpPr>
@@ -12850,7 +13270,7 @@
       </p:sp>
       <p:sp>
         <p:nvSpPr>
-          <p:cNvPr id="40" name="Diagram label: source_metadata"/>
+          <p:cNvPr id="50" name="Diagram label: source_metadata"/>
           <p:cNvSpPr txBox="1"/>
           <p:nvPr/>
         </p:nvSpPr>
@@ -12892,7 +13312,7 @@
       </p:sp>
       <p:sp>
         <p:nvSpPr>
-          <p:cNvPr id="41" name="Rectangle 40"/>
+          <p:cNvPr id="51" name="Rectangle 50"/>
           <p:cNvSpPr/>
           <p:nvPr/>
         </p:nvSpPr>
@@ -12937,7 +13357,7 @@
       </p:sp>
       <p:sp>
         <p:nvSpPr>
-          <p:cNvPr id="42" name="Diagram label: observation / inventory"/>
+          <p:cNvPr id="52" name="Diagram label: observation / inventory"/>
           <p:cNvSpPr txBox="1"/>
           <p:nvPr/>
         </p:nvSpPr>
@@ -12998,7 +13418,7 @@
       </p:sp>
       <p:sp>
         <p:nvSpPr>
-          <p:cNvPr id="43" name="Rectangle 42"/>
+          <p:cNvPr id="53" name="Rectangle 52"/>
           <p:cNvSpPr/>
           <p:nvPr/>
         </p:nvSpPr>
@@ -13043,7 +13463,7 @@
       </p:sp>
       <p:sp>
         <p:nvSpPr>
-          <p:cNvPr id="44" name="Diagram label: operation_receipt"/>
+          <p:cNvPr id="54" name="Diagram label: operation_receipt"/>
           <p:cNvSpPr txBox="1"/>
           <p:nvPr/>
         </p:nvSpPr>
@@ -13085,7 +13505,7 @@
       </p:sp>
       <p:sp>
         <p:nvSpPr>
-          <p:cNvPr id="45" name="Rectangle 44"/>
+          <p:cNvPr id="55" name="Rectangle 54"/>
           <p:cNvSpPr/>
           <p:nvPr/>
         </p:nvSpPr>
@@ -13130,7 +13550,7 @@
       </p:sp>
       <p:sp>
         <p:nvSpPr>
-          <p:cNvPr id="46" name="Diagram label: forecast_result"/>
+          <p:cNvPr id="56" name="Diagram label: forecast_result"/>
           <p:cNvSpPr txBox="1"/>
           <p:nvPr/>
         </p:nvSpPr>
@@ -13172,7 +13592,7 @@
       </p:sp>
       <p:sp>
         <p:nvSpPr>
-          <p:cNvPr id="47" name="Rectangle 46"/>
+          <p:cNvPr id="57" name="Rectangle 56"/>
           <p:cNvSpPr/>
           <p:nvPr/>
         </p:nvSpPr>
@@ -13217,7 +13637,7 @@
       </p:sp>
       <p:sp>
         <p:nvSpPr>
-          <p:cNvPr id="48" name="Diagram label: audit_event"/>
+          <p:cNvPr id="58" name="Diagram label: audit_event"/>
           <p:cNvSpPr txBox="1"/>
           <p:nvPr/>
         </p:nvSpPr>
@@ -13259,7 +13679,7 @@
       </p:sp>
       <p:sp>
         <p:nvSpPr>
-          <p:cNvPr id="49" name="Rectangle 48"/>
+          <p:cNvPr id="59" name="Rectangle 58"/>
           <p:cNvSpPr/>
           <p:nvPr/>
         </p:nvSpPr>
@@ -13304,7 +13724,7 @@
       </p:sp>
       <p:sp>
         <p:nvSpPr>
-          <p:cNvPr id="50" name="Diagram label: pulseai_session/message"/>
+          <p:cNvPr id="60" name="Diagram label: pulseai_session/message"/>
           <p:cNvSpPr txBox="1"/>
           <p:nvPr/>
         </p:nvSpPr>
@@ -13365,7 +13785,7 @@
       </p:sp>
       <p:sp>
         <p:nvSpPr>
-          <p:cNvPr id="51" name="Rectangle 50"/>
+          <p:cNvPr id="61" name="Rectangle 60"/>
           <p:cNvSpPr/>
           <p:nvPr/>
         </p:nvSpPr>
@@ -13410,7 +13830,7 @@
       </p:sp>
       <p:sp>
         <p:nvSpPr>
-          <p:cNvPr id="52" name="Diagram label: decision_snapshot/scenario"/>
+          <p:cNvPr id="62" name="Diagram label: decision_snapshot/scenario"/>
           <p:cNvSpPr txBox="1"/>
           <p:nvPr/>
         </p:nvSpPr>
@@ -13471,7 +13891,7 @@
       </p:sp>
       <p:sp>
         <p:nvSpPr>
-          <p:cNvPr id="53" name="Rectangle 52"/>
+          <p:cNvPr id="63" name="Rectangle 62"/>
           <p:cNvSpPr/>
           <p:nvPr/>
         </p:nvSpPr>
@@ -13516,7 +13936,7 @@
       </p:sp>
       <p:sp>
         <p:nvSpPr>
-          <p:cNvPr id="54" name="Diagram label: verification_request"/>
+          <p:cNvPr id="64" name="Diagram label: verification_request"/>
           <p:cNvSpPr txBox="1"/>
           <p:nvPr/>
         </p:nvSpPr>
@@ -14363,7 +14783,7 @@
         <p:spPr>
           <a:xfrm>
             <a:off x="7685531" y="2450591"/>
-            <a:ext cx="0" cy="676657"/>
+            <a:ext cx="0" cy="128017"/>
           </a:xfrm>
           <a:prstGeom prst="line">
             <a:avLst/>
@@ -14396,9 +14816,9 @@
           <p:nvPr/>
         </p:nvCxnSpPr>
         <p:spPr>
-          <a:xfrm>
-            <a:off x="7685531" y="3127248"/>
-            <a:ext cx="0" cy="0"/>
+          <a:xfrm flipH="1">
+            <a:off x="3849624" y="2578608"/>
+            <a:ext cx="3835907" cy="0"/>
           </a:xfrm>
           <a:prstGeom prst="line">
             <a:avLst/>
@@ -14432,8 +14852,8 @@
         </p:nvCxnSpPr>
         <p:spPr>
           <a:xfrm>
-            <a:off x="7685531" y="3127248"/>
-            <a:ext cx="0" cy="676656"/>
+            <a:off x="3849624" y="2578608"/>
+            <a:ext cx="0" cy="1097280"/>
           </a:xfrm>
           <a:prstGeom prst="line">
             <a:avLst/>
@@ -14442,7 +14862,6 @@
             <a:solidFill>
               <a:srgbClr val="67E8F9"/>
             </a:solidFill>
-            <a:tailEnd type="triangle"/>
           </a:ln>
         </p:spPr>
         <p:style>
@@ -14468,8 +14887,43 @@
         </p:nvCxnSpPr>
         <p:spPr>
           <a:xfrm>
-            <a:off x="6309359" y="4160520"/>
-            <a:ext cx="2752345" cy="0"/>
+            <a:off x="3849624" y="3675888"/>
+            <a:ext cx="3835907" cy="0"/>
+          </a:xfrm>
+          <a:prstGeom prst="line">
+            <a:avLst/>
+          </a:prstGeom>
+          <a:ln w="12700">
+            <a:solidFill>
+              <a:srgbClr val="67E8F9"/>
+            </a:solidFill>
+          </a:ln>
+        </p:spPr>
+        <p:style>
+          <a:lnRef idx="2">
+            <a:schemeClr val="accent1"/>
+          </a:lnRef>
+          <a:fillRef idx="0">
+            <a:schemeClr val="accent1"/>
+          </a:fillRef>
+          <a:effectRef idx="1">
+            <a:schemeClr val="accent1"/>
+          </a:effectRef>
+          <a:fontRef idx="minor">
+            <a:schemeClr val="tx1"/>
+          </a:fontRef>
+        </p:style>
+      </p:cxnSp>
+      <p:cxnSp>
+        <p:nvCxnSpPr>
+          <p:cNvPr id="26" name="Connector 25"/>
+          <p:cNvCxnSpPr/>
+          <p:nvPr/>
+        </p:nvCxnSpPr>
+        <p:spPr>
+          <a:xfrm>
+            <a:off x="7685531" y="3675888"/>
+            <a:ext cx="0" cy="128016"/>
           </a:xfrm>
           <a:prstGeom prst="line">
             <a:avLst/>
@@ -14496,9 +14950,115 @@
           </a:fontRef>
         </p:style>
       </p:cxnSp>
-      <p:sp>
-        <p:nvSpPr>
-          <p:cNvPr id="26" name="Rectangle 25"/>
+      <p:cxnSp>
+        <p:nvCxnSpPr>
+          <p:cNvPr id="27" name="Connector 26"/>
+          <p:cNvCxnSpPr/>
+          <p:nvPr/>
+        </p:nvCxnSpPr>
+        <p:spPr>
+          <a:xfrm flipV="1">
+            <a:off x="5143500" y="3675888"/>
+            <a:ext cx="0" cy="128016"/>
+          </a:xfrm>
+          <a:prstGeom prst="line">
+            <a:avLst/>
+          </a:prstGeom>
+          <a:ln w="12700">
+            <a:solidFill>
+              <a:srgbClr val="67E8F9"/>
+            </a:solidFill>
+          </a:ln>
+        </p:spPr>
+        <p:style>
+          <a:lnRef idx="2">
+            <a:schemeClr val="accent1"/>
+          </a:lnRef>
+          <a:fillRef idx="0">
+            <a:schemeClr val="accent1"/>
+          </a:fillRef>
+          <a:effectRef idx="1">
+            <a:schemeClr val="accent1"/>
+          </a:effectRef>
+          <a:fontRef idx="minor">
+            <a:schemeClr val="tx1"/>
+          </a:fontRef>
+        </p:style>
+      </p:cxnSp>
+      <p:cxnSp>
+        <p:nvCxnSpPr>
+          <p:cNvPr id="28" name="Connector 27"/>
+          <p:cNvCxnSpPr/>
+          <p:nvPr/>
+        </p:nvCxnSpPr>
+        <p:spPr>
+          <a:xfrm>
+            <a:off x="5143500" y="3675888"/>
+            <a:ext cx="5084064" cy="0"/>
+          </a:xfrm>
+          <a:prstGeom prst="line">
+            <a:avLst/>
+          </a:prstGeom>
+          <a:ln w="12700">
+            <a:solidFill>
+              <a:srgbClr val="67E8F9"/>
+            </a:solidFill>
+          </a:ln>
+        </p:spPr>
+        <p:style>
+          <a:lnRef idx="2">
+            <a:schemeClr val="accent1"/>
+          </a:lnRef>
+          <a:fillRef idx="0">
+            <a:schemeClr val="accent1"/>
+          </a:fillRef>
+          <a:effectRef idx="1">
+            <a:schemeClr val="accent1"/>
+          </a:effectRef>
+          <a:fontRef idx="minor">
+            <a:schemeClr val="tx1"/>
+          </a:fontRef>
+        </p:style>
+      </p:cxnSp>
+      <p:cxnSp>
+        <p:nvCxnSpPr>
+          <p:cNvPr id="29" name="Connector 28"/>
+          <p:cNvCxnSpPr/>
+          <p:nvPr/>
+        </p:nvCxnSpPr>
+        <p:spPr>
+          <a:xfrm>
+            <a:off x="10227564" y="3675888"/>
+            <a:ext cx="0" cy="128016"/>
+          </a:xfrm>
+          <a:prstGeom prst="line">
+            <a:avLst/>
+          </a:prstGeom>
+          <a:ln w="12700">
+            <a:solidFill>
+              <a:srgbClr val="67E8F9"/>
+            </a:solidFill>
+            <a:tailEnd type="triangle"/>
+          </a:ln>
+        </p:spPr>
+        <p:style>
+          <a:lnRef idx="2">
+            <a:schemeClr val="accent1"/>
+          </a:lnRef>
+          <a:fillRef idx="0">
+            <a:schemeClr val="accent1"/>
+          </a:fillRef>
+          <a:effectRef idx="1">
+            <a:schemeClr val="accent1"/>
+          </a:effectRef>
+          <a:fontRef idx="minor">
+            <a:schemeClr val="tx1"/>
+          </a:fontRef>
+        </p:style>
+      </p:cxnSp>
+      <p:sp>
+        <p:nvSpPr>
+          <p:cNvPr id="30" name="Rectangle 29"/>
           <p:cNvSpPr/>
           <p:nvPr/>
         </p:nvSpPr>
@@ -14543,7 +15103,7 @@
       </p:sp>
       <p:sp>
         <p:nvSpPr>
-          <p:cNvPr id="27" name="Diagram label: CSV / JSON / GeoJSON"/>
+          <p:cNvPr id="31" name="Diagram label: CSV / JSON / GeoJSON"/>
           <p:cNvSpPr txBox="1"/>
           <p:nvPr/>
         </p:nvSpPr>
@@ -14604,7 +15164,7 @@
       </p:sp>
       <p:sp>
         <p:nvSpPr>
-          <p:cNvPr id="28" name="Rectangle 27"/>
+          <p:cNvPr id="32" name="Rectangle 31"/>
           <p:cNvSpPr/>
           <p:nvPr/>
         </p:nvSpPr>
@@ -14649,7 +15209,7 @@
       </p:sp>
       <p:sp>
         <p:nvSpPr>
-          <p:cNvPr id="29" name="Diagram label: Parse and validate"/>
+          <p:cNvPr id="33" name="Diagram label: Parse and validate"/>
           <p:cNvSpPr txBox="1"/>
           <p:nvPr/>
         </p:nvSpPr>
@@ -14691,7 +15251,7 @@
       </p:sp>
       <p:sp>
         <p:nvSpPr>
-          <p:cNvPr id="30" name="Rectangle 29"/>
+          <p:cNvPr id="34" name="Rectangle 33"/>
           <p:cNvSpPr/>
           <p:nvPr/>
         </p:nvSpPr>
@@ -14736,7 +15296,7 @@
       </p:sp>
       <p:sp>
         <p:nvSpPr>
-          <p:cNvPr id="31" name="Diagram label: Clean and normalize"/>
+          <p:cNvPr id="35" name="Diagram label: Clean and normalize"/>
           <p:cNvSpPr txBox="1"/>
           <p:nvPr/>
         </p:nvSpPr>
@@ -14778,7 +15338,7 @@
       </p:sp>
       <p:sp>
         <p:nvSpPr>
-          <p:cNvPr id="32" name="Rectangle 31"/>
+          <p:cNvPr id="36" name="Rectangle 35"/>
           <p:cNvSpPr/>
           <p:nvPr/>
         </p:nvSpPr>
@@ -14823,7 +15383,7 @@
       </p:sp>
       <p:sp>
         <p:nvSpPr>
-          <p:cNvPr id="33" name="Diagram label: Deduplicate / quality"/>
+          <p:cNvPr id="37" name="Diagram label: Deduplicate / quality"/>
           <p:cNvSpPr txBox="1"/>
           <p:nvPr/>
         </p:nvSpPr>
@@ -14865,7 +15425,7 @@
       </p:sp>
       <p:sp>
         <p:nvSpPr>
-          <p:cNvPr id="34" name="Rectangle 33"/>
+          <p:cNvPr id="38" name="Rectangle 37"/>
           <p:cNvSpPr/>
           <p:nvPr/>
         </p:nvSpPr>
@@ -14910,7 +15470,7 @@
       </p:sp>
       <p:sp>
         <p:nvSpPr>
-          <p:cNvPr id="35" name="Diagram label: Durable local output"/>
+          <p:cNvPr id="39" name="Diagram label: Durable local output"/>
           <p:cNvSpPr txBox="1"/>
           <p:nvPr/>
         </p:nvSpPr>
@@ -14952,7 +15512,7 @@
       </p:sp>
       <p:sp>
         <p:nvSpPr>
-          <p:cNvPr id="36" name="Rectangle 35"/>
+          <p:cNvPr id="40" name="Rectangle 39"/>
           <p:cNvSpPr/>
           <p:nvPr/>
         </p:nvSpPr>
@@ -14997,7 +15557,7 @@
       </p:sp>
       <p:sp>
         <p:nvSpPr>
-          <p:cNvPr id="37" name="Diagram label: API publication"/>
+          <p:cNvPr id="41" name="Diagram label: API publication"/>
           <p:cNvSpPr txBox="1"/>
           <p:nvPr/>
         </p:nvSpPr>
@@ -15039,7 +15599,7 @@
       </p:sp>
       <p:sp>
         <p:nvSpPr>
-          <p:cNvPr id="38" name="Rectangle 37"/>
+          <p:cNvPr id="42" name="Rectangle 41"/>
           <p:cNvSpPr/>
           <p:nvPr/>
         </p:nvSpPr>
@@ -15084,7 +15644,7 @@
       </p:sp>
       <p:sp>
         <p:nvSpPr>
-          <p:cNvPr id="39" name="Diagram label: PostGIS"/>
+          <p:cNvPr id="43" name="Diagram label: PostGIS"/>
           <p:cNvSpPr txBox="1"/>
           <p:nvPr/>
         </p:nvSpPr>
@@ -15126,7 +15686,7 @@
       </p:sp>
       <p:sp>
         <p:nvSpPr>
-          <p:cNvPr id="40" name="Rectangle 39"/>
+          <p:cNvPr id="44" name="Rectangle 43"/>
           <p:cNvSpPr/>
           <p:nvPr/>
         </p:nvSpPr>
@@ -15171,7 +15731,7 @@
       </p:sp>
       <p:sp>
         <p:nvSpPr>
-          <p:cNvPr id="41" name="Diagram label: Reject / dead letter"/>
+          <p:cNvPr id="45" name="Diagram label: Reject / dead letter"/>
           <p:cNvSpPr txBox="1"/>
           <p:nvPr/>
         </p:nvSpPr>
@@ -15213,7 +15773,7 @@
       </p:sp>
       <p:sp>
         <p:nvSpPr>
-          <p:cNvPr id="42" name="Rectangle 41"/>
+          <p:cNvPr id="46" name="Rectangle 45"/>
           <p:cNvSpPr/>
           <p:nvPr/>
         </p:nvSpPr>
@@ -15258,7 +15818,7 @@
       </p:sp>
       <p:sp>
         <p:nvSpPr>
-          <p:cNvPr id="43" name="Diagram label: Analytical queries"/>
+          <p:cNvPr id="47" name="Diagram label: Analytical queries"/>
           <p:cNvSpPr txBox="1"/>
           <p:nvPr/>
         </p:nvSpPr>
@@ -17611,7 +18171,7 @@
               </a:defRPr>
             </a:pPr>
             <a:r>
-              <a:t>Actual local synthetic response; residual intervals are diagnostic</a:t>
+              <a:t>Synthetic daily demand units, Jul–Aug 2025; residual intervals are diagnostic</a:t>
             </a:r>
           </a:p>
         </p:txBody>
@@ -19365,9 +19925,79 @@
           <p:nvPr/>
         </p:nvCxnSpPr>
         <p:spPr>
-          <a:xfrm>
-            <a:off x="6309359" y="4160520"/>
-            <a:ext cx="2752345" cy="0"/>
+          <a:xfrm flipV="1">
+            <a:off x="5143500" y="3675888"/>
+            <a:ext cx="0" cy="128016"/>
+          </a:xfrm>
+          <a:prstGeom prst="line">
+            <a:avLst/>
+          </a:prstGeom>
+          <a:ln w="12700">
+            <a:solidFill>
+              <a:srgbClr val="67E8F9"/>
+            </a:solidFill>
+          </a:ln>
+        </p:spPr>
+        <p:style>
+          <a:lnRef idx="2">
+            <a:schemeClr val="accent1"/>
+          </a:lnRef>
+          <a:fillRef idx="0">
+            <a:schemeClr val="accent1"/>
+          </a:fillRef>
+          <a:effectRef idx="1">
+            <a:schemeClr val="accent1"/>
+          </a:effectRef>
+          <a:fontRef idx="minor">
+            <a:schemeClr val="tx1"/>
+          </a:fontRef>
+        </p:style>
+      </p:cxnSp>
+      <p:cxnSp>
+        <p:nvCxnSpPr>
+          <p:cNvPr id="24" name="Connector 23"/>
+          <p:cNvCxnSpPr/>
+          <p:nvPr/>
+        </p:nvCxnSpPr>
+        <p:spPr>
+          <a:xfrm>
+            <a:off x="5143500" y="3675888"/>
+            <a:ext cx="5084064" cy="0"/>
+          </a:xfrm>
+          <a:prstGeom prst="line">
+            <a:avLst/>
+          </a:prstGeom>
+          <a:ln w="12700">
+            <a:solidFill>
+              <a:srgbClr val="67E8F9"/>
+            </a:solidFill>
+          </a:ln>
+        </p:spPr>
+        <p:style>
+          <a:lnRef idx="2">
+            <a:schemeClr val="accent1"/>
+          </a:lnRef>
+          <a:fillRef idx="0">
+            <a:schemeClr val="accent1"/>
+          </a:fillRef>
+          <a:effectRef idx="1">
+            <a:schemeClr val="accent1"/>
+          </a:effectRef>
+          <a:fontRef idx="minor">
+            <a:schemeClr val="tx1"/>
+          </a:fontRef>
+        </p:style>
+      </p:cxnSp>
+      <p:cxnSp>
+        <p:nvCxnSpPr>
+          <p:cNvPr id="25" name="Connector 24"/>
+          <p:cNvCxnSpPr/>
+          <p:nvPr/>
+        </p:nvCxnSpPr>
+        <p:spPr>
+          <a:xfrm>
+            <a:off x="10227564" y="3675888"/>
+            <a:ext cx="0" cy="128016"/>
           </a:xfrm>
           <a:prstGeom prst="line">
             <a:avLst/>
@@ -19396,7 +20026,7 @@
       </p:cxnSp>
       <p:sp>
         <p:nvSpPr>
-          <p:cNvPr id="24" name="Rectangle 23"/>
+          <p:cNvPr id="26" name="Rectangle 25"/>
           <p:cNvSpPr/>
           <p:nvPr/>
         </p:nvSpPr>
@@ -19441,7 +20071,7 @@
       </p:sp>
       <p:sp>
         <p:nvSpPr>
-          <p:cNvPr id="25" name="Diagram label: Bounded question + filters"/>
+          <p:cNvPr id="27" name="Diagram label: Bounded question + filters"/>
           <p:cNvSpPr txBox="1"/>
           <p:nvPr/>
         </p:nvSpPr>
@@ -19502,7 +20132,7 @@
       </p:sp>
       <p:sp>
         <p:nvSpPr>
-          <p:cNvPr id="26" name="Rectangle 25"/>
+          <p:cNvPr id="28" name="Rectangle 27"/>
           <p:cNvSpPr/>
           <p:nvPr/>
         </p:nvSpPr>
@@ -19547,7 +20177,7 @@
       </p:sp>
       <p:sp>
         <p:nvSpPr>
-          <p:cNvPr id="27" name="Diagram label: Spring policy"/>
+          <p:cNvPr id="29" name="Diagram label: Spring policy"/>
           <p:cNvSpPr txBox="1"/>
           <p:nvPr/>
         </p:nvSpPr>
@@ -19589,7 +20219,7 @@
       </p:sp>
       <p:sp>
         <p:nvSpPr>
-          <p:cNvPr id="28" name="Rectangle 27"/>
+          <p:cNvPr id="30" name="Rectangle 29"/>
           <p:cNvSpPr/>
           <p:nvPr/>
         </p:nvSpPr>
@@ -19634,7 +20264,7 @@
       </p:sp>
       <p:sp>
         <p:nvSpPr>
-          <p:cNvPr id="29" name="Diagram label: Fixed read-only tools"/>
+          <p:cNvPr id="31" name="Diagram label: Fixed read-only tools"/>
           <p:cNvSpPr txBox="1"/>
           <p:nvPr/>
         </p:nvSpPr>
@@ -19676,7 +20306,7 @@
       </p:sp>
       <p:sp>
         <p:nvSpPr>
-          <p:cNvPr id="30" name="Rectangle 29"/>
+          <p:cNvPr id="32" name="Rectangle 31"/>
           <p:cNvSpPr/>
           <p:nvPr/>
         </p:nvSpPr>
@@ -19721,7 +20351,7 @@
       </p:sp>
       <p:sp>
         <p:nvSpPr>
-          <p:cNvPr id="31" name="Diagram label: Verified statements"/>
+          <p:cNvPr id="33" name="Diagram label: Verified statements"/>
           <p:cNvSpPr txBox="1"/>
           <p:nvPr/>
         </p:nvSpPr>
@@ -19763,7 +20393,7 @@
       </p:sp>
       <p:sp>
         <p:nvSpPr>
-          <p:cNvPr id="32" name="Rectangle 31"/>
+          <p:cNvPr id="34" name="Rectangle 33"/>
           <p:cNvSpPr/>
           <p:nvPr/>
         </p:nvSpPr>
@@ -19808,7 +20438,7 @@
       </p:sp>
       <p:sp>
         <p:nvSpPr>
-          <p:cNvPr id="33" name="Diagram label: Optional provider"/>
+          <p:cNvPr id="35" name="Diagram label: Optional provider"/>
           <p:cNvSpPr txBox="1"/>
           <p:nvPr/>
         </p:nvSpPr>
@@ -19850,7 +20480,7 @@
       </p:sp>
       <p:sp>
         <p:nvSpPr>
-          <p:cNvPr id="34" name="Rectangle 33"/>
+          <p:cNvPr id="36" name="Rectangle 35"/>
           <p:cNvSpPr/>
           <p:nvPr/>
         </p:nvSpPr>
@@ -19895,7 +20525,7 @@
       </p:sp>
       <p:sp>
         <p:nvSpPr>
-          <p:cNvPr id="35" name="Diagram label: Validate ID selection"/>
+          <p:cNvPr id="37" name="Diagram label: Validate ID selection"/>
           <p:cNvSpPr txBox="1"/>
           <p:nvPr/>
         </p:nvSpPr>
@@ -19937,7 +20567,7 @@
       </p:sp>
       <p:sp>
         <p:nvSpPr>
-          <p:cNvPr id="36" name="Rectangle 35"/>
+          <p:cNvPr id="38" name="Rectangle 37"/>
           <p:cNvSpPr/>
           <p:nvPr/>
         </p:nvSpPr>
@@ -19982,7 +20612,7 @@
       </p:sp>
       <p:sp>
         <p:nvSpPr>
-          <p:cNvPr id="37" name="Diagram label: Construct answer"/>
+          <p:cNvPr id="39" name="Diagram label: Construct answer"/>
           <p:cNvSpPr txBox="1"/>
           <p:nvPr/>
         </p:nvSpPr>
@@ -20024,7 +20654,7 @@
       </p:sp>
       <p:sp>
         <p:nvSpPr>
-          <p:cNvPr id="38" name="Rectangle 37"/>
+          <p:cNvPr id="40" name="Rectangle 39"/>
           <p:cNvSpPr/>
           <p:nvPr/>
         </p:nvSpPr>
@@ -20069,7 +20699,7 @@
       </p:sp>
       <p:sp>
         <p:nvSpPr>
-          <p:cNvPr id="39" name="Diagram label: Evidence fallback"/>
+          <p:cNvPr id="41" name="Diagram label: Evidence fallback"/>
           <p:cNvSpPr txBox="1"/>
           <p:nvPr/>
         </p:nvSpPr>
@@ -20111,7 +20741,7 @@
       </p:sp>
       <p:sp>
         <p:nvSpPr>
-          <p:cNvPr id="40" name="Rectangle 39"/>
+          <p:cNvPr id="42" name="Rectangle 41"/>
           <p:cNvSpPr/>
           <p:nvPr/>
         </p:nvSpPr>
@@ -20156,7 +20786,7 @@
       </p:sp>
       <p:sp>
         <p:nvSpPr>
-          <p:cNvPr id="41" name="Diagram label: Owned conversation"/>
+          <p:cNvPr id="43" name="Diagram label: Owned conversation"/>
           <p:cNvSpPr txBox="1"/>
           <p:nvPr/>
         </p:nvSpPr>
@@ -23663,9 +24293,79 @@
           <p:nvPr/>
         </p:nvCxnSpPr>
         <p:spPr>
+          <a:xfrm flipV="1">
+            <a:off x="10227564" y="3675888"/>
+            <a:ext cx="0" cy="128016"/>
+          </a:xfrm>
+          <a:prstGeom prst="line">
+            <a:avLst/>
+          </a:prstGeom>
+          <a:ln w="12700">
+            <a:solidFill>
+              <a:srgbClr val="67E8F9"/>
+            </a:solidFill>
+          </a:ln>
+        </p:spPr>
+        <p:style>
+          <a:lnRef idx="2">
+            <a:schemeClr val="accent1"/>
+          </a:lnRef>
+          <a:fillRef idx="0">
+            <a:schemeClr val="accent1"/>
+          </a:fillRef>
+          <a:effectRef idx="1">
+            <a:schemeClr val="accent1"/>
+          </a:effectRef>
+          <a:fontRef idx="minor">
+            <a:schemeClr val="tx1"/>
+          </a:fontRef>
+        </p:style>
+      </p:cxnSp>
+      <p:cxnSp>
+        <p:nvCxnSpPr>
+          <p:cNvPr id="25" name="Connector 24"/>
+          <p:cNvCxnSpPr/>
+          <p:nvPr/>
+        </p:nvCxnSpPr>
+        <p:spPr>
           <a:xfrm flipH="1">
-            <a:off x="6309359" y="4160520"/>
-            <a:ext cx="2752345" cy="0"/>
+            <a:off x="5143500" y="3675888"/>
+            <a:ext cx="5084064" cy="0"/>
+          </a:xfrm>
+          <a:prstGeom prst="line">
+            <a:avLst/>
+          </a:prstGeom>
+          <a:ln w="12700">
+            <a:solidFill>
+              <a:srgbClr val="67E8F9"/>
+            </a:solidFill>
+          </a:ln>
+        </p:spPr>
+        <p:style>
+          <a:lnRef idx="2">
+            <a:schemeClr val="accent1"/>
+          </a:lnRef>
+          <a:fillRef idx="0">
+            <a:schemeClr val="accent1"/>
+          </a:fillRef>
+          <a:effectRef idx="1">
+            <a:schemeClr val="accent1"/>
+          </a:effectRef>
+          <a:fontRef idx="minor">
+            <a:schemeClr val="tx1"/>
+          </a:fontRef>
+        </p:style>
+      </p:cxnSp>
+      <p:cxnSp>
+        <p:nvCxnSpPr>
+          <p:cNvPr id="26" name="Connector 25"/>
+          <p:cNvCxnSpPr/>
+          <p:nvPr/>
+        </p:nvCxnSpPr>
+        <p:spPr>
+          <a:xfrm>
+            <a:off x="5143500" y="3675888"/>
+            <a:ext cx="0" cy="128016"/>
           </a:xfrm>
           <a:prstGeom prst="line">
             <a:avLst/>
@@ -23694,7 +24394,7 @@
       </p:cxnSp>
       <p:sp>
         <p:nvSpPr>
-          <p:cNvPr id="25" name="Rectangle 24"/>
+          <p:cNvPr id="27" name="Rectangle 26"/>
           <p:cNvSpPr/>
           <p:nvPr/>
         </p:nvSpPr>
@@ -23739,7 +24439,7 @@
       </p:sp>
       <p:sp>
         <p:nvSpPr>
-          <p:cNvPr id="26" name="Diagram label: Local / CI host"/>
+          <p:cNvPr id="28" name="Diagram label: Local / CI host"/>
           <p:cNvSpPr txBox="1"/>
           <p:nvPr/>
         </p:nvSpPr>
@@ -23781,7 +24481,7 @@
       </p:sp>
       <p:sp>
         <p:nvSpPr>
-          <p:cNvPr id="27" name="Rectangle 26"/>
+          <p:cNvPr id="29" name="Rectangle 28"/>
           <p:cNvSpPr/>
           <p:nvPr/>
         </p:nvSpPr>
@@ -23826,7 +24526,7 @@
       </p:sp>
       <p:sp>
         <p:nvSpPr>
-          <p:cNvPr id="28" name="Diagram label: Web / API / AI"/>
+          <p:cNvPr id="30" name="Diagram label: Web / API / AI"/>
           <p:cNvSpPr txBox="1"/>
           <p:nvPr/>
         </p:nvSpPr>
@@ -23868,7 +24568,7 @@
       </p:sp>
       <p:sp>
         <p:nvSpPr>
-          <p:cNvPr id="29" name="Rectangle 28"/>
+          <p:cNvPr id="31" name="Rectangle 30"/>
           <p:cNvSpPr/>
           <p:nvPr/>
         </p:nvSpPr>
@@ -23913,7 +24613,7 @@
       </p:sp>
       <p:sp>
         <p:nvSpPr>
-          <p:cNvPr id="30" name="Diagram label: PostGIS / Redis"/>
+          <p:cNvPr id="32" name="Diagram label: PostGIS / Redis"/>
           <p:cNvSpPr txBox="1"/>
           <p:nvPr/>
         </p:nvSpPr>
@@ -23955,7 +24655,7 @@
       </p:sp>
       <p:sp>
         <p:nvSpPr>
-          <p:cNvPr id="31" name="Rectangle 30"/>
+          <p:cNvPr id="33" name="Rectangle 32"/>
           <p:cNvSpPr/>
           <p:nvPr/>
         </p:nvSpPr>
@@ -24000,7 +24700,7 @@
       </p:sp>
       <p:sp>
         <p:nvSpPr>
-          <p:cNvPr id="32" name="Diagram label: Optional telemetry / chain"/>
+          <p:cNvPr id="34" name="Diagram label: Optional telemetry / chain"/>
           <p:cNvSpPr txBox="1"/>
           <p:nvPr/>
         </p:nvSpPr>
@@ -24061,7 +24761,7 @@
       </p:sp>
       <p:sp>
         <p:nvSpPr>
-          <p:cNvPr id="33" name="Rectangle 32"/>
+          <p:cNvPr id="35" name="Rectangle 34"/>
           <p:cNvSpPr/>
           <p:nvPr/>
         </p:nvSpPr>
@@ -24106,7 +24806,7 @@
       </p:sp>
       <p:sp>
         <p:nvSpPr>
-          <p:cNvPr id="34" name="Diagram label: AWS HTTPS ALB"/>
+          <p:cNvPr id="36" name="Diagram label: AWS HTTPS ALB"/>
           <p:cNvSpPr txBox="1"/>
           <p:nvPr/>
         </p:nvSpPr>
@@ -24148,7 +24848,7 @@
       </p:sp>
       <p:sp>
         <p:nvSpPr>
-          <p:cNvPr id="35" name="Rectangle 34"/>
+          <p:cNvPr id="37" name="Rectangle 36"/>
           <p:cNvSpPr/>
           <p:nvPr/>
         </p:nvSpPr>
@@ -24193,7 +24893,7 @@
       </p:sp>
       <p:sp>
         <p:nvSpPr>
-          <p:cNvPr id="36" name="Diagram label: Private ECS/Fargate"/>
+          <p:cNvPr id="38" name="Diagram label: Private ECS/Fargate"/>
           <p:cNvSpPr txBox="1"/>
           <p:nvPr/>
         </p:nvSpPr>
@@ -24235,7 +24935,7 @@
       </p:sp>
       <p:sp>
         <p:nvSpPr>
-          <p:cNvPr id="37" name="Rectangle 36"/>
+          <p:cNvPr id="39" name="Rectangle 38"/>
           <p:cNvSpPr/>
           <p:nvPr/>
         </p:nvSpPr>
@@ -24280,7 +24980,7 @@
       </p:sp>
       <p:sp>
         <p:nvSpPr>
-          <p:cNvPr id="38" name="Diagram label: Managed data"/>
+          <p:cNvPr id="40" name="Diagram label: Managed data"/>
           <p:cNvSpPr txBox="1"/>
           <p:nvPr/>
         </p:nvSpPr>
@@ -24322,7 +25022,7 @@
       </p:sp>
       <p:sp>
         <p:nvSpPr>
-          <p:cNvPr id="39" name="Rectangle 38"/>
+          <p:cNvPr id="41" name="Rectangle 40"/>
           <p:cNvSpPr/>
           <p:nvPr/>
         </p:nvSpPr>
@@ -24367,7 +25067,7 @@
       </p:sp>
       <p:sp>
         <p:nvSpPr>
-          <p:cNvPr id="40" name="Diagram label: EFS and private S3"/>
+          <p:cNvPr id="42" name="Diagram label: EFS and private S3"/>
           <p:cNvSpPr txBox="1"/>
           <p:nvPr/>
         </p:nvSpPr>
@@ -24409,7 +25109,7 @@
       </p:sp>
       <p:sp>
         <p:nvSpPr>
-          <p:cNvPr id="41" name="Rectangle 40"/>
+          <p:cNvPr id="43" name="Rectangle 42"/>
           <p:cNvSpPr/>
           <p:nvPr/>
         </p:nvSpPr>
@@ -24454,7 +25154,7 @@
       </p:sp>
       <p:sp>
         <p:nvSpPr>
-          <p:cNvPr id="42" name="Diagram label: Isolated migration task"/>
+          <p:cNvPr id="44" name="Diagram label: Isolated migration task"/>
           <p:cNvSpPr txBox="1"/>
           <p:nvPr/>
         </p:nvSpPr>

</xml_diff>

<commit_message>
docs: refresh release candidate artifacts
</commit_message>
<xml_diff>
--- a/docs/presentations/CityPulse-Project-Presentation.pptx
+++ b/docs/presentations/CityPulse-Project-Presentation.pptx
@@ -1334,12 +1334,12 @@
           <a:p/>
           <a:p>
             <a:r>
-              <a:t>Application snapshot: 2385ea7a3c6f9349c9c9ee67a56ace5f279fa992</a:t>
-            </a:r>
-          </a:p>
-          <a:p>
-            <a:r>
-              <a:t>Evidence date: 2026-10-29</a:t>
+              <a:t>Application snapshot: 723bb901411f84815f48acf1d5e6cef0a51f112d</a:t>
+            </a:r>
+          </a:p>
+          <a:p>
+            <a:r>
+              <a:t>Evidence date: 2026-10-30</a:t>
             </a:r>
           </a:p>
           <a:p>
@@ -1354,7 +1354,7 @@
           </a:p>
           <a:p>
             <a:r>
-              <a:t>https://github.com/manikantbindass/CityPulse/blob/2385ea7a3c6f9349c9c9ee67a56ace5f279fa992/README.md</a:t>
+              <a:t>https://github.com/manikantbindass/CityPulse/blob/723bb901411f84815f48acf1d5e6cef0a51f112d/README.md</a:t>
             </a:r>
           </a:p>
           <a:p>
@@ -1435,12 +1435,12 @@
           <a:p/>
           <a:p>
             <a:r>
-              <a:t>Application snapshot: 2385ea7a3c6f9349c9c9ee67a56ace5f279fa992</a:t>
-            </a:r>
-          </a:p>
-          <a:p>
-            <a:r>
-              <a:t>Evidence date: 2026-10-29</a:t>
+              <a:t>Application snapshot: 723bb901411f84815f48acf1d5e6cef0a51f112d</a:t>
+            </a:r>
+          </a:p>
+          <a:p>
+            <a:r>
+              <a:t>Evidence date: 2026-10-30</a:t>
             </a:r>
           </a:p>
           <a:p>
@@ -1455,7 +1455,7 @@
           </a:p>
           <a:p>
             <a:r>
-              <a:t>https://github.com/manikantbindass/CityPulse/blob/2385ea7a3c6f9349c9c9ee67a56ace5f279fa992/apps/web/package.json</a:t>
+              <a:t>https://github.com/manikantbindass/CityPulse/blob/723bb901411f84815f48acf1d5e6cef0a51f112d/apps/web/package.json</a:t>
             </a:r>
           </a:p>
           <a:p>
@@ -1465,7 +1465,7 @@
           </a:p>
           <a:p>
             <a:r>
-              <a:t>https://github.com/manikantbindass/CityPulse/blob/2385ea7a3c6f9349c9c9ee67a56ace5f279fa992/services/api/pom.xml</a:t>
+              <a:t>https://github.com/manikantbindass/CityPulse/blob/723bb901411f84815f48acf1d5e6cef0a51f112d/services/api/pom.xml</a:t>
             </a:r>
           </a:p>
           <a:p>
@@ -1475,7 +1475,7 @@
           </a:p>
           <a:p>
             <a:r>
-              <a:t>https://github.com/manikantbindass/CityPulse/blob/2385ea7a3c6f9349c9c9ee67a56ace5f279fa992/services/ai-engine/pyproject.toml</a:t>
+              <a:t>https://github.com/manikantbindass/CityPulse/blob/723bb901411f84815f48acf1d5e6cef0a51f112d/services/ai-engine/pyproject.toml</a:t>
             </a:r>
           </a:p>
         </p:txBody>
@@ -1551,12 +1551,12 @@
           <a:p/>
           <a:p>
             <a:r>
-              <a:t>Application snapshot: 2385ea7a3c6f9349c9c9ee67a56ace5f279fa992</a:t>
-            </a:r>
-          </a:p>
-          <a:p>
-            <a:r>
-              <a:t>Evidence date: 2026-10-29</a:t>
+              <a:t>Application snapshot: 723bb901411f84815f48acf1d5e6cef0a51f112d</a:t>
+            </a:r>
+          </a:p>
+          <a:p>
+            <a:r>
+              <a:t>Evidence date: 2026-10-30</a:t>
             </a:r>
           </a:p>
           <a:p>
@@ -1576,7 +1576,7 @@
           </a:p>
           <a:p>
             <a:r>
-              <a:t>https://github.com/manikantbindass/CityPulse/blob/2385ea7a3c6f9349c9c9ee67a56ace5f279fa992/compose.yaml</a:t>
+              <a:t>https://github.com/manikantbindass/CityPulse/blob/723bb901411f84815f48acf1d5e6cef0a51f112d/compose.yaml</a:t>
             </a:r>
           </a:p>
         </p:txBody>
@@ -1652,12 +1652,12 @@
           <a:p/>
           <a:p>
             <a:r>
-              <a:t>Application snapshot: 2385ea7a3c6f9349c9c9ee67a56ace5f279fa992</a:t>
-            </a:r>
-          </a:p>
-          <a:p>
-            <a:r>
-              <a:t>Evidence date: 2026-10-29</a:t>
+              <a:t>Application snapshot: 723bb901411f84815f48acf1d5e6cef0a51f112d</a:t>
+            </a:r>
+          </a:p>
+          <a:p>
+            <a:r>
+              <a:t>Evidence date: 2026-10-30</a:t>
             </a:r>
           </a:p>
           <a:p>
@@ -1672,7 +1672,7 @@
           </a:p>
           <a:p>
             <a:r>
-              <a:t>https://github.com/manikantbindass/CityPulse/blob/2385ea7a3c6f9349c9c9ee67a56ace5f279fa992/apps/web/components/providers.tsx</a:t>
+              <a:t>https://github.com/manikantbindass/CityPulse/blob/723bb901411f84815f48acf1d5e6cef0a51f112d/apps/web/components/providers.tsx</a:t>
             </a:r>
           </a:p>
           <a:p>
@@ -1682,7 +1682,7 @@
           </a:p>
           <a:p>
             <a:r>
-              <a:t>https://github.com/manikantbindass/CityPulse/blob/2385ea7a3c6f9349c9c9ee67a56ace5f279fa992/apps/web/e2e/theme.spec.ts</a:t>
+              <a:t>https://github.com/manikantbindass/CityPulse/blob/723bb901411f84815f48acf1d5e6cef0a51f112d/apps/web/e2e/theme.spec.ts</a:t>
             </a:r>
           </a:p>
         </p:txBody>
@@ -1758,12 +1758,12 @@
           <a:p/>
           <a:p>
             <a:r>
-              <a:t>Application snapshot: 2385ea7a3c6f9349c9c9ee67a56ace5f279fa992</a:t>
-            </a:r>
-          </a:p>
-          <a:p>
-            <a:r>
-              <a:t>Evidence date: 2026-10-29</a:t>
+              <a:t>Application snapshot: 723bb901411f84815f48acf1d5e6cef0a51f112d</a:t>
+            </a:r>
+          </a:p>
+          <a:p>
+            <a:r>
+              <a:t>Evidence date: 2026-10-30</a:t>
             </a:r>
           </a:p>
           <a:p>
@@ -1778,7 +1778,7 @@
           </a:p>
           <a:p>
             <a:r>
-              <a:t>https://github.com/manikantbindass/CityPulse/blob/2385ea7a3c6f9349c9c9ee67a56ace5f279fa992/services/api/src/main/java/io/citypulse/identity/MembershipFilter.java</a:t>
+              <a:t>https://github.com/manikantbindass/CityPulse/blob/723bb901411f84815f48acf1d5e6cef0a51f112d/services/api/src/main/java/io/citypulse/identity/MembershipFilter.java</a:t>
             </a:r>
           </a:p>
           <a:p>
@@ -1788,7 +1788,7 @@
           </a:p>
           <a:p>
             <a:r>
-              <a:t>https://github.com/manikantbindass/CityPulse/blob/2385ea7a3c6f9349c9c9ee67a56ace5f279fa992/docs/api/backend.md</a:t>
+              <a:t>https://github.com/manikantbindass/CityPulse/blob/723bb901411f84815f48acf1d5e6cef0a51f112d/docs/api/backend.md</a:t>
             </a:r>
           </a:p>
         </p:txBody>
@@ -1864,12 +1864,12 @@
           <a:p/>
           <a:p>
             <a:r>
-              <a:t>Application snapshot: 2385ea7a3c6f9349c9c9ee67a56ace5f279fa992</a:t>
-            </a:r>
-          </a:p>
-          <a:p>
-            <a:r>
-              <a:t>Evidence date: 2026-10-29</a:t>
+              <a:t>Application snapshot: 723bb901411f84815f48acf1d5e6cef0a51f112d</a:t>
+            </a:r>
+          </a:p>
+          <a:p>
+            <a:r>
+              <a:t>Evidence date: 2026-10-30</a:t>
             </a:r>
           </a:p>
           <a:p>
@@ -1884,7 +1884,7 @@
           </a:p>
           <a:p>
             <a:r>
-              <a:t>https://github.com/manikantbindass/CityPulse/blob/2385ea7a3c6f9349c9c9ee67a56ace5f279fa992/services/api/src/main/resources/db/migration/V1__canonical_geospatial_schema.sql</a:t>
+              <a:t>https://github.com/manikantbindass/CityPulse/blob/723bb901411f84815f48acf1d5e6cef0a51f112d/services/api/src/main/resources/db/migration/V1__canonical_geospatial_schema.sql</a:t>
             </a:r>
           </a:p>
           <a:p>
@@ -1894,7 +1894,7 @@
           </a:p>
           <a:p>
             <a:r>
-              <a:t>https://github.com/manikantbindass/CityPulse/blob/2385ea7a3c6f9349c9c9ee67a56ace5f279fa992/services/api/src/main/resources/db/migration/V2__tenant_operations.sql</a:t>
+              <a:t>https://github.com/manikantbindass/CityPulse/blob/723bb901411f84815f48acf1d5e6cef0a51f112d/services/api/src/main/resources/db/migration/V2__tenant_operations.sql</a:t>
             </a:r>
           </a:p>
         </p:txBody>
@@ -1970,12 +1970,12 @@
           <a:p/>
           <a:p>
             <a:r>
-              <a:t>Application snapshot: 2385ea7a3c6f9349c9c9ee67a56ace5f279fa992</a:t>
-            </a:r>
-          </a:p>
-          <a:p>
-            <a:r>
-              <a:t>Evidence date: 2026-10-29</a:t>
+              <a:t>Application snapshot: 723bb901411f84815f48acf1d5e6cef0a51f112d</a:t>
+            </a:r>
+          </a:p>
+          <a:p>
+            <a:r>
+              <a:t>Evidence date: 2026-10-30</a:t>
             </a:r>
           </a:p>
           <a:p>
@@ -1990,7 +1990,7 @@
           </a:p>
           <a:p>
             <a:r>
-              <a:t>https://github.com/manikantbindass/CityPulse/blob/2385ea7a3c6f9349c9c9ee67a56ace5f279fa992/services/ingestion/citypulse_ingestion/pipeline.py</a:t>
+              <a:t>https://github.com/manikantbindass/CityPulse/blob/723bb901411f84815f48acf1d5e6cef0a51f112d/services/ingestion/citypulse_ingestion/pipeline.py</a:t>
             </a:r>
           </a:p>
           <a:p>
@@ -2000,7 +2000,7 @@
           </a:p>
           <a:p>
             <a:r>
-              <a:t>https://github.com/manikantbindass/CityPulse/blob/2385ea7a3c6f9349c9c9ee67a56ace5f279fa992/scripts/data_pipeline.py</a:t>
+              <a:t>https://github.com/manikantbindass/CityPulse/blob/723bb901411f84815f48acf1d5e6cef0a51f112d/scripts/data_pipeline.py</a:t>
             </a:r>
           </a:p>
         </p:txBody>
@@ -2076,12 +2076,12 @@
           <a:p/>
           <a:p>
             <a:r>
-              <a:t>Application snapshot: 2385ea7a3c6f9349c9c9ee67a56ace5f279fa992</a:t>
-            </a:r>
-          </a:p>
-          <a:p>
-            <a:r>
-              <a:t>Evidence date: 2026-10-29</a:t>
+              <a:t>Application snapshot: 723bb901411f84815f48acf1d5e6cef0a51f112d</a:t>
+            </a:r>
+          </a:p>
+          <a:p>
+            <a:r>
+              <a:t>Evidence date: 2026-10-30</a:t>
             </a:r>
           </a:p>
           <a:p>
@@ -2096,7 +2096,7 @@
           </a:p>
           <a:p>
             <a:r>
-              <a:t>https://github.com/manikantbindass/CityPulse/blob/2385ea7a3c6f9349c9c9ee67a56ace5f279fa992/services/ai-engine/citypulse_ai/modeling.py</a:t>
+              <a:t>https://github.com/manikantbindass/CityPulse/blob/723bb901411f84815f48acf1d5e6cef0a51f112d/services/ai-engine/citypulse_ai/modeling.py</a:t>
             </a:r>
           </a:p>
           <a:p>
@@ -2106,7 +2106,7 @@
           </a:p>
           <a:p>
             <a:r>
-              <a:t>https://github.com/manikantbindass/CityPulse/blob/2385ea7a3c6f9349c9c9ee67a56ace5f279fa992/docs/reports/model-evaluation.json</a:t>
+              <a:t>https://github.com/manikantbindass/CityPulse/blob/723bb901411f84815f48acf1d5e6cef0a51f112d/docs/reports/model-evaluation.json</a:t>
             </a:r>
           </a:p>
         </p:txBody>
@@ -2182,12 +2182,12 @@
           <a:p/>
           <a:p>
             <a:r>
-              <a:t>Application snapshot: 2385ea7a3c6f9349c9c9ee67a56ace5f279fa992</a:t>
-            </a:r>
-          </a:p>
-          <a:p>
-            <a:r>
-              <a:t>Evidence date: 2026-10-29</a:t>
+              <a:t>Application snapshot: 723bb901411f84815f48acf1d5e6cef0a51f112d</a:t>
+            </a:r>
+          </a:p>
+          <a:p>
+            <a:r>
+              <a:t>Evidence date: 2026-10-30</a:t>
             </a:r>
           </a:p>
           <a:p>
@@ -2202,7 +2202,7 @@
           </a:p>
           <a:p>
             <a:r>
-              <a:t>https://github.com/manikantbindass/CityPulse/blob/2385ea7a3c6f9349c9c9ee67a56ace5f279fa992/docs/reports/model-evaluation.json</a:t>
+              <a:t>https://github.com/manikantbindass/CityPulse/blob/723bb901411f84815f48acf1d5e6cef0a51f112d/docs/reports/model-evaluation.json</a:t>
             </a:r>
           </a:p>
           <a:p>
@@ -2212,7 +2212,7 @@
           </a:p>
           <a:p>
             <a:r>
-              <a:t>https://github.com/manikantbindass/CityPulse/blob/2385ea7a3c6f9349c9c9ee67a56ace5f279fa992/docs/model-card.md</a:t>
+              <a:t>https://github.com/manikantbindass/CityPulse/blob/723bb901411f84815f48acf1d5e6cef0a51f112d/docs/model-card.md</a:t>
             </a:r>
           </a:p>
         </p:txBody>
@@ -2288,12 +2288,12 @@
           <a:p/>
           <a:p>
             <a:r>
-              <a:t>Application snapshot: 2385ea7a3c6f9349c9c9ee67a56ace5f279fa992</a:t>
-            </a:r>
-          </a:p>
-          <a:p>
-            <a:r>
-              <a:t>Evidence date: 2026-10-29</a:t>
+              <a:t>Application snapshot: 723bb901411f84815f48acf1d5e6cef0a51f112d</a:t>
+            </a:r>
+          </a:p>
+          <a:p>
+            <a:r>
+              <a:t>Evidence date: 2026-10-30</a:t>
             </a:r>
           </a:p>
           <a:p>
@@ -2313,7 +2313,7 @@
           </a:p>
           <a:p>
             <a:r>
-              <a:t>https://github.com/manikantbindass/CityPulse/blob/2385ea7a3c6f9349c9c9ee67a56ace5f279fa992/docs/model-card.md</a:t>
+              <a:t>https://github.com/manikantbindass/CityPulse/blob/723bb901411f84815f48acf1d5e6cef0a51f112d/docs/model-card.md</a:t>
             </a:r>
           </a:p>
         </p:txBody>
@@ -2389,12 +2389,12 @@
           <a:p/>
           <a:p>
             <a:r>
-              <a:t>Application snapshot: 2385ea7a3c6f9349c9c9ee67a56ace5f279fa992</a:t>
-            </a:r>
-          </a:p>
-          <a:p>
-            <a:r>
-              <a:t>Evidence date: 2026-10-29</a:t>
+              <a:t>Application snapshot: 723bb901411f84815f48acf1d5e6cef0a51f112d</a:t>
+            </a:r>
+          </a:p>
+          <a:p>
+            <a:r>
+              <a:t>Evidence date: 2026-10-30</a:t>
             </a:r>
           </a:p>
           <a:p>
@@ -2409,7 +2409,7 @@
           </a:p>
           <a:p>
             <a:r>
-              <a:t>https://github.com/manikantbindass/CityPulse/blob/2385ea7a3c6f9349c9c9ee67a56ace5f279fa992/docs/reports/decision-evaluation.json</a:t>
+              <a:t>https://github.com/manikantbindass/CityPulse/blob/723bb901411f84815f48acf1d5e6cef0a51f112d/docs/reports/decision-evaluation.json</a:t>
             </a:r>
           </a:p>
           <a:p>
@@ -2419,7 +2419,7 @@
           </a:p>
           <a:p>
             <a:r>
-              <a:t>https://github.com/manikantbindass/CityPulse/blob/2385ea7a3c6f9349c9c9ee67a56ace5f279fa992/services/ai-engine/citypulse_ai/decisions.py</a:t>
+              <a:t>https://github.com/manikantbindass/CityPulse/blob/723bb901411f84815f48acf1d5e6cef0a51f112d/services/ai-engine/citypulse_ai/decisions.py</a:t>
             </a:r>
           </a:p>
         </p:txBody>
@@ -2495,12 +2495,12 @@
           <a:p/>
           <a:p>
             <a:r>
-              <a:t>Application snapshot: 2385ea7a3c6f9349c9c9ee67a56ace5f279fa992</a:t>
-            </a:r>
-          </a:p>
-          <a:p>
-            <a:r>
-              <a:t>Evidence date: 2026-10-29</a:t>
+              <a:t>Application snapshot: 723bb901411f84815f48acf1d5e6cef0a51f112d</a:t>
+            </a:r>
+          </a:p>
+          <a:p>
+            <a:r>
+              <a:t>Evidence date: 2026-10-30</a:t>
             </a:r>
           </a:p>
           <a:p>
@@ -2515,7 +2515,7 @@
           </a:p>
           <a:p>
             <a:r>
-              <a:t>https://github.com/manikantbindass/CityPulse/blob/2385ea7a3c6f9349c9c9ee67a56ace5f279fa992/README.md</a:t>
+              <a:t>https://github.com/manikantbindass/CityPulse/blob/723bb901411f84815f48acf1d5e6cef0a51f112d/README.md</a:t>
             </a:r>
           </a:p>
           <a:p>
@@ -2525,7 +2525,7 @@
           </a:p>
           <a:p>
             <a:r>
-              <a:t>https://github.com/manikantbindass/CityPulse/blob/2385ea7a3c6f9349c9c9ee67a56ace5f279fa992/compose.yaml</a:t>
+              <a:t>https://github.com/manikantbindass/CityPulse/blob/723bb901411f84815f48acf1d5e6cef0a51f112d/compose.yaml</a:t>
             </a:r>
           </a:p>
         </p:txBody>
@@ -2601,12 +2601,12 @@
           <a:p/>
           <a:p>
             <a:r>
-              <a:t>Application snapshot: 2385ea7a3c6f9349c9c9ee67a56ace5f279fa992</a:t>
-            </a:r>
-          </a:p>
-          <a:p>
-            <a:r>
-              <a:t>Evidence date: 2026-10-29</a:t>
+              <a:t>Application snapshot: 723bb901411f84815f48acf1d5e6cef0a51f112d</a:t>
+            </a:r>
+          </a:p>
+          <a:p>
+            <a:r>
+              <a:t>Evidence date: 2026-10-30</a:t>
             </a:r>
           </a:p>
           <a:p>
@@ -2621,7 +2621,7 @@
           </a:p>
           <a:p>
             <a:r>
-              <a:t>https://github.com/manikantbindass/CityPulse/blob/2385ea7a3c6f9349c9c9ee67a56ace5f279fa992/services/api/src/main/java/io/citypulse/pulseai/PulseAiService.java</a:t>
+              <a:t>https://github.com/manikantbindass/CityPulse/blob/723bb901411f84815f48acf1d5e6cef0a51f112d/services/api/src/main/java/io/citypulse/pulseai/PulseAiService.java</a:t>
             </a:r>
           </a:p>
           <a:p>
@@ -2631,7 +2631,7 @@
           </a:p>
           <a:p>
             <a:r>
-              <a:t>https://github.com/manikantbindass/CityPulse/blob/2385ea7a3c6f9349c9c9ee67a56ace5f279fa992/services/ai-engine/citypulse_ai/pulseai.py</a:t>
+              <a:t>https://github.com/manikantbindass/CityPulse/blob/723bb901411f84815f48acf1d5e6cef0a51f112d/services/ai-engine/citypulse_ai/pulseai.py</a:t>
             </a:r>
           </a:p>
         </p:txBody>
@@ -2707,12 +2707,12 @@
           <a:p/>
           <a:p>
             <a:r>
-              <a:t>Application snapshot: 2385ea7a3c6f9349c9c9ee67a56ace5f279fa992</a:t>
-            </a:r>
-          </a:p>
-          <a:p>
-            <a:r>
-              <a:t>Evidence date: 2026-10-29</a:t>
+              <a:t>Application snapshot: 723bb901411f84815f48acf1d5e6cef0a51f112d</a:t>
+            </a:r>
+          </a:p>
+          <a:p>
+            <a:r>
+              <a:t>Evidence date: 2026-10-30</a:t>
             </a:r>
           </a:p>
           <a:p>
@@ -2727,7 +2727,7 @@
           </a:p>
           <a:p>
             <a:r>
-              <a:t>https://github.com/manikantbindass/CityPulse/blob/2385ea7a3c6f9349c9c9ee67a56ace5f279fa992/docs/blockchain.md</a:t>
+              <a:t>https://github.com/manikantbindass/CityPulse/blob/723bb901411f84815f48acf1d5e6cef0a51f112d/docs/blockchain.md</a:t>
             </a:r>
           </a:p>
           <a:p>
@@ -2737,7 +2737,7 @@
           </a:p>
           <a:p>
             <a:r>
-              <a:t>https://github.com/manikantbindass/CityPulse/blob/2385ea7a3c6f9349c9c9ee67a56ace5f279fa992/blockchain/contracts/DatasetAttestationRegistry.sol</a:t>
+              <a:t>https://github.com/manikantbindass/CityPulse/blob/723bb901411f84815f48acf1d5e6cef0a51f112d/blockchain/contracts/DatasetAttestationRegistry.sol</a:t>
             </a:r>
           </a:p>
         </p:txBody>
@@ -2813,12 +2813,12 @@
           <a:p/>
           <a:p>
             <a:r>
-              <a:t>Application snapshot: 2385ea7a3c6f9349c9c9ee67a56ace5f279fa992</a:t>
-            </a:r>
-          </a:p>
-          <a:p>
-            <a:r>
-              <a:t>Evidence date: 2026-10-29</a:t>
+              <a:t>Application snapshot: 723bb901411f84815f48acf1d5e6cef0a51f112d</a:t>
+            </a:r>
+          </a:p>
+          <a:p>
+            <a:r>
+              <a:t>Evidence date: 2026-10-30</a:t>
             </a:r>
           </a:p>
           <a:p>
@@ -2833,7 +2833,7 @@
           </a:p>
           <a:p>
             <a:r>
-              <a:t>https://github.com/manikantbindass/CityPulse/blob/2385ea7a3c6f9349c9c9ee67a56ace5f279fa992/docs/reports/blockchain-local-demo.json</a:t>
+              <a:t>https://github.com/manikantbindass/CityPulse/blob/723bb901411f84815f48acf1d5e6cef0a51f112d/docs/reports/blockchain-local-demo.json</a:t>
             </a:r>
           </a:p>
           <a:p>
@@ -2843,7 +2843,7 @@
           </a:p>
           <a:p>
             <a:r>
-              <a:t>https://github.com/manikantbindass/CityPulse/blob/2385ea7a3c6f9349c9c9ee67a56ace5f279fa992/services/api/src/main/java/io/citypulse/workspace/application/ChainReceiptService.java</a:t>
+              <a:t>https://github.com/manikantbindass/CityPulse/blob/723bb901411f84815f48acf1d5e6cef0a51f112d/services/api/src/main/java/io/citypulse/workspace/application/ChainReceiptService.java</a:t>
             </a:r>
           </a:p>
         </p:txBody>
@@ -2919,12 +2919,12 @@
           <a:p/>
           <a:p>
             <a:r>
-              <a:t>Application snapshot: 2385ea7a3c6f9349c9c9ee67a56ace5f279fa992</a:t>
-            </a:r>
-          </a:p>
-          <a:p>
-            <a:r>
-              <a:t>Evidence date: 2026-10-29</a:t>
+              <a:t>Application snapshot: 723bb901411f84815f48acf1d5e6cef0a51f112d</a:t>
+            </a:r>
+          </a:p>
+          <a:p>
+            <a:r>
+              <a:t>Evidence date: 2026-10-30</a:t>
             </a:r>
           </a:p>
           <a:p>
@@ -2939,7 +2939,7 @@
           </a:p>
           <a:p>
             <a:r>
-              <a:t>https://github.com/manikantbindass/CityPulse/blob/2385ea7a3c6f9349c9c9ee67a56ace5f279fa992/docs/security/architecture.md</a:t>
+              <a:t>https://github.com/manikantbindass/CityPulse/blob/723bb901411f84815f48acf1d5e6cef0a51f112d/docs/security/architecture.md</a:t>
             </a:r>
           </a:p>
           <a:p>
@@ -2949,7 +2949,7 @@
           </a:p>
           <a:p>
             <a:r>
-              <a:t>https://github.com/manikantbindass/CityPulse/blob/2385ea7a3c6f9349c9c9ee67a56ace5f279fa992/docs/security/threat-model.md</a:t>
+              <a:t>https://github.com/manikantbindass/CityPulse/blob/723bb901411f84815f48acf1d5e6cef0a51f112d/docs/security/threat-model.md</a:t>
             </a:r>
           </a:p>
         </p:txBody>
@@ -3025,12 +3025,12 @@
           <a:p/>
           <a:p>
             <a:r>
-              <a:t>Application snapshot: 2385ea7a3c6f9349c9c9ee67a56ace5f279fa992</a:t>
-            </a:r>
-          </a:p>
-          <a:p>
-            <a:r>
-              <a:t>Evidence date: 2026-10-29</a:t>
+              <a:t>Application snapshot: 723bb901411f84815f48acf1d5e6cef0a51f112d</a:t>
+            </a:r>
+          </a:p>
+          <a:p>
+            <a:r>
+              <a:t>Evidence date: 2026-10-30</a:t>
             </a:r>
           </a:p>
           <a:p>
@@ -3045,7 +3045,7 @@
           </a:p>
           <a:p>
             <a:r>
-              <a:t>https://github.com/manikantbindass/CityPulse/blob/2385ea7a3c6f9349c9c9ee67a56ace5f279fa992/infrastructure/terraform/main.tf.json</a:t>
+              <a:t>https://github.com/manikantbindass/CityPulse/blob/723bb901411f84815f48acf1d5e6cef0a51f112d/infrastructure/terraform/main.tf.json</a:t>
             </a:r>
           </a:p>
           <a:p>
@@ -3055,7 +3055,7 @@
           </a:p>
           <a:p>
             <a:r>
-              <a:t>https://github.com/manikantbindass/CityPulse/blob/2385ea7a3c6f9349c9c9ee67a56ace5f279fa992/docs/operations/deployment.md</a:t>
+              <a:t>https://github.com/manikantbindass/CityPulse/blob/723bb901411f84815f48acf1d5e6cef0a51f112d/docs/operations/deployment.md</a:t>
             </a:r>
           </a:p>
         </p:txBody>
@@ -3131,12 +3131,12 @@
           <a:p/>
           <a:p>
             <a:r>
-              <a:t>Application snapshot: 2385ea7a3c6f9349c9c9ee67a56ace5f279fa992</a:t>
-            </a:r>
-          </a:p>
-          <a:p>
-            <a:r>
-              <a:t>Evidence date: 2026-10-29</a:t>
+              <a:t>Application snapshot: 723bb901411f84815f48acf1d5e6cef0a51f112d</a:t>
+            </a:r>
+          </a:p>
+          <a:p>
+            <a:r>
+              <a:t>Evidence date: 2026-10-30</a:t>
             </a:r>
           </a:p>
           <a:p>
@@ -3151,7 +3151,7 @@
           </a:p>
           <a:p>
             <a:r>
-              <a:t>https://github.com/manikantbindass/CityPulse/blob/2385ea7a3c6f9349c9c9ee67a56ace5f279fa992/docs/operations/scaling.md</a:t>
+              <a:t>https://github.com/manikantbindass/CityPulse/blob/723bb901411f84815f48acf1d5e6cef0a51f112d/docs/operations/scaling.md</a:t>
             </a:r>
           </a:p>
           <a:p>
@@ -3161,7 +3161,7 @@
           </a:p>
           <a:p>
             <a:r>
-              <a:t>https://github.com/manikantbindass/CityPulse/blob/2385ea7a3c6f9349c9c9ee67a56ace5f279fa992/docs/operations/recovery.md</a:t>
+              <a:t>https://github.com/manikantbindass/CityPulse/blob/723bb901411f84815f48acf1d5e6cef0a51f112d/docs/operations/recovery.md</a:t>
             </a:r>
           </a:p>
         </p:txBody>
@@ -3237,12 +3237,12 @@
           <a:p/>
           <a:p>
             <a:r>
-              <a:t>Application snapshot: 2385ea7a3c6f9349c9c9ee67a56ace5f279fa992</a:t>
-            </a:r>
-          </a:p>
-          <a:p>
-            <a:r>
-              <a:t>Evidence date: 2026-10-29</a:t>
+              <a:t>Application snapshot: 723bb901411f84815f48acf1d5e6cef0a51f112d</a:t>
+            </a:r>
+          </a:p>
+          <a:p>
+            <a:r>
+              <a:t>Evidence date: 2026-10-30</a:t>
             </a:r>
           </a:p>
           <a:p>
@@ -3257,7 +3257,7 @@
           </a:p>
           <a:p>
             <a:r>
-              <a:t>https://github.com/manikantbindass/CityPulse/blob/2385ea7a3c6f9349c9c9ee67a56ace5f279fa992/.github/workflows/ci.yml</a:t>
+              <a:t>https://github.com/manikantbindass/CityPulse/blob/723bb901411f84815f48acf1d5e6cef0a51f112d/.github/workflows/ci.yml</a:t>
             </a:r>
           </a:p>
           <a:p>
@@ -3267,7 +3267,7 @@
           </a:p>
           <a:p>
             <a:r>
-              <a:t>https://github.com/manikantbindass/CityPulse/blob/2385ea7a3c6f9349c9c9ee67a56ace5f279fa992/.github/workflows/security.yml</a:t>
+              <a:t>https://github.com/manikantbindass/CityPulse/blob/723bb901411f84815f48acf1d5e6cef0a51f112d/.github/workflows/security.yml</a:t>
             </a:r>
           </a:p>
           <a:p>
@@ -3277,7 +3277,7 @@
           </a:p>
           <a:p>
             <a:r>
-              <a:t>https://github.com/manikantbindass/CityPulse/blob/2385ea7a3c6f9349c9c9ee67a56ace5f279fa992/scripts/monitoring_smoke.py</a:t>
+              <a:t>https://github.com/manikantbindass/CityPulse/blob/723bb901411f84815f48acf1d5e6cef0a51f112d/scripts/monitoring_smoke.py</a:t>
             </a:r>
           </a:p>
         </p:txBody>
@@ -3347,18 +3347,18 @@
           <a:lstStyle/>
           <a:p>
             <a:r>
-              <a:t>These counts have revision-linked CI evidence in the report. Linux Java has zero skips; local Docker tests skip because the engine was unavailable. Browser tests include accessibility and theme persistence. Zero fixable HIGH/CRITICAL findings is a scoped scan gate, not a clean bill of security.</a:t>
+              <a:t>These counts have revision-linked CI evidence in the report. Linux Java has zero skips; local Docker tests skip because the engine was unavailable. Browser tests include accessibility and theme persistence. Zero fixable HIGH/CRITICAL findings is a scoped scan gate, not a clean bill of security. These counts are the verified earlier 2385ea7 CI baseline. The candidate discovers 30 Java tests; eight are skipped locally without Docker, while 22 execute. The new whole-stack browser scenario must be verified in candidate CI.</a:t>
             </a:r>
           </a:p>
           <a:p/>
           <a:p>
             <a:r>
-              <a:t>Application snapshot: 2385ea7a3c6f9349c9c9ee67a56ace5f279fa992</a:t>
-            </a:r>
-          </a:p>
-          <a:p>
-            <a:r>
-              <a:t>Evidence date: 2026-10-29</a:t>
+              <a:t>Application snapshot: 723bb901411f84815f48acf1d5e6cef0a51f112d</a:t>
+            </a:r>
+          </a:p>
+          <a:p>
+            <a:r>
+              <a:t>Evidence date: 2026-10-30</a:t>
             </a:r>
           </a:p>
           <a:p>
@@ -3378,7 +3378,7 @@
           </a:p>
           <a:p>
             <a:r>
-              <a:t>https://github.com/manikantbindass/CityPulse/blob/2385ea7a3c6f9349c9c9ee67a56ace5f279fa992/apps/web/e2e/theme.spec.ts</a:t>
+              <a:t>https://github.com/manikantbindass/CityPulse/blob/723bb901411f84815f48acf1d5e6cef0a51f112d/apps/web/e2e/theme.spec.ts</a:t>
             </a:r>
           </a:p>
         </p:txBody>
@@ -3454,12 +3454,12 @@
           <a:p/>
           <a:p>
             <a:r>
-              <a:t>Application snapshot: 2385ea7a3c6f9349c9c9ee67a56ace5f279fa992</a:t>
-            </a:r>
-          </a:p>
-          <a:p>
-            <a:r>
-              <a:t>Evidence date: 2026-10-29</a:t>
+              <a:t>Application snapshot: 723bb901411f84815f48acf1d5e6cef0a51f112d</a:t>
+            </a:r>
+          </a:p>
+          <a:p>
+            <a:r>
+              <a:t>Evidence date: 2026-10-30</a:t>
             </a:r>
           </a:p>
           <a:p>
@@ -3474,7 +3474,7 @@
           </a:p>
           <a:p>
             <a:r>
-              <a:t>https://github.com/manikantbindass/CityPulse/blob/2385ea7a3c6f9349c9c9ee67a56ace5f279fa992/scripts/smoke.py</a:t>
+              <a:t>https://github.com/manikantbindass/CityPulse/blob/723bb901411f84815f48acf1d5e6cef0a51f112d/scripts/smoke.py</a:t>
             </a:r>
           </a:p>
           <a:p>
@@ -3484,7 +3484,7 @@
           </a:p>
           <a:p>
             <a:r>
-              <a:t>https://github.com/manikantbindass/CityPulse/blob/2385ea7a3c6f9349c9c9ee67a56ace5f279fa992/docs/decision-engine.md</a:t>
+              <a:t>https://github.com/manikantbindass/CityPulse/blob/723bb901411f84815f48acf1d5e6cef0a51f112d/docs/decision-engine.md</a:t>
             </a:r>
           </a:p>
           <a:p>
@@ -3494,7 +3494,7 @@
           </a:p>
           <a:p>
             <a:r>
-              <a:t>https://github.com/manikantbindass/CityPulse/blob/2385ea7a3c6f9349c9c9ee67a56ace5f279fa992/docs/pulseai.md</a:t>
+              <a:t>https://github.com/manikantbindass/CityPulse/blob/723bb901411f84815f48acf1d5e6cef0a51f112d/docs/pulseai.md</a:t>
             </a:r>
           </a:p>
         </p:txBody>
@@ -3570,12 +3570,12 @@
           <a:p/>
           <a:p>
             <a:r>
-              <a:t>Application snapshot: 2385ea7a3c6f9349c9c9ee67a56ace5f279fa992</a:t>
-            </a:r>
-          </a:p>
-          <a:p>
-            <a:r>
-              <a:t>Evidence date: 2026-10-29</a:t>
+              <a:t>Application snapshot: 723bb901411f84815f48acf1d5e6cef0a51f112d</a:t>
+            </a:r>
+          </a:p>
+          <a:p>
+            <a:r>
+              <a:t>Evidence date: 2026-10-30</a:t>
             </a:r>
           </a:p>
           <a:p>
@@ -3590,7 +3590,7 @@
           </a:p>
           <a:p>
             <a:r>
-              <a:t>https://github.com/manikantbindass/CityPulse/blob/2385ea7a3c6f9349c9c9ee67a56ace5f279fa992/docs/reports/operations/k6-local-ai.json</a:t>
+              <a:t>https://github.com/manikantbindass/CityPulse/blob/723bb901411f84815f48acf1d5e6cef0a51f112d/docs/reports/operations/k6-local-ai.json</a:t>
             </a:r>
           </a:p>
           <a:p>
@@ -3600,7 +3600,7 @@
           </a:p>
           <a:p>
             <a:r>
-              <a:t>https://github.com/manikantbindass/CityPulse/blob/2385ea7a3c6f9349c9c9ee67a56ace5f279fa992/docs/reports/decision-evaluation.json</a:t>
+              <a:t>https://github.com/manikantbindass/CityPulse/blob/723bb901411f84815f48acf1d5e6cef0a51f112d/docs/reports/decision-evaluation.json</a:t>
             </a:r>
           </a:p>
         </p:txBody>
@@ -3676,12 +3676,12 @@
           <a:p/>
           <a:p>
             <a:r>
-              <a:t>Application snapshot: 2385ea7a3c6f9349c9c9ee67a56ace5f279fa992</a:t>
-            </a:r>
-          </a:p>
-          <a:p>
-            <a:r>
-              <a:t>Evidence date: 2026-10-29</a:t>
+              <a:t>Application snapshot: 723bb901411f84815f48acf1d5e6cef0a51f112d</a:t>
+            </a:r>
+          </a:p>
+          <a:p>
+            <a:r>
+              <a:t>Evidence date: 2026-10-30</a:t>
             </a:r>
           </a:p>
           <a:p>
@@ -3696,7 +3696,7 @@
           </a:p>
           <a:p>
             <a:r>
-              <a:t>https://github.com/manikantbindass/CityPulse/blob/2385ea7a3c6f9349c9c9ee67a56ace5f279fa992/docs/data-dictionary.md</a:t>
+              <a:t>https://github.com/manikantbindass/CityPulse/blob/723bb901411f84815f48acf1d5e6cef0a51f112d/docs/data-dictionary.md</a:t>
             </a:r>
           </a:p>
           <a:p>
@@ -3706,7 +3706,7 @@
           </a:p>
           <a:p>
             <a:r>
-              <a:t>https://github.com/manikantbindass/CityPulse/blob/2385ea7a3c6f9349c9c9ee67a56ace5f279fa992/services/api/src/main/java/io/citypulse/workspace/application/AnalyticsService.java</a:t>
+              <a:t>https://github.com/manikantbindass/CityPulse/blob/723bb901411f84815f48acf1d5e6cef0a51f112d/services/api/src/main/java/io/citypulse/workspace/application/AnalyticsService.java</a:t>
             </a:r>
           </a:p>
         </p:txBody>
@@ -3782,12 +3782,12 @@
           <a:p/>
           <a:p>
             <a:r>
-              <a:t>Application snapshot: 2385ea7a3c6f9349c9c9ee67a56ace5f279fa992</a:t>
-            </a:r>
-          </a:p>
-          <a:p>
-            <a:r>
-              <a:t>Evidence date: 2026-10-29</a:t>
+              <a:t>Application snapshot: 723bb901411f84815f48acf1d5e6cef0a51f112d</a:t>
+            </a:r>
+          </a:p>
+          <a:p>
+            <a:r>
+              <a:t>Evidence date: 2026-10-30</a:t>
             </a:r>
           </a:p>
           <a:p>
@@ -3802,7 +3802,7 @@
           </a:p>
           <a:p>
             <a:r>
-              <a:t>https://github.com/manikantbindass/CityPulse/blob/2385ea7a3c6f9349c9c9ee67a56ace5f279fa992/docs/api/backend.md</a:t>
+              <a:t>https://github.com/manikantbindass/CityPulse/blob/723bb901411f84815f48acf1d5e6cef0a51f112d/docs/api/backend.md</a:t>
             </a:r>
           </a:p>
           <a:p>
@@ -3812,7 +3812,7 @@
           </a:p>
           <a:p>
             <a:r>
-              <a:t>https://github.com/manikantbindass/CityPulse/blob/2385ea7a3c6f9349c9c9ee67a56ace5f279fa992/docs/security/verification.md</a:t>
+              <a:t>https://github.com/manikantbindass/CityPulse/blob/723bb901411f84815f48acf1d5e6cef0a51f112d/docs/security/verification.md</a:t>
             </a:r>
           </a:p>
           <a:p>
@@ -3822,7 +3822,7 @@
           </a:p>
           <a:p>
             <a:r>
-              <a:t>https://github.com/manikantbindass/CityPulse/blob/2385ea7a3c6f9349c9c9ee67a56ace5f279fa992/docs/operations/scaling.md</a:t>
+              <a:t>https://github.com/manikantbindass/CityPulse/blob/723bb901411f84815f48acf1d5e6cef0a51f112d/docs/operations/scaling.md</a:t>
             </a:r>
           </a:p>
         </p:txBody>
@@ -3898,12 +3898,12 @@
           <a:p/>
           <a:p>
             <a:r>
-              <a:t>Application snapshot: 2385ea7a3c6f9349c9c9ee67a56ace5f279fa992</a:t>
-            </a:r>
-          </a:p>
-          <a:p>
-            <a:r>
-              <a:t>Evidence date: 2026-10-29</a:t>
+              <a:t>Application snapshot: 723bb901411f84815f48acf1d5e6cef0a51f112d</a:t>
+            </a:r>
+          </a:p>
+          <a:p>
+            <a:r>
+              <a:t>Evidence date: 2026-10-30</a:t>
             </a:r>
           </a:p>
           <a:p>
@@ -3918,7 +3918,7 @@
           </a:p>
           <a:p>
             <a:r>
-              <a:t>https://github.com/manikantbindass/CityPulse/blob/2385ea7a3c6f9349c9c9ee67a56ace5f279fa992/README.md</a:t>
+              <a:t>https://github.com/manikantbindass/CityPulse/blob/723bb901411f84815f48acf1d5e6cef0a51f112d/README.md</a:t>
             </a:r>
           </a:p>
           <a:p>
@@ -3928,7 +3928,7 @@
           </a:p>
           <a:p>
             <a:r>
-              <a:t>https://github.com/manikantbindass/CityPulse/blob/2385ea7a3c6f9349c9c9ee67a56ace5f279fa992/docs/operations/scaling.md</a:t>
+              <a:t>https://github.com/manikantbindass/CityPulse/blob/723bb901411f84815f48acf1d5e6cef0a51f112d/docs/operations/scaling.md</a:t>
             </a:r>
           </a:p>
           <a:p>
@@ -3938,7 +3938,7 @@
           </a:p>
           <a:p>
             <a:r>
-              <a:t>https://github.com/manikantbindass/CityPulse/blob/2385ea7a3c6f9349c9c9ee67a56ace5f279fa992/docs/model-card.md</a:t>
+              <a:t>https://github.com/manikantbindass/CityPulse/blob/723bb901411f84815f48acf1d5e6cef0a51f112d/docs/model-card.md</a:t>
             </a:r>
           </a:p>
         </p:txBody>
@@ -4014,12 +4014,12 @@
           <a:p/>
           <a:p>
             <a:r>
-              <a:t>Application snapshot: 2385ea7a3c6f9349c9c9ee67a56ace5f279fa992</a:t>
-            </a:r>
-          </a:p>
-          <a:p>
-            <a:r>
-              <a:t>Evidence date: 2026-10-29</a:t>
+              <a:t>Application snapshot: 723bb901411f84815f48acf1d5e6cef0a51f112d</a:t>
+            </a:r>
+          </a:p>
+          <a:p>
+            <a:r>
+              <a:t>Evidence date: 2026-10-30</a:t>
             </a:r>
           </a:p>
           <a:p>
@@ -4039,7 +4039,7 @@
           </a:p>
           <a:p>
             <a:r>
-              <a:t>https://github.com/manikantbindass/CityPulse/blob/2385ea7a3c6f9349c9c9ee67a56ace5f279fa992/README.md</a:t>
+              <a:t>https://github.com/manikantbindass/CityPulse/blob/723bb901411f84815f48acf1d5e6cef0a51f112d/README.md</a:t>
             </a:r>
           </a:p>
         </p:txBody>
@@ -4115,12 +4115,12 @@
           <a:p/>
           <a:p>
             <a:r>
-              <a:t>Application snapshot: 2385ea7a3c6f9349c9c9ee67a56ace5f279fa992</a:t>
-            </a:r>
-          </a:p>
-          <a:p>
-            <a:r>
-              <a:t>Evidence date: 2026-10-29</a:t>
+              <a:t>Application snapshot: 723bb901411f84815f48acf1d5e6cef0a51f112d</a:t>
+            </a:r>
+          </a:p>
+          <a:p>
+            <a:r>
+              <a:t>Evidence date: 2026-10-30</a:t>
             </a:r>
           </a:p>
           <a:p>
@@ -4135,7 +4135,7 @@
           </a:p>
           <a:p>
             <a:r>
-              <a:t>https://github.com/manikantbindass/CityPulse/blob/2385ea7a3c6f9349c9c9ee67a56ace5f279fa992/README.md</a:t>
+              <a:t>https://github.com/manikantbindass/CityPulse/blob/723bb901411f84815f48acf1d5e6cef0a51f112d/README.md</a:t>
             </a:r>
           </a:p>
         </p:txBody>
@@ -4211,12 +4211,12 @@
           <a:p/>
           <a:p>
             <a:r>
-              <a:t>Application snapshot: 2385ea7a3c6f9349c9c9ee67a56ace5f279fa992</a:t>
-            </a:r>
-          </a:p>
-          <a:p>
-            <a:r>
-              <a:t>Evidence date: 2026-10-29</a:t>
+              <a:t>Application snapshot: 723bb901411f84815f48acf1d5e6cef0a51f112d</a:t>
+            </a:r>
+          </a:p>
+          <a:p>
+            <a:r>
+              <a:t>Evidence date: 2026-10-30</a:t>
             </a:r>
           </a:p>
           <a:p>
@@ -4302,12 +4302,12 @@
           <a:p/>
           <a:p>
             <a:r>
-              <a:t>Application snapshot: 2385ea7a3c6f9349c9c9ee67a56ace5f279fa992</a:t>
-            </a:r>
-          </a:p>
-          <a:p>
-            <a:r>
-              <a:t>Evidence date: 2026-10-29</a:t>
+              <a:t>Application snapshot: 723bb901411f84815f48acf1d5e6cef0a51f112d</a:t>
+            </a:r>
+          </a:p>
+          <a:p>
+            <a:r>
+              <a:t>Evidence date: 2026-10-30</a:t>
             </a:r>
           </a:p>
           <a:p>
@@ -4322,7 +4322,7 @@
           </a:p>
           <a:p>
             <a:r>
-              <a:t>https://github.com/manikantbindass/CityPulse/blob/2385ea7a3c6f9349c9c9ee67a56ace5f279fa992/README.md</a:t>
+              <a:t>https://github.com/manikantbindass/CityPulse/blob/723bb901411f84815f48acf1d5e6cef0a51f112d/README.md</a:t>
             </a:r>
           </a:p>
           <a:p>
@@ -4332,7 +4332,7 @@
           </a:p>
           <a:p>
             <a:r>
-              <a:t>https://github.com/manikantbindass/CityPulse/blob/2385ea7a3c6f9349c9c9ee67a56ace5f279fa992/docs/decision-engine.md</a:t>
+              <a:t>https://github.com/manikantbindass/CityPulse/blob/723bb901411f84815f48acf1d5e6cef0a51f112d/docs/decision-engine.md</a:t>
             </a:r>
           </a:p>
         </p:txBody>
@@ -4408,12 +4408,12 @@
           <a:p/>
           <a:p>
             <a:r>
-              <a:t>Application snapshot: 2385ea7a3c6f9349c9c9ee67a56ace5f279fa992</a:t>
-            </a:r>
-          </a:p>
-          <a:p>
-            <a:r>
-              <a:t>Evidence date: 2026-10-29</a:t>
+              <a:t>Application snapshot: 723bb901411f84815f48acf1d5e6cef0a51f112d</a:t>
+            </a:r>
+          </a:p>
+          <a:p>
+            <a:r>
+              <a:t>Evidence date: 2026-10-30</a:t>
             </a:r>
           </a:p>
           <a:p>
@@ -4428,7 +4428,7 @@
           </a:p>
           <a:p>
             <a:r>
-              <a:t>https://github.com/manikantbindass/CityPulse/blob/2385ea7a3c6f9349c9c9ee67a56ace5f279fa992/docs/PRD.md</a:t>
+              <a:t>https://github.com/manikantbindass/CityPulse/blob/723bb901411f84815f48acf1d5e6cef0a51f112d/docs/PRD.md</a:t>
             </a:r>
           </a:p>
           <a:p>
@@ -4509,12 +4509,12 @@
           <a:p/>
           <a:p>
             <a:r>
-              <a:t>Application snapshot: 2385ea7a3c6f9349c9c9ee67a56ace5f279fa992</a:t>
-            </a:r>
-          </a:p>
-          <a:p>
-            <a:r>
-              <a:t>Evidence date: 2026-10-29</a:t>
+              <a:t>Application snapshot: 723bb901411f84815f48acf1d5e6cef0a51f112d</a:t>
+            </a:r>
+          </a:p>
+          <a:p>
+            <a:r>
+              <a:t>Evidence date: 2026-10-30</a:t>
             </a:r>
           </a:p>
           <a:p>
@@ -4529,7 +4529,7 @@
           </a:p>
           <a:p>
             <a:r>
-              <a:t>https://github.com/manikantbindass/CityPulse/blob/2385ea7a3c6f9349c9c9ee67a56ace5f279fa992/docs/api/backend.md</a:t>
+              <a:t>https://github.com/manikantbindass/CityPulse/blob/723bb901411f84815f48acf1d5e6cef0a51f112d/docs/api/backend.md</a:t>
             </a:r>
           </a:p>
           <a:p>
@@ -4539,7 +4539,7 @@
           </a:p>
           <a:p>
             <a:r>
-              <a:t>https://github.com/manikantbindass/CityPulse/blob/2385ea7a3c6f9349c9c9ee67a56ace5f279fa992/docs/security/architecture.md</a:t>
+              <a:t>https://github.com/manikantbindass/CityPulse/blob/723bb901411f84815f48acf1d5e6cef0a51f112d/docs/security/architecture.md</a:t>
             </a:r>
           </a:p>
         </p:txBody>
@@ -4615,12 +4615,12 @@
           <a:p/>
           <a:p>
             <a:r>
-              <a:t>Application snapshot: 2385ea7a3c6f9349c9c9ee67a56ace5f279fa992</a:t>
-            </a:r>
-          </a:p>
-          <a:p>
-            <a:r>
-              <a:t>Evidence date: 2026-10-29</a:t>
+              <a:t>Application snapshot: 723bb901411f84815f48acf1d5e6cef0a51f112d</a:t>
+            </a:r>
+          </a:p>
+          <a:p>
+            <a:r>
+              <a:t>Evidence date: 2026-10-30</a:t>
             </a:r>
           </a:p>
           <a:p>
@@ -4635,7 +4635,7 @@
           </a:p>
           <a:p>
             <a:r>
-              <a:t>https://github.com/manikantbindass/CityPulse/blob/2385ea7a3c6f9349c9c9ee67a56ace5f279fa992/README.md</a:t>
+              <a:t>https://github.com/manikantbindass/CityPulse/blob/723bb901411f84815f48acf1d5e6cef0a51f112d/README.md</a:t>
             </a:r>
           </a:p>
           <a:p>
@@ -4645,7 +4645,7 @@
           </a:p>
           <a:p>
             <a:r>
-              <a:t>https://github.com/manikantbindass/CityPulse/blob/2385ea7a3c6f9349c9c9ee67a56ace5f279fa992/docs/decision-engine.md</a:t>
+              <a:t>https://github.com/manikantbindass/CityPulse/blob/723bb901411f84815f48acf1d5e6cef0a51f112d/docs/decision-engine.md</a:t>
             </a:r>
           </a:p>
         </p:txBody>
@@ -4721,12 +4721,12 @@
           <a:p/>
           <a:p>
             <a:r>
-              <a:t>Application snapshot: 2385ea7a3c6f9349c9c9ee67a56ace5f279fa992</a:t>
-            </a:r>
-          </a:p>
-          <a:p>
-            <a:r>
-              <a:t>Evidence date: 2026-10-29</a:t>
+              <a:t>Application snapshot: 723bb901411f84815f48acf1d5e6cef0a51f112d</a:t>
+            </a:r>
+          </a:p>
+          <a:p>
+            <a:r>
+              <a:t>Evidence date: 2026-10-30</a:t>
             </a:r>
           </a:p>
           <a:p>
@@ -4741,7 +4741,7 @@
           </a:p>
           <a:p>
             <a:r>
-              <a:t>https://github.com/manikantbindass/CityPulse/blob/2385ea7a3c6f9349c9c9ee67a56ace5f279fa992/docs/assets/readme-provenance.json</a:t>
+              <a:t>https://github.com/manikantbindass/CityPulse/blob/723bb901411f84815f48acf1d5e6cef0a51f112d/docs/assets/readme-provenance.json</a:t>
             </a:r>
           </a:p>
         </p:txBody>
@@ -28370,7 +28370,7 @@
               </a:defRPr>
             </a:pPr>
             <a:r>
-              <a:t>Revision-linked CI evidence; two mocked Terraform plans; no coverage percentage invented</a:t>
+              <a:t>Earlier CI baseline 2385ea7; candidate adds a PostGIS regression; current checks are authoritative</a:t>
             </a:r>
           </a:p>
         </p:txBody>

</xml_diff>

<commit_message>
docs: bind evidence to corrected release query
</commit_message>
<xml_diff>
--- a/docs/presentations/CityPulse-Project-Presentation.pptx
+++ b/docs/presentations/CityPulse-Project-Presentation.pptx
@@ -1334,7 +1334,7 @@
           <a:p/>
           <a:p>
             <a:r>
-              <a:t>Application snapshot: 723bb901411f84815f48acf1d5e6cef0a51f112d</a:t>
+              <a:t>Application snapshot: 370e60164da719fc506bd69c2796fb59823cc4ba</a:t>
             </a:r>
           </a:p>
           <a:p>
@@ -1354,7 +1354,7 @@
           </a:p>
           <a:p>
             <a:r>
-              <a:t>https://github.com/manikantbindass/CityPulse/blob/723bb901411f84815f48acf1d5e6cef0a51f112d/README.md</a:t>
+              <a:t>https://github.com/manikantbindass/CityPulse/blob/370e60164da719fc506bd69c2796fb59823cc4ba/README.md</a:t>
             </a:r>
           </a:p>
           <a:p>
@@ -1435,7 +1435,7 @@
           <a:p/>
           <a:p>
             <a:r>
-              <a:t>Application snapshot: 723bb901411f84815f48acf1d5e6cef0a51f112d</a:t>
+              <a:t>Application snapshot: 370e60164da719fc506bd69c2796fb59823cc4ba</a:t>
             </a:r>
           </a:p>
           <a:p>
@@ -1455,7 +1455,7 @@
           </a:p>
           <a:p>
             <a:r>
-              <a:t>https://github.com/manikantbindass/CityPulse/blob/723bb901411f84815f48acf1d5e6cef0a51f112d/apps/web/package.json</a:t>
+              <a:t>https://github.com/manikantbindass/CityPulse/blob/370e60164da719fc506bd69c2796fb59823cc4ba/apps/web/package.json</a:t>
             </a:r>
           </a:p>
           <a:p>
@@ -1465,7 +1465,7 @@
           </a:p>
           <a:p>
             <a:r>
-              <a:t>https://github.com/manikantbindass/CityPulse/blob/723bb901411f84815f48acf1d5e6cef0a51f112d/services/api/pom.xml</a:t>
+              <a:t>https://github.com/manikantbindass/CityPulse/blob/370e60164da719fc506bd69c2796fb59823cc4ba/services/api/pom.xml</a:t>
             </a:r>
           </a:p>
           <a:p>
@@ -1475,7 +1475,7 @@
           </a:p>
           <a:p>
             <a:r>
-              <a:t>https://github.com/manikantbindass/CityPulse/blob/723bb901411f84815f48acf1d5e6cef0a51f112d/services/ai-engine/pyproject.toml</a:t>
+              <a:t>https://github.com/manikantbindass/CityPulse/blob/370e60164da719fc506bd69c2796fb59823cc4ba/services/ai-engine/pyproject.toml</a:t>
             </a:r>
           </a:p>
         </p:txBody>
@@ -1551,7 +1551,7 @@
           <a:p/>
           <a:p>
             <a:r>
-              <a:t>Application snapshot: 723bb901411f84815f48acf1d5e6cef0a51f112d</a:t>
+              <a:t>Application snapshot: 370e60164da719fc506bd69c2796fb59823cc4ba</a:t>
             </a:r>
           </a:p>
           <a:p>
@@ -1576,7 +1576,7 @@
           </a:p>
           <a:p>
             <a:r>
-              <a:t>https://github.com/manikantbindass/CityPulse/blob/723bb901411f84815f48acf1d5e6cef0a51f112d/compose.yaml</a:t>
+              <a:t>https://github.com/manikantbindass/CityPulse/blob/370e60164da719fc506bd69c2796fb59823cc4ba/compose.yaml</a:t>
             </a:r>
           </a:p>
         </p:txBody>
@@ -1652,7 +1652,7 @@
           <a:p/>
           <a:p>
             <a:r>
-              <a:t>Application snapshot: 723bb901411f84815f48acf1d5e6cef0a51f112d</a:t>
+              <a:t>Application snapshot: 370e60164da719fc506bd69c2796fb59823cc4ba</a:t>
             </a:r>
           </a:p>
           <a:p>
@@ -1672,7 +1672,7 @@
           </a:p>
           <a:p>
             <a:r>
-              <a:t>https://github.com/manikantbindass/CityPulse/blob/723bb901411f84815f48acf1d5e6cef0a51f112d/apps/web/components/providers.tsx</a:t>
+              <a:t>https://github.com/manikantbindass/CityPulse/blob/370e60164da719fc506bd69c2796fb59823cc4ba/apps/web/components/providers.tsx</a:t>
             </a:r>
           </a:p>
           <a:p>
@@ -1682,7 +1682,7 @@
           </a:p>
           <a:p>
             <a:r>
-              <a:t>https://github.com/manikantbindass/CityPulse/blob/723bb901411f84815f48acf1d5e6cef0a51f112d/apps/web/e2e/theme.spec.ts</a:t>
+              <a:t>https://github.com/manikantbindass/CityPulse/blob/370e60164da719fc506bd69c2796fb59823cc4ba/apps/web/e2e/theme.spec.ts</a:t>
             </a:r>
           </a:p>
         </p:txBody>
@@ -1758,7 +1758,7 @@
           <a:p/>
           <a:p>
             <a:r>
-              <a:t>Application snapshot: 723bb901411f84815f48acf1d5e6cef0a51f112d</a:t>
+              <a:t>Application snapshot: 370e60164da719fc506bd69c2796fb59823cc4ba</a:t>
             </a:r>
           </a:p>
           <a:p>
@@ -1778,7 +1778,7 @@
           </a:p>
           <a:p>
             <a:r>
-              <a:t>https://github.com/manikantbindass/CityPulse/blob/723bb901411f84815f48acf1d5e6cef0a51f112d/services/api/src/main/java/io/citypulse/identity/MembershipFilter.java</a:t>
+              <a:t>https://github.com/manikantbindass/CityPulse/blob/370e60164da719fc506bd69c2796fb59823cc4ba/services/api/src/main/java/io/citypulse/identity/MembershipFilter.java</a:t>
             </a:r>
           </a:p>
           <a:p>
@@ -1788,7 +1788,7 @@
           </a:p>
           <a:p>
             <a:r>
-              <a:t>https://github.com/manikantbindass/CityPulse/blob/723bb901411f84815f48acf1d5e6cef0a51f112d/docs/api/backend.md</a:t>
+              <a:t>https://github.com/manikantbindass/CityPulse/blob/370e60164da719fc506bd69c2796fb59823cc4ba/docs/api/backend.md</a:t>
             </a:r>
           </a:p>
         </p:txBody>
@@ -1864,7 +1864,7 @@
           <a:p/>
           <a:p>
             <a:r>
-              <a:t>Application snapshot: 723bb901411f84815f48acf1d5e6cef0a51f112d</a:t>
+              <a:t>Application snapshot: 370e60164da719fc506bd69c2796fb59823cc4ba</a:t>
             </a:r>
           </a:p>
           <a:p>
@@ -1884,7 +1884,7 @@
           </a:p>
           <a:p>
             <a:r>
-              <a:t>https://github.com/manikantbindass/CityPulse/blob/723bb901411f84815f48acf1d5e6cef0a51f112d/services/api/src/main/resources/db/migration/V1__canonical_geospatial_schema.sql</a:t>
+              <a:t>https://github.com/manikantbindass/CityPulse/blob/370e60164da719fc506bd69c2796fb59823cc4ba/services/api/src/main/resources/db/migration/V1__canonical_geospatial_schema.sql</a:t>
             </a:r>
           </a:p>
           <a:p>
@@ -1894,7 +1894,7 @@
           </a:p>
           <a:p>
             <a:r>
-              <a:t>https://github.com/manikantbindass/CityPulse/blob/723bb901411f84815f48acf1d5e6cef0a51f112d/services/api/src/main/resources/db/migration/V2__tenant_operations.sql</a:t>
+              <a:t>https://github.com/manikantbindass/CityPulse/blob/370e60164da719fc506bd69c2796fb59823cc4ba/services/api/src/main/resources/db/migration/V2__tenant_operations.sql</a:t>
             </a:r>
           </a:p>
         </p:txBody>
@@ -1970,7 +1970,7 @@
           <a:p/>
           <a:p>
             <a:r>
-              <a:t>Application snapshot: 723bb901411f84815f48acf1d5e6cef0a51f112d</a:t>
+              <a:t>Application snapshot: 370e60164da719fc506bd69c2796fb59823cc4ba</a:t>
             </a:r>
           </a:p>
           <a:p>
@@ -1990,7 +1990,7 @@
           </a:p>
           <a:p>
             <a:r>
-              <a:t>https://github.com/manikantbindass/CityPulse/blob/723bb901411f84815f48acf1d5e6cef0a51f112d/services/ingestion/citypulse_ingestion/pipeline.py</a:t>
+              <a:t>https://github.com/manikantbindass/CityPulse/blob/370e60164da719fc506bd69c2796fb59823cc4ba/services/ingestion/citypulse_ingestion/pipeline.py</a:t>
             </a:r>
           </a:p>
           <a:p>
@@ -2000,7 +2000,7 @@
           </a:p>
           <a:p>
             <a:r>
-              <a:t>https://github.com/manikantbindass/CityPulse/blob/723bb901411f84815f48acf1d5e6cef0a51f112d/scripts/data_pipeline.py</a:t>
+              <a:t>https://github.com/manikantbindass/CityPulse/blob/370e60164da719fc506bd69c2796fb59823cc4ba/scripts/data_pipeline.py</a:t>
             </a:r>
           </a:p>
         </p:txBody>
@@ -2076,7 +2076,7 @@
           <a:p/>
           <a:p>
             <a:r>
-              <a:t>Application snapshot: 723bb901411f84815f48acf1d5e6cef0a51f112d</a:t>
+              <a:t>Application snapshot: 370e60164da719fc506bd69c2796fb59823cc4ba</a:t>
             </a:r>
           </a:p>
           <a:p>
@@ -2096,7 +2096,7 @@
           </a:p>
           <a:p>
             <a:r>
-              <a:t>https://github.com/manikantbindass/CityPulse/blob/723bb901411f84815f48acf1d5e6cef0a51f112d/services/ai-engine/citypulse_ai/modeling.py</a:t>
+              <a:t>https://github.com/manikantbindass/CityPulse/blob/370e60164da719fc506bd69c2796fb59823cc4ba/services/ai-engine/citypulse_ai/modeling.py</a:t>
             </a:r>
           </a:p>
           <a:p>
@@ -2106,7 +2106,7 @@
           </a:p>
           <a:p>
             <a:r>
-              <a:t>https://github.com/manikantbindass/CityPulse/blob/723bb901411f84815f48acf1d5e6cef0a51f112d/docs/reports/model-evaluation.json</a:t>
+              <a:t>https://github.com/manikantbindass/CityPulse/blob/370e60164da719fc506bd69c2796fb59823cc4ba/docs/reports/model-evaluation.json</a:t>
             </a:r>
           </a:p>
         </p:txBody>
@@ -2182,7 +2182,7 @@
           <a:p/>
           <a:p>
             <a:r>
-              <a:t>Application snapshot: 723bb901411f84815f48acf1d5e6cef0a51f112d</a:t>
+              <a:t>Application snapshot: 370e60164da719fc506bd69c2796fb59823cc4ba</a:t>
             </a:r>
           </a:p>
           <a:p>
@@ -2202,7 +2202,7 @@
           </a:p>
           <a:p>
             <a:r>
-              <a:t>https://github.com/manikantbindass/CityPulse/blob/723bb901411f84815f48acf1d5e6cef0a51f112d/docs/reports/model-evaluation.json</a:t>
+              <a:t>https://github.com/manikantbindass/CityPulse/blob/370e60164da719fc506bd69c2796fb59823cc4ba/docs/reports/model-evaluation.json</a:t>
             </a:r>
           </a:p>
           <a:p>
@@ -2212,7 +2212,7 @@
           </a:p>
           <a:p>
             <a:r>
-              <a:t>https://github.com/manikantbindass/CityPulse/blob/723bb901411f84815f48acf1d5e6cef0a51f112d/docs/model-card.md</a:t>
+              <a:t>https://github.com/manikantbindass/CityPulse/blob/370e60164da719fc506bd69c2796fb59823cc4ba/docs/model-card.md</a:t>
             </a:r>
           </a:p>
         </p:txBody>
@@ -2288,7 +2288,7 @@
           <a:p/>
           <a:p>
             <a:r>
-              <a:t>Application snapshot: 723bb901411f84815f48acf1d5e6cef0a51f112d</a:t>
+              <a:t>Application snapshot: 370e60164da719fc506bd69c2796fb59823cc4ba</a:t>
             </a:r>
           </a:p>
           <a:p>
@@ -2313,7 +2313,7 @@
           </a:p>
           <a:p>
             <a:r>
-              <a:t>https://github.com/manikantbindass/CityPulse/blob/723bb901411f84815f48acf1d5e6cef0a51f112d/docs/model-card.md</a:t>
+              <a:t>https://github.com/manikantbindass/CityPulse/blob/370e60164da719fc506bd69c2796fb59823cc4ba/docs/model-card.md</a:t>
             </a:r>
           </a:p>
         </p:txBody>
@@ -2389,7 +2389,7 @@
           <a:p/>
           <a:p>
             <a:r>
-              <a:t>Application snapshot: 723bb901411f84815f48acf1d5e6cef0a51f112d</a:t>
+              <a:t>Application snapshot: 370e60164da719fc506bd69c2796fb59823cc4ba</a:t>
             </a:r>
           </a:p>
           <a:p>
@@ -2409,7 +2409,7 @@
           </a:p>
           <a:p>
             <a:r>
-              <a:t>https://github.com/manikantbindass/CityPulse/blob/723bb901411f84815f48acf1d5e6cef0a51f112d/docs/reports/decision-evaluation.json</a:t>
+              <a:t>https://github.com/manikantbindass/CityPulse/blob/370e60164da719fc506bd69c2796fb59823cc4ba/docs/reports/decision-evaluation.json</a:t>
             </a:r>
           </a:p>
           <a:p>
@@ -2419,7 +2419,7 @@
           </a:p>
           <a:p>
             <a:r>
-              <a:t>https://github.com/manikantbindass/CityPulse/blob/723bb901411f84815f48acf1d5e6cef0a51f112d/services/ai-engine/citypulse_ai/decisions.py</a:t>
+              <a:t>https://github.com/manikantbindass/CityPulse/blob/370e60164da719fc506bd69c2796fb59823cc4ba/services/ai-engine/citypulse_ai/decisions.py</a:t>
             </a:r>
           </a:p>
         </p:txBody>
@@ -2495,7 +2495,7 @@
           <a:p/>
           <a:p>
             <a:r>
-              <a:t>Application snapshot: 723bb901411f84815f48acf1d5e6cef0a51f112d</a:t>
+              <a:t>Application snapshot: 370e60164da719fc506bd69c2796fb59823cc4ba</a:t>
             </a:r>
           </a:p>
           <a:p>
@@ -2515,7 +2515,7 @@
           </a:p>
           <a:p>
             <a:r>
-              <a:t>https://github.com/manikantbindass/CityPulse/blob/723bb901411f84815f48acf1d5e6cef0a51f112d/README.md</a:t>
+              <a:t>https://github.com/manikantbindass/CityPulse/blob/370e60164da719fc506bd69c2796fb59823cc4ba/README.md</a:t>
             </a:r>
           </a:p>
           <a:p>
@@ -2525,7 +2525,7 @@
           </a:p>
           <a:p>
             <a:r>
-              <a:t>https://github.com/manikantbindass/CityPulse/blob/723bb901411f84815f48acf1d5e6cef0a51f112d/compose.yaml</a:t>
+              <a:t>https://github.com/manikantbindass/CityPulse/blob/370e60164da719fc506bd69c2796fb59823cc4ba/compose.yaml</a:t>
             </a:r>
           </a:p>
         </p:txBody>
@@ -2601,7 +2601,7 @@
           <a:p/>
           <a:p>
             <a:r>
-              <a:t>Application snapshot: 723bb901411f84815f48acf1d5e6cef0a51f112d</a:t>
+              <a:t>Application snapshot: 370e60164da719fc506bd69c2796fb59823cc4ba</a:t>
             </a:r>
           </a:p>
           <a:p>
@@ -2621,7 +2621,7 @@
           </a:p>
           <a:p>
             <a:r>
-              <a:t>https://github.com/manikantbindass/CityPulse/blob/723bb901411f84815f48acf1d5e6cef0a51f112d/services/api/src/main/java/io/citypulse/pulseai/PulseAiService.java</a:t>
+              <a:t>https://github.com/manikantbindass/CityPulse/blob/370e60164da719fc506bd69c2796fb59823cc4ba/services/api/src/main/java/io/citypulse/pulseai/PulseAiService.java</a:t>
             </a:r>
           </a:p>
           <a:p>
@@ -2631,7 +2631,7 @@
           </a:p>
           <a:p>
             <a:r>
-              <a:t>https://github.com/manikantbindass/CityPulse/blob/723bb901411f84815f48acf1d5e6cef0a51f112d/services/ai-engine/citypulse_ai/pulseai.py</a:t>
+              <a:t>https://github.com/manikantbindass/CityPulse/blob/370e60164da719fc506bd69c2796fb59823cc4ba/services/ai-engine/citypulse_ai/pulseai.py</a:t>
             </a:r>
           </a:p>
         </p:txBody>
@@ -2707,7 +2707,7 @@
           <a:p/>
           <a:p>
             <a:r>
-              <a:t>Application snapshot: 723bb901411f84815f48acf1d5e6cef0a51f112d</a:t>
+              <a:t>Application snapshot: 370e60164da719fc506bd69c2796fb59823cc4ba</a:t>
             </a:r>
           </a:p>
           <a:p>
@@ -2727,7 +2727,7 @@
           </a:p>
           <a:p>
             <a:r>
-              <a:t>https://github.com/manikantbindass/CityPulse/blob/723bb901411f84815f48acf1d5e6cef0a51f112d/docs/blockchain.md</a:t>
+              <a:t>https://github.com/manikantbindass/CityPulse/blob/370e60164da719fc506bd69c2796fb59823cc4ba/docs/blockchain.md</a:t>
             </a:r>
           </a:p>
           <a:p>
@@ -2737,7 +2737,7 @@
           </a:p>
           <a:p>
             <a:r>
-              <a:t>https://github.com/manikantbindass/CityPulse/blob/723bb901411f84815f48acf1d5e6cef0a51f112d/blockchain/contracts/DatasetAttestationRegistry.sol</a:t>
+              <a:t>https://github.com/manikantbindass/CityPulse/blob/370e60164da719fc506bd69c2796fb59823cc4ba/blockchain/contracts/DatasetAttestationRegistry.sol</a:t>
             </a:r>
           </a:p>
         </p:txBody>
@@ -2813,7 +2813,7 @@
           <a:p/>
           <a:p>
             <a:r>
-              <a:t>Application snapshot: 723bb901411f84815f48acf1d5e6cef0a51f112d</a:t>
+              <a:t>Application snapshot: 370e60164da719fc506bd69c2796fb59823cc4ba</a:t>
             </a:r>
           </a:p>
           <a:p>
@@ -2833,7 +2833,7 @@
           </a:p>
           <a:p>
             <a:r>
-              <a:t>https://github.com/manikantbindass/CityPulse/blob/723bb901411f84815f48acf1d5e6cef0a51f112d/docs/reports/blockchain-local-demo.json</a:t>
+              <a:t>https://github.com/manikantbindass/CityPulse/blob/370e60164da719fc506bd69c2796fb59823cc4ba/docs/reports/blockchain-local-demo.json</a:t>
             </a:r>
           </a:p>
           <a:p>
@@ -2843,7 +2843,7 @@
           </a:p>
           <a:p>
             <a:r>
-              <a:t>https://github.com/manikantbindass/CityPulse/blob/723bb901411f84815f48acf1d5e6cef0a51f112d/services/api/src/main/java/io/citypulse/workspace/application/ChainReceiptService.java</a:t>
+              <a:t>https://github.com/manikantbindass/CityPulse/blob/370e60164da719fc506bd69c2796fb59823cc4ba/services/api/src/main/java/io/citypulse/workspace/application/ChainReceiptService.java</a:t>
             </a:r>
           </a:p>
         </p:txBody>
@@ -2919,7 +2919,7 @@
           <a:p/>
           <a:p>
             <a:r>
-              <a:t>Application snapshot: 723bb901411f84815f48acf1d5e6cef0a51f112d</a:t>
+              <a:t>Application snapshot: 370e60164da719fc506bd69c2796fb59823cc4ba</a:t>
             </a:r>
           </a:p>
           <a:p>
@@ -2939,7 +2939,7 @@
           </a:p>
           <a:p>
             <a:r>
-              <a:t>https://github.com/manikantbindass/CityPulse/blob/723bb901411f84815f48acf1d5e6cef0a51f112d/docs/security/architecture.md</a:t>
+              <a:t>https://github.com/manikantbindass/CityPulse/blob/370e60164da719fc506bd69c2796fb59823cc4ba/docs/security/architecture.md</a:t>
             </a:r>
           </a:p>
           <a:p>
@@ -2949,7 +2949,7 @@
           </a:p>
           <a:p>
             <a:r>
-              <a:t>https://github.com/manikantbindass/CityPulse/blob/723bb901411f84815f48acf1d5e6cef0a51f112d/docs/security/threat-model.md</a:t>
+              <a:t>https://github.com/manikantbindass/CityPulse/blob/370e60164da719fc506bd69c2796fb59823cc4ba/docs/security/threat-model.md</a:t>
             </a:r>
           </a:p>
         </p:txBody>
@@ -3025,7 +3025,7 @@
           <a:p/>
           <a:p>
             <a:r>
-              <a:t>Application snapshot: 723bb901411f84815f48acf1d5e6cef0a51f112d</a:t>
+              <a:t>Application snapshot: 370e60164da719fc506bd69c2796fb59823cc4ba</a:t>
             </a:r>
           </a:p>
           <a:p>
@@ -3045,7 +3045,7 @@
           </a:p>
           <a:p>
             <a:r>
-              <a:t>https://github.com/manikantbindass/CityPulse/blob/723bb901411f84815f48acf1d5e6cef0a51f112d/infrastructure/terraform/main.tf.json</a:t>
+              <a:t>https://github.com/manikantbindass/CityPulse/blob/370e60164da719fc506bd69c2796fb59823cc4ba/infrastructure/terraform/main.tf.json</a:t>
             </a:r>
           </a:p>
           <a:p>
@@ -3055,7 +3055,7 @@
           </a:p>
           <a:p>
             <a:r>
-              <a:t>https://github.com/manikantbindass/CityPulse/blob/723bb901411f84815f48acf1d5e6cef0a51f112d/docs/operations/deployment.md</a:t>
+              <a:t>https://github.com/manikantbindass/CityPulse/blob/370e60164da719fc506bd69c2796fb59823cc4ba/docs/operations/deployment.md</a:t>
             </a:r>
           </a:p>
         </p:txBody>
@@ -3131,7 +3131,7 @@
           <a:p/>
           <a:p>
             <a:r>
-              <a:t>Application snapshot: 723bb901411f84815f48acf1d5e6cef0a51f112d</a:t>
+              <a:t>Application snapshot: 370e60164da719fc506bd69c2796fb59823cc4ba</a:t>
             </a:r>
           </a:p>
           <a:p>
@@ -3151,7 +3151,7 @@
           </a:p>
           <a:p>
             <a:r>
-              <a:t>https://github.com/manikantbindass/CityPulse/blob/723bb901411f84815f48acf1d5e6cef0a51f112d/docs/operations/scaling.md</a:t>
+              <a:t>https://github.com/manikantbindass/CityPulse/blob/370e60164da719fc506bd69c2796fb59823cc4ba/docs/operations/scaling.md</a:t>
             </a:r>
           </a:p>
           <a:p>
@@ -3161,7 +3161,7 @@
           </a:p>
           <a:p>
             <a:r>
-              <a:t>https://github.com/manikantbindass/CityPulse/blob/723bb901411f84815f48acf1d5e6cef0a51f112d/docs/operations/recovery.md</a:t>
+              <a:t>https://github.com/manikantbindass/CityPulse/blob/370e60164da719fc506bd69c2796fb59823cc4ba/docs/operations/recovery.md</a:t>
             </a:r>
           </a:p>
         </p:txBody>
@@ -3237,7 +3237,7 @@
           <a:p/>
           <a:p>
             <a:r>
-              <a:t>Application snapshot: 723bb901411f84815f48acf1d5e6cef0a51f112d</a:t>
+              <a:t>Application snapshot: 370e60164da719fc506bd69c2796fb59823cc4ba</a:t>
             </a:r>
           </a:p>
           <a:p>
@@ -3257,7 +3257,7 @@
           </a:p>
           <a:p>
             <a:r>
-              <a:t>https://github.com/manikantbindass/CityPulse/blob/723bb901411f84815f48acf1d5e6cef0a51f112d/.github/workflows/ci.yml</a:t>
+              <a:t>https://github.com/manikantbindass/CityPulse/blob/370e60164da719fc506bd69c2796fb59823cc4ba/.github/workflows/ci.yml</a:t>
             </a:r>
           </a:p>
           <a:p>
@@ -3267,7 +3267,7 @@
           </a:p>
           <a:p>
             <a:r>
-              <a:t>https://github.com/manikantbindass/CityPulse/blob/723bb901411f84815f48acf1d5e6cef0a51f112d/.github/workflows/security.yml</a:t>
+              <a:t>https://github.com/manikantbindass/CityPulse/blob/370e60164da719fc506bd69c2796fb59823cc4ba/.github/workflows/security.yml</a:t>
             </a:r>
           </a:p>
           <a:p>
@@ -3277,7 +3277,7 @@
           </a:p>
           <a:p>
             <a:r>
-              <a:t>https://github.com/manikantbindass/CityPulse/blob/723bb901411f84815f48acf1d5e6cef0a51f112d/scripts/monitoring_smoke.py</a:t>
+              <a:t>https://github.com/manikantbindass/CityPulse/blob/370e60164da719fc506bd69c2796fb59823cc4ba/scripts/monitoring_smoke.py</a:t>
             </a:r>
           </a:p>
         </p:txBody>
@@ -3353,7 +3353,7 @@
           <a:p/>
           <a:p>
             <a:r>
-              <a:t>Application snapshot: 723bb901411f84815f48acf1d5e6cef0a51f112d</a:t>
+              <a:t>Application snapshot: 370e60164da719fc506bd69c2796fb59823cc4ba</a:t>
             </a:r>
           </a:p>
           <a:p>
@@ -3378,7 +3378,7 @@
           </a:p>
           <a:p>
             <a:r>
-              <a:t>https://github.com/manikantbindass/CityPulse/blob/723bb901411f84815f48acf1d5e6cef0a51f112d/apps/web/e2e/theme.spec.ts</a:t>
+              <a:t>https://github.com/manikantbindass/CityPulse/blob/370e60164da719fc506bd69c2796fb59823cc4ba/apps/web/e2e/theme.spec.ts</a:t>
             </a:r>
           </a:p>
         </p:txBody>
@@ -3454,7 +3454,7 @@
           <a:p/>
           <a:p>
             <a:r>
-              <a:t>Application snapshot: 723bb901411f84815f48acf1d5e6cef0a51f112d</a:t>
+              <a:t>Application snapshot: 370e60164da719fc506bd69c2796fb59823cc4ba</a:t>
             </a:r>
           </a:p>
           <a:p>
@@ -3474,7 +3474,7 @@
           </a:p>
           <a:p>
             <a:r>
-              <a:t>https://github.com/manikantbindass/CityPulse/blob/723bb901411f84815f48acf1d5e6cef0a51f112d/scripts/smoke.py</a:t>
+              <a:t>https://github.com/manikantbindass/CityPulse/blob/370e60164da719fc506bd69c2796fb59823cc4ba/scripts/smoke.py</a:t>
             </a:r>
           </a:p>
           <a:p>
@@ -3484,7 +3484,7 @@
           </a:p>
           <a:p>
             <a:r>
-              <a:t>https://github.com/manikantbindass/CityPulse/blob/723bb901411f84815f48acf1d5e6cef0a51f112d/docs/decision-engine.md</a:t>
+              <a:t>https://github.com/manikantbindass/CityPulse/blob/370e60164da719fc506bd69c2796fb59823cc4ba/docs/decision-engine.md</a:t>
             </a:r>
           </a:p>
           <a:p>
@@ -3494,7 +3494,7 @@
           </a:p>
           <a:p>
             <a:r>
-              <a:t>https://github.com/manikantbindass/CityPulse/blob/723bb901411f84815f48acf1d5e6cef0a51f112d/docs/pulseai.md</a:t>
+              <a:t>https://github.com/manikantbindass/CityPulse/blob/370e60164da719fc506bd69c2796fb59823cc4ba/docs/pulseai.md</a:t>
             </a:r>
           </a:p>
         </p:txBody>
@@ -3570,7 +3570,7 @@
           <a:p/>
           <a:p>
             <a:r>
-              <a:t>Application snapshot: 723bb901411f84815f48acf1d5e6cef0a51f112d</a:t>
+              <a:t>Application snapshot: 370e60164da719fc506bd69c2796fb59823cc4ba</a:t>
             </a:r>
           </a:p>
           <a:p>
@@ -3590,7 +3590,7 @@
           </a:p>
           <a:p>
             <a:r>
-              <a:t>https://github.com/manikantbindass/CityPulse/blob/723bb901411f84815f48acf1d5e6cef0a51f112d/docs/reports/operations/k6-local-ai.json</a:t>
+              <a:t>https://github.com/manikantbindass/CityPulse/blob/370e60164da719fc506bd69c2796fb59823cc4ba/docs/reports/operations/k6-local-ai.json</a:t>
             </a:r>
           </a:p>
           <a:p>
@@ -3600,7 +3600,7 @@
           </a:p>
           <a:p>
             <a:r>
-              <a:t>https://github.com/manikantbindass/CityPulse/blob/723bb901411f84815f48acf1d5e6cef0a51f112d/docs/reports/decision-evaluation.json</a:t>
+              <a:t>https://github.com/manikantbindass/CityPulse/blob/370e60164da719fc506bd69c2796fb59823cc4ba/docs/reports/decision-evaluation.json</a:t>
             </a:r>
           </a:p>
         </p:txBody>
@@ -3676,7 +3676,7 @@
           <a:p/>
           <a:p>
             <a:r>
-              <a:t>Application snapshot: 723bb901411f84815f48acf1d5e6cef0a51f112d</a:t>
+              <a:t>Application snapshot: 370e60164da719fc506bd69c2796fb59823cc4ba</a:t>
             </a:r>
           </a:p>
           <a:p>
@@ -3696,7 +3696,7 @@
           </a:p>
           <a:p>
             <a:r>
-              <a:t>https://github.com/manikantbindass/CityPulse/blob/723bb901411f84815f48acf1d5e6cef0a51f112d/docs/data-dictionary.md</a:t>
+              <a:t>https://github.com/manikantbindass/CityPulse/blob/370e60164da719fc506bd69c2796fb59823cc4ba/docs/data-dictionary.md</a:t>
             </a:r>
           </a:p>
           <a:p>
@@ -3706,7 +3706,7 @@
           </a:p>
           <a:p>
             <a:r>
-              <a:t>https://github.com/manikantbindass/CityPulse/blob/723bb901411f84815f48acf1d5e6cef0a51f112d/services/api/src/main/java/io/citypulse/workspace/application/AnalyticsService.java</a:t>
+              <a:t>https://github.com/manikantbindass/CityPulse/blob/370e60164da719fc506bd69c2796fb59823cc4ba/services/api/src/main/java/io/citypulse/workspace/application/AnalyticsService.java</a:t>
             </a:r>
           </a:p>
         </p:txBody>
@@ -3782,7 +3782,7 @@
           <a:p/>
           <a:p>
             <a:r>
-              <a:t>Application snapshot: 723bb901411f84815f48acf1d5e6cef0a51f112d</a:t>
+              <a:t>Application snapshot: 370e60164da719fc506bd69c2796fb59823cc4ba</a:t>
             </a:r>
           </a:p>
           <a:p>
@@ -3802,7 +3802,7 @@
           </a:p>
           <a:p>
             <a:r>
-              <a:t>https://github.com/manikantbindass/CityPulse/blob/723bb901411f84815f48acf1d5e6cef0a51f112d/docs/api/backend.md</a:t>
+              <a:t>https://github.com/manikantbindass/CityPulse/blob/370e60164da719fc506bd69c2796fb59823cc4ba/docs/api/backend.md</a:t>
             </a:r>
           </a:p>
           <a:p>
@@ -3812,7 +3812,7 @@
           </a:p>
           <a:p>
             <a:r>
-              <a:t>https://github.com/manikantbindass/CityPulse/blob/723bb901411f84815f48acf1d5e6cef0a51f112d/docs/security/verification.md</a:t>
+              <a:t>https://github.com/manikantbindass/CityPulse/blob/370e60164da719fc506bd69c2796fb59823cc4ba/docs/security/verification.md</a:t>
             </a:r>
           </a:p>
           <a:p>
@@ -3822,7 +3822,7 @@
           </a:p>
           <a:p>
             <a:r>
-              <a:t>https://github.com/manikantbindass/CityPulse/blob/723bb901411f84815f48acf1d5e6cef0a51f112d/docs/operations/scaling.md</a:t>
+              <a:t>https://github.com/manikantbindass/CityPulse/blob/370e60164da719fc506bd69c2796fb59823cc4ba/docs/operations/scaling.md</a:t>
             </a:r>
           </a:p>
         </p:txBody>
@@ -3898,7 +3898,7 @@
           <a:p/>
           <a:p>
             <a:r>
-              <a:t>Application snapshot: 723bb901411f84815f48acf1d5e6cef0a51f112d</a:t>
+              <a:t>Application snapshot: 370e60164da719fc506bd69c2796fb59823cc4ba</a:t>
             </a:r>
           </a:p>
           <a:p>
@@ -3918,7 +3918,7 @@
           </a:p>
           <a:p>
             <a:r>
-              <a:t>https://github.com/manikantbindass/CityPulse/blob/723bb901411f84815f48acf1d5e6cef0a51f112d/README.md</a:t>
+              <a:t>https://github.com/manikantbindass/CityPulse/blob/370e60164da719fc506bd69c2796fb59823cc4ba/README.md</a:t>
             </a:r>
           </a:p>
           <a:p>
@@ -3928,7 +3928,7 @@
           </a:p>
           <a:p>
             <a:r>
-              <a:t>https://github.com/manikantbindass/CityPulse/blob/723bb901411f84815f48acf1d5e6cef0a51f112d/docs/operations/scaling.md</a:t>
+              <a:t>https://github.com/manikantbindass/CityPulse/blob/370e60164da719fc506bd69c2796fb59823cc4ba/docs/operations/scaling.md</a:t>
             </a:r>
           </a:p>
           <a:p>
@@ -3938,7 +3938,7 @@
           </a:p>
           <a:p>
             <a:r>
-              <a:t>https://github.com/manikantbindass/CityPulse/blob/723bb901411f84815f48acf1d5e6cef0a51f112d/docs/model-card.md</a:t>
+              <a:t>https://github.com/manikantbindass/CityPulse/blob/370e60164da719fc506bd69c2796fb59823cc4ba/docs/model-card.md</a:t>
             </a:r>
           </a:p>
         </p:txBody>
@@ -4014,7 +4014,7 @@
           <a:p/>
           <a:p>
             <a:r>
-              <a:t>Application snapshot: 723bb901411f84815f48acf1d5e6cef0a51f112d</a:t>
+              <a:t>Application snapshot: 370e60164da719fc506bd69c2796fb59823cc4ba</a:t>
             </a:r>
           </a:p>
           <a:p>
@@ -4039,7 +4039,7 @@
           </a:p>
           <a:p>
             <a:r>
-              <a:t>https://github.com/manikantbindass/CityPulse/blob/723bb901411f84815f48acf1d5e6cef0a51f112d/README.md</a:t>
+              <a:t>https://github.com/manikantbindass/CityPulse/blob/370e60164da719fc506bd69c2796fb59823cc4ba/README.md</a:t>
             </a:r>
           </a:p>
         </p:txBody>
@@ -4115,7 +4115,7 @@
           <a:p/>
           <a:p>
             <a:r>
-              <a:t>Application snapshot: 723bb901411f84815f48acf1d5e6cef0a51f112d</a:t>
+              <a:t>Application snapshot: 370e60164da719fc506bd69c2796fb59823cc4ba</a:t>
             </a:r>
           </a:p>
           <a:p>
@@ -4135,7 +4135,7 @@
           </a:p>
           <a:p>
             <a:r>
-              <a:t>https://github.com/manikantbindass/CityPulse/blob/723bb901411f84815f48acf1d5e6cef0a51f112d/README.md</a:t>
+              <a:t>https://github.com/manikantbindass/CityPulse/blob/370e60164da719fc506bd69c2796fb59823cc4ba/README.md</a:t>
             </a:r>
           </a:p>
         </p:txBody>
@@ -4211,7 +4211,7 @@
           <a:p/>
           <a:p>
             <a:r>
-              <a:t>Application snapshot: 723bb901411f84815f48acf1d5e6cef0a51f112d</a:t>
+              <a:t>Application snapshot: 370e60164da719fc506bd69c2796fb59823cc4ba</a:t>
             </a:r>
           </a:p>
           <a:p>
@@ -4302,7 +4302,7 @@
           <a:p/>
           <a:p>
             <a:r>
-              <a:t>Application snapshot: 723bb901411f84815f48acf1d5e6cef0a51f112d</a:t>
+              <a:t>Application snapshot: 370e60164da719fc506bd69c2796fb59823cc4ba</a:t>
             </a:r>
           </a:p>
           <a:p>
@@ -4322,7 +4322,7 @@
           </a:p>
           <a:p>
             <a:r>
-              <a:t>https://github.com/manikantbindass/CityPulse/blob/723bb901411f84815f48acf1d5e6cef0a51f112d/README.md</a:t>
+              <a:t>https://github.com/manikantbindass/CityPulse/blob/370e60164da719fc506bd69c2796fb59823cc4ba/README.md</a:t>
             </a:r>
           </a:p>
           <a:p>
@@ -4332,7 +4332,7 @@
           </a:p>
           <a:p>
             <a:r>
-              <a:t>https://github.com/manikantbindass/CityPulse/blob/723bb901411f84815f48acf1d5e6cef0a51f112d/docs/decision-engine.md</a:t>
+              <a:t>https://github.com/manikantbindass/CityPulse/blob/370e60164da719fc506bd69c2796fb59823cc4ba/docs/decision-engine.md</a:t>
             </a:r>
           </a:p>
         </p:txBody>
@@ -4408,7 +4408,7 @@
           <a:p/>
           <a:p>
             <a:r>
-              <a:t>Application snapshot: 723bb901411f84815f48acf1d5e6cef0a51f112d</a:t>
+              <a:t>Application snapshot: 370e60164da719fc506bd69c2796fb59823cc4ba</a:t>
             </a:r>
           </a:p>
           <a:p>
@@ -4428,7 +4428,7 @@
           </a:p>
           <a:p>
             <a:r>
-              <a:t>https://github.com/manikantbindass/CityPulse/blob/723bb901411f84815f48acf1d5e6cef0a51f112d/docs/PRD.md</a:t>
+              <a:t>https://github.com/manikantbindass/CityPulse/blob/370e60164da719fc506bd69c2796fb59823cc4ba/docs/PRD.md</a:t>
             </a:r>
           </a:p>
           <a:p>
@@ -4509,7 +4509,7 @@
           <a:p/>
           <a:p>
             <a:r>
-              <a:t>Application snapshot: 723bb901411f84815f48acf1d5e6cef0a51f112d</a:t>
+              <a:t>Application snapshot: 370e60164da719fc506bd69c2796fb59823cc4ba</a:t>
             </a:r>
           </a:p>
           <a:p>
@@ -4529,7 +4529,7 @@
           </a:p>
           <a:p>
             <a:r>
-              <a:t>https://github.com/manikantbindass/CityPulse/blob/723bb901411f84815f48acf1d5e6cef0a51f112d/docs/api/backend.md</a:t>
+              <a:t>https://github.com/manikantbindass/CityPulse/blob/370e60164da719fc506bd69c2796fb59823cc4ba/docs/api/backend.md</a:t>
             </a:r>
           </a:p>
           <a:p>
@@ -4539,7 +4539,7 @@
           </a:p>
           <a:p>
             <a:r>
-              <a:t>https://github.com/manikantbindass/CityPulse/blob/723bb901411f84815f48acf1d5e6cef0a51f112d/docs/security/architecture.md</a:t>
+              <a:t>https://github.com/manikantbindass/CityPulse/blob/370e60164da719fc506bd69c2796fb59823cc4ba/docs/security/architecture.md</a:t>
             </a:r>
           </a:p>
         </p:txBody>
@@ -4615,7 +4615,7 @@
           <a:p/>
           <a:p>
             <a:r>
-              <a:t>Application snapshot: 723bb901411f84815f48acf1d5e6cef0a51f112d</a:t>
+              <a:t>Application snapshot: 370e60164da719fc506bd69c2796fb59823cc4ba</a:t>
             </a:r>
           </a:p>
           <a:p>
@@ -4635,7 +4635,7 @@
           </a:p>
           <a:p>
             <a:r>
-              <a:t>https://github.com/manikantbindass/CityPulse/blob/723bb901411f84815f48acf1d5e6cef0a51f112d/README.md</a:t>
+              <a:t>https://github.com/manikantbindass/CityPulse/blob/370e60164da719fc506bd69c2796fb59823cc4ba/README.md</a:t>
             </a:r>
           </a:p>
           <a:p>
@@ -4645,7 +4645,7 @@
           </a:p>
           <a:p>
             <a:r>
-              <a:t>https://github.com/manikantbindass/CityPulse/blob/723bb901411f84815f48acf1d5e6cef0a51f112d/docs/decision-engine.md</a:t>
+              <a:t>https://github.com/manikantbindass/CityPulse/blob/370e60164da719fc506bd69c2796fb59823cc4ba/docs/decision-engine.md</a:t>
             </a:r>
           </a:p>
         </p:txBody>
@@ -4721,7 +4721,7 @@
           <a:p/>
           <a:p>
             <a:r>
-              <a:t>Application snapshot: 723bb901411f84815f48acf1d5e6cef0a51f112d</a:t>
+              <a:t>Application snapshot: 370e60164da719fc506bd69c2796fb59823cc4ba</a:t>
             </a:r>
           </a:p>
           <a:p>
@@ -4741,7 +4741,7 @@
           </a:p>
           <a:p>
             <a:r>
-              <a:t>https://github.com/manikantbindass/CityPulse/blob/723bb901411f84815f48acf1d5e6cef0a51f112d/docs/assets/readme-provenance.json</a:t>
+              <a:t>https://github.com/manikantbindass/CityPulse/blob/370e60164da719fc506bd69c2796fb59823cc4ba/docs/assets/readme-provenance.json</a:t>
             </a:r>
           </a:p>
         </p:txBody>

</xml_diff>

<commit_message>
docs: include verified RPC release evidence
</commit_message>
<xml_diff>
--- a/docs/presentations/CityPulse-Project-Presentation.pptx
+++ b/docs/presentations/CityPulse-Project-Presentation.pptx
@@ -1334,7 +1334,7 @@
           <a:p/>
           <a:p>
             <a:r>
-              <a:t>Application snapshot: 370e60164da719fc506bd69c2796fb59823cc4ba</a:t>
+              <a:t>Application snapshot: dd387635e3c19ef8eca2369db67ac2cf4a0523c8</a:t>
             </a:r>
           </a:p>
           <a:p>
@@ -1354,7 +1354,7 @@
           </a:p>
           <a:p>
             <a:r>
-              <a:t>https://github.com/manikantbindass/CityPulse/blob/370e60164da719fc506bd69c2796fb59823cc4ba/README.md</a:t>
+              <a:t>https://github.com/manikantbindass/CityPulse/blob/dd387635e3c19ef8eca2369db67ac2cf4a0523c8/README.md</a:t>
             </a:r>
           </a:p>
           <a:p>
@@ -1435,7 +1435,7 @@
           <a:p/>
           <a:p>
             <a:r>
-              <a:t>Application snapshot: 370e60164da719fc506bd69c2796fb59823cc4ba</a:t>
+              <a:t>Application snapshot: dd387635e3c19ef8eca2369db67ac2cf4a0523c8</a:t>
             </a:r>
           </a:p>
           <a:p>
@@ -1455,7 +1455,7 @@
           </a:p>
           <a:p>
             <a:r>
-              <a:t>https://github.com/manikantbindass/CityPulse/blob/370e60164da719fc506bd69c2796fb59823cc4ba/apps/web/package.json</a:t>
+              <a:t>https://github.com/manikantbindass/CityPulse/blob/dd387635e3c19ef8eca2369db67ac2cf4a0523c8/apps/web/package.json</a:t>
             </a:r>
           </a:p>
           <a:p>
@@ -1465,7 +1465,7 @@
           </a:p>
           <a:p>
             <a:r>
-              <a:t>https://github.com/manikantbindass/CityPulse/blob/370e60164da719fc506bd69c2796fb59823cc4ba/services/api/pom.xml</a:t>
+              <a:t>https://github.com/manikantbindass/CityPulse/blob/dd387635e3c19ef8eca2369db67ac2cf4a0523c8/services/api/pom.xml</a:t>
             </a:r>
           </a:p>
           <a:p>
@@ -1475,7 +1475,7 @@
           </a:p>
           <a:p>
             <a:r>
-              <a:t>https://github.com/manikantbindass/CityPulse/blob/370e60164da719fc506bd69c2796fb59823cc4ba/services/ai-engine/pyproject.toml</a:t>
+              <a:t>https://github.com/manikantbindass/CityPulse/blob/dd387635e3c19ef8eca2369db67ac2cf4a0523c8/services/ai-engine/pyproject.toml</a:t>
             </a:r>
           </a:p>
         </p:txBody>
@@ -1551,7 +1551,7 @@
           <a:p/>
           <a:p>
             <a:r>
-              <a:t>Application snapshot: 370e60164da719fc506bd69c2796fb59823cc4ba</a:t>
+              <a:t>Application snapshot: dd387635e3c19ef8eca2369db67ac2cf4a0523c8</a:t>
             </a:r>
           </a:p>
           <a:p>
@@ -1576,7 +1576,7 @@
           </a:p>
           <a:p>
             <a:r>
-              <a:t>https://github.com/manikantbindass/CityPulse/blob/370e60164da719fc506bd69c2796fb59823cc4ba/compose.yaml</a:t>
+              <a:t>https://github.com/manikantbindass/CityPulse/blob/dd387635e3c19ef8eca2369db67ac2cf4a0523c8/compose.yaml</a:t>
             </a:r>
           </a:p>
         </p:txBody>
@@ -1652,7 +1652,7 @@
           <a:p/>
           <a:p>
             <a:r>
-              <a:t>Application snapshot: 370e60164da719fc506bd69c2796fb59823cc4ba</a:t>
+              <a:t>Application snapshot: dd387635e3c19ef8eca2369db67ac2cf4a0523c8</a:t>
             </a:r>
           </a:p>
           <a:p>
@@ -1672,7 +1672,7 @@
           </a:p>
           <a:p>
             <a:r>
-              <a:t>https://github.com/manikantbindass/CityPulse/blob/370e60164da719fc506bd69c2796fb59823cc4ba/apps/web/components/providers.tsx</a:t>
+              <a:t>https://github.com/manikantbindass/CityPulse/blob/dd387635e3c19ef8eca2369db67ac2cf4a0523c8/apps/web/components/providers.tsx</a:t>
             </a:r>
           </a:p>
           <a:p>
@@ -1682,7 +1682,7 @@
           </a:p>
           <a:p>
             <a:r>
-              <a:t>https://github.com/manikantbindass/CityPulse/blob/370e60164da719fc506bd69c2796fb59823cc4ba/apps/web/e2e/theme.spec.ts</a:t>
+              <a:t>https://github.com/manikantbindass/CityPulse/blob/dd387635e3c19ef8eca2369db67ac2cf4a0523c8/apps/web/e2e/theme.spec.ts</a:t>
             </a:r>
           </a:p>
         </p:txBody>
@@ -1758,7 +1758,7 @@
           <a:p/>
           <a:p>
             <a:r>
-              <a:t>Application snapshot: 370e60164da719fc506bd69c2796fb59823cc4ba</a:t>
+              <a:t>Application snapshot: dd387635e3c19ef8eca2369db67ac2cf4a0523c8</a:t>
             </a:r>
           </a:p>
           <a:p>
@@ -1778,7 +1778,7 @@
           </a:p>
           <a:p>
             <a:r>
-              <a:t>https://github.com/manikantbindass/CityPulse/blob/370e60164da719fc506bd69c2796fb59823cc4ba/services/api/src/main/java/io/citypulse/identity/MembershipFilter.java</a:t>
+              <a:t>https://github.com/manikantbindass/CityPulse/blob/dd387635e3c19ef8eca2369db67ac2cf4a0523c8/services/api/src/main/java/io/citypulse/identity/MembershipFilter.java</a:t>
             </a:r>
           </a:p>
           <a:p>
@@ -1788,7 +1788,7 @@
           </a:p>
           <a:p>
             <a:r>
-              <a:t>https://github.com/manikantbindass/CityPulse/blob/370e60164da719fc506bd69c2796fb59823cc4ba/docs/api/backend.md</a:t>
+              <a:t>https://github.com/manikantbindass/CityPulse/blob/dd387635e3c19ef8eca2369db67ac2cf4a0523c8/docs/api/backend.md</a:t>
             </a:r>
           </a:p>
         </p:txBody>
@@ -1864,7 +1864,7 @@
           <a:p/>
           <a:p>
             <a:r>
-              <a:t>Application snapshot: 370e60164da719fc506bd69c2796fb59823cc4ba</a:t>
+              <a:t>Application snapshot: dd387635e3c19ef8eca2369db67ac2cf4a0523c8</a:t>
             </a:r>
           </a:p>
           <a:p>
@@ -1884,7 +1884,7 @@
           </a:p>
           <a:p>
             <a:r>
-              <a:t>https://github.com/manikantbindass/CityPulse/blob/370e60164da719fc506bd69c2796fb59823cc4ba/services/api/src/main/resources/db/migration/V1__canonical_geospatial_schema.sql</a:t>
+              <a:t>https://github.com/manikantbindass/CityPulse/blob/dd387635e3c19ef8eca2369db67ac2cf4a0523c8/services/api/src/main/resources/db/migration/V1__canonical_geospatial_schema.sql</a:t>
             </a:r>
           </a:p>
           <a:p>
@@ -1894,7 +1894,7 @@
           </a:p>
           <a:p>
             <a:r>
-              <a:t>https://github.com/manikantbindass/CityPulse/blob/370e60164da719fc506bd69c2796fb59823cc4ba/services/api/src/main/resources/db/migration/V2__tenant_operations.sql</a:t>
+              <a:t>https://github.com/manikantbindass/CityPulse/blob/dd387635e3c19ef8eca2369db67ac2cf4a0523c8/services/api/src/main/resources/db/migration/V2__tenant_operations.sql</a:t>
             </a:r>
           </a:p>
         </p:txBody>
@@ -1970,7 +1970,7 @@
           <a:p/>
           <a:p>
             <a:r>
-              <a:t>Application snapshot: 370e60164da719fc506bd69c2796fb59823cc4ba</a:t>
+              <a:t>Application snapshot: dd387635e3c19ef8eca2369db67ac2cf4a0523c8</a:t>
             </a:r>
           </a:p>
           <a:p>
@@ -1990,7 +1990,7 @@
           </a:p>
           <a:p>
             <a:r>
-              <a:t>https://github.com/manikantbindass/CityPulse/blob/370e60164da719fc506bd69c2796fb59823cc4ba/services/ingestion/citypulse_ingestion/pipeline.py</a:t>
+              <a:t>https://github.com/manikantbindass/CityPulse/blob/dd387635e3c19ef8eca2369db67ac2cf4a0523c8/services/ingestion/citypulse_ingestion/pipeline.py</a:t>
             </a:r>
           </a:p>
           <a:p>
@@ -2000,7 +2000,7 @@
           </a:p>
           <a:p>
             <a:r>
-              <a:t>https://github.com/manikantbindass/CityPulse/blob/370e60164da719fc506bd69c2796fb59823cc4ba/scripts/data_pipeline.py</a:t>
+              <a:t>https://github.com/manikantbindass/CityPulse/blob/dd387635e3c19ef8eca2369db67ac2cf4a0523c8/scripts/data_pipeline.py</a:t>
             </a:r>
           </a:p>
         </p:txBody>
@@ -2076,7 +2076,7 @@
           <a:p/>
           <a:p>
             <a:r>
-              <a:t>Application snapshot: 370e60164da719fc506bd69c2796fb59823cc4ba</a:t>
+              <a:t>Application snapshot: dd387635e3c19ef8eca2369db67ac2cf4a0523c8</a:t>
             </a:r>
           </a:p>
           <a:p>
@@ -2096,7 +2096,7 @@
           </a:p>
           <a:p>
             <a:r>
-              <a:t>https://github.com/manikantbindass/CityPulse/blob/370e60164da719fc506bd69c2796fb59823cc4ba/services/ai-engine/citypulse_ai/modeling.py</a:t>
+              <a:t>https://github.com/manikantbindass/CityPulse/blob/dd387635e3c19ef8eca2369db67ac2cf4a0523c8/services/ai-engine/citypulse_ai/modeling.py</a:t>
             </a:r>
           </a:p>
           <a:p>
@@ -2106,7 +2106,7 @@
           </a:p>
           <a:p>
             <a:r>
-              <a:t>https://github.com/manikantbindass/CityPulse/blob/370e60164da719fc506bd69c2796fb59823cc4ba/docs/reports/model-evaluation.json</a:t>
+              <a:t>https://github.com/manikantbindass/CityPulse/blob/dd387635e3c19ef8eca2369db67ac2cf4a0523c8/docs/reports/model-evaluation.json</a:t>
             </a:r>
           </a:p>
         </p:txBody>
@@ -2182,7 +2182,7 @@
           <a:p/>
           <a:p>
             <a:r>
-              <a:t>Application snapshot: 370e60164da719fc506bd69c2796fb59823cc4ba</a:t>
+              <a:t>Application snapshot: dd387635e3c19ef8eca2369db67ac2cf4a0523c8</a:t>
             </a:r>
           </a:p>
           <a:p>
@@ -2202,7 +2202,7 @@
           </a:p>
           <a:p>
             <a:r>
-              <a:t>https://github.com/manikantbindass/CityPulse/blob/370e60164da719fc506bd69c2796fb59823cc4ba/docs/reports/model-evaluation.json</a:t>
+              <a:t>https://github.com/manikantbindass/CityPulse/blob/dd387635e3c19ef8eca2369db67ac2cf4a0523c8/docs/reports/model-evaluation.json</a:t>
             </a:r>
           </a:p>
           <a:p>
@@ -2212,7 +2212,7 @@
           </a:p>
           <a:p>
             <a:r>
-              <a:t>https://github.com/manikantbindass/CityPulse/blob/370e60164da719fc506bd69c2796fb59823cc4ba/docs/model-card.md</a:t>
+              <a:t>https://github.com/manikantbindass/CityPulse/blob/dd387635e3c19ef8eca2369db67ac2cf4a0523c8/docs/model-card.md</a:t>
             </a:r>
           </a:p>
         </p:txBody>
@@ -2288,7 +2288,7 @@
           <a:p/>
           <a:p>
             <a:r>
-              <a:t>Application snapshot: 370e60164da719fc506bd69c2796fb59823cc4ba</a:t>
+              <a:t>Application snapshot: dd387635e3c19ef8eca2369db67ac2cf4a0523c8</a:t>
             </a:r>
           </a:p>
           <a:p>
@@ -2313,7 +2313,7 @@
           </a:p>
           <a:p>
             <a:r>
-              <a:t>https://github.com/manikantbindass/CityPulse/blob/370e60164da719fc506bd69c2796fb59823cc4ba/docs/model-card.md</a:t>
+              <a:t>https://github.com/manikantbindass/CityPulse/blob/dd387635e3c19ef8eca2369db67ac2cf4a0523c8/docs/model-card.md</a:t>
             </a:r>
           </a:p>
         </p:txBody>
@@ -2389,7 +2389,7 @@
           <a:p/>
           <a:p>
             <a:r>
-              <a:t>Application snapshot: 370e60164da719fc506bd69c2796fb59823cc4ba</a:t>
+              <a:t>Application snapshot: dd387635e3c19ef8eca2369db67ac2cf4a0523c8</a:t>
             </a:r>
           </a:p>
           <a:p>
@@ -2409,7 +2409,7 @@
           </a:p>
           <a:p>
             <a:r>
-              <a:t>https://github.com/manikantbindass/CityPulse/blob/370e60164da719fc506bd69c2796fb59823cc4ba/docs/reports/decision-evaluation.json</a:t>
+              <a:t>https://github.com/manikantbindass/CityPulse/blob/dd387635e3c19ef8eca2369db67ac2cf4a0523c8/docs/reports/decision-evaluation.json</a:t>
             </a:r>
           </a:p>
           <a:p>
@@ -2419,7 +2419,7 @@
           </a:p>
           <a:p>
             <a:r>
-              <a:t>https://github.com/manikantbindass/CityPulse/blob/370e60164da719fc506bd69c2796fb59823cc4ba/services/ai-engine/citypulse_ai/decisions.py</a:t>
+              <a:t>https://github.com/manikantbindass/CityPulse/blob/dd387635e3c19ef8eca2369db67ac2cf4a0523c8/services/ai-engine/citypulse_ai/decisions.py</a:t>
             </a:r>
           </a:p>
         </p:txBody>
@@ -2495,7 +2495,7 @@
           <a:p/>
           <a:p>
             <a:r>
-              <a:t>Application snapshot: 370e60164da719fc506bd69c2796fb59823cc4ba</a:t>
+              <a:t>Application snapshot: dd387635e3c19ef8eca2369db67ac2cf4a0523c8</a:t>
             </a:r>
           </a:p>
           <a:p>
@@ -2515,7 +2515,7 @@
           </a:p>
           <a:p>
             <a:r>
-              <a:t>https://github.com/manikantbindass/CityPulse/blob/370e60164da719fc506bd69c2796fb59823cc4ba/README.md</a:t>
+              <a:t>https://github.com/manikantbindass/CityPulse/blob/dd387635e3c19ef8eca2369db67ac2cf4a0523c8/README.md</a:t>
             </a:r>
           </a:p>
           <a:p>
@@ -2525,7 +2525,7 @@
           </a:p>
           <a:p>
             <a:r>
-              <a:t>https://github.com/manikantbindass/CityPulse/blob/370e60164da719fc506bd69c2796fb59823cc4ba/compose.yaml</a:t>
+              <a:t>https://github.com/manikantbindass/CityPulse/blob/dd387635e3c19ef8eca2369db67ac2cf4a0523c8/compose.yaml</a:t>
             </a:r>
           </a:p>
         </p:txBody>
@@ -2601,7 +2601,7 @@
           <a:p/>
           <a:p>
             <a:r>
-              <a:t>Application snapshot: 370e60164da719fc506bd69c2796fb59823cc4ba</a:t>
+              <a:t>Application snapshot: dd387635e3c19ef8eca2369db67ac2cf4a0523c8</a:t>
             </a:r>
           </a:p>
           <a:p>
@@ -2621,7 +2621,7 @@
           </a:p>
           <a:p>
             <a:r>
-              <a:t>https://github.com/manikantbindass/CityPulse/blob/370e60164da719fc506bd69c2796fb59823cc4ba/services/api/src/main/java/io/citypulse/pulseai/PulseAiService.java</a:t>
+              <a:t>https://github.com/manikantbindass/CityPulse/blob/dd387635e3c19ef8eca2369db67ac2cf4a0523c8/services/api/src/main/java/io/citypulse/pulseai/PulseAiService.java</a:t>
             </a:r>
           </a:p>
           <a:p>
@@ -2631,7 +2631,7 @@
           </a:p>
           <a:p>
             <a:r>
-              <a:t>https://github.com/manikantbindass/CityPulse/blob/370e60164da719fc506bd69c2796fb59823cc4ba/services/ai-engine/citypulse_ai/pulseai.py</a:t>
+              <a:t>https://github.com/manikantbindass/CityPulse/blob/dd387635e3c19ef8eca2369db67ac2cf4a0523c8/services/ai-engine/citypulse_ai/pulseai.py</a:t>
             </a:r>
           </a:p>
         </p:txBody>
@@ -2707,7 +2707,7 @@
           <a:p/>
           <a:p>
             <a:r>
-              <a:t>Application snapshot: 370e60164da719fc506bd69c2796fb59823cc4ba</a:t>
+              <a:t>Application snapshot: dd387635e3c19ef8eca2369db67ac2cf4a0523c8</a:t>
             </a:r>
           </a:p>
           <a:p>
@@ -2727,7 +2727,7 @@
           </a:p>
           <a:p>
             <a:r>
-              <a:t>https://github.com/manikantbindass/CityPulse/blob/370e60164da719fc506bd69c2796fb59823cc4ba/docs/blockchain.md</a:t>
+              <a:t>https://github.com/manikantbindass/CityPulse/blob/dd387635e3c19ef8eca2369db67ac2cf4a0523c8/docs/blockchain.md</a:t>
             </a:r>
           </a:p>
           <a:p>
@@ -2737,7 +2737,7 @@
           </a:p>
           <a:p>
             <a:r>
-              <a:t>https://github.com/manikantbindass/CityPulse/blob/370e60164da719fc506bd69c2796fb59823cc4ba/blockchain/contracts/DatasetAttestationRegistry.sol</a:t>
+              <a:t>https://github.com/manikantbindass/CityPulse/blob/dd387635e3c19ef8eca2369db67ac2cf4a0523c8/blockchain/contracts/DatasetAttestationRegistry.sol</a:t>
             </a:r>
           </a:p>
         </p:txBody>
@@ -2813,7 +2813,7 @@
           <a:p/>
           <a:p>
             <a:r>
-              <a:t>Application snapshot: 370e60164da719fc506bd69c2796fb59823cc4ba</a:t>
+              <a:t>Application snapshot: dd387635e3c19ef8eca2369db67ac2cf4a0523c8</a:t>
             </a:r>
           </a:p>
           <a:p>
@@ -2833,7 +2833,7 @@
           </a:p>
           <a:p>
             <a:r>
-              <a:t>https://github.com/manikantbindass/CityPulse/blob/370e60164da719fc506bd69c2796fb59823cc4ba/docs/reports/blockchain-local-demo.json</a:t>
+              <a:t>https://github.com/manikantbindass/CityPulse/blob/dd387635e3c19ef8eca2369db67ac2cf4a0523c8/docs/reports/blockchain-local-demo.json</a:t>
             </a:r>
           </a:p>
           <a:p>
@@ -2843,7 +2843,7 @@
           </a:p>
           <a:p>
             <a:r>
-              <a:t>https://github.com/manikantbindass/CityPulse/blob/370e60164da719fc506bd69c2796fb59823cc4ba/services/api/src/main/java/io/citypulse/workspace/application/ChainReceiptService.java</a:t>
+              <a:t>https://github.com/manikantbindass/CityPulse/blob/dd387635e3c19ef8eca2369db67ac2cf4a0523c8/services/api/src/main/java/io/citypulse/workspace/application/ChainReceiptService.java</a:t>
             </a:r>
           </a:p>
         </p:txBody>
@@ -2919,7 +2919,7 @@
           <a:p/>
           <a:p>
             <a:r>
-              <a:t>Application snapshot: 370e60164da719fc506bd69c2796fb59823cc4ba</a:t>
+              <a:t>Application snapshot: dd387635e3c19ef8eca2369db67ac2cf4a0523c8</a:t>
             </a:r>
           </a:p>
           <a:p>
@@ -2939,7 +2939,7 @@
           </a:p>
           <a:p>
             <a:r>
-              <a:t>https://github.com/manikantbindass/CityPulse/blob/370e60164da719fc506bd69c2796fb59823cc4ba/docs/security/architecture.md</a:t>
+              <a:t>https://github.com/manikantbindass/CityPulse/blob/dd387635e3c19ef8eca2369db67ac2cf4a0523c8/docs/security/architecture.md</a:t>
             </a:r>
           </a:p>
           <a:p>
@@ -2949,7 +2949,7 @@
           </a:p>
           <a:p>
             <a:r>
-              <a:t>https://github.com/manikantbindass/CityPulse/blob/370e60164da719fc506bd69c2796fb59823cc4ba/docs/security/threat-model.md</a:t>
+              <a:t>https://github.com/manikantbindass/CityPulse/blob/dd387635e3c19ef8eca2369db67ac2cf4a0523c8/docs/security/threat-model.md</a:t>
             </a:r>
           </a:p>
         </p:txBody>
@@ -3025,7 +3025,7 @@
           <a:p/>
           <a:p>
             <a:r>
-              <a:t>Application snapshot: 370e60164da719fc506bd69c2796fb59823cc4ba</a:t>
+              <a:t>Application snapshot: dd387635e3c19ef8eca2369db67ac2cf4a0523c8</a:t>
             </a:r>
           </a:p>
           <a:p>
@@ -3045,7 +3045,7 @@
           </a:p>
           <a:p>
             <a:r>
-              <a:t>https://github.com/manikantbindass/CityPulse/blob/370e60164da719fc506bd69c2796fb59823cc4ba/infrastructure/terraform/main.tf.json</a:t>
+              <a:t>https://github.com/manikantbindass/CityPulse/blob/dd387635e3c19ef8eca2369db67ac2cf4a0523c8/infrastructure/terraform/main.tf.json</a:t>
             </a:r>
           </a:p>
           <a:p>
@@ -3055,7 +3055,7 @@
           </a:p>
           <a:p>
             <a:r>
-              <a:t>https://github.com/manikantbindass/CityPulse/blob/370e60164da719fc506bd69c2796fb59823cc4ba/docs/operations/deployment.md</a:t>
+              <a:t>https://github.com/manikantbindass/CityPulse/blob/dd387635e3c19ef8eca2369db67ac2cf4a0523c8/docs/operations/deployment.md</a:t>
             </a:r>
           </a:p>
         </p:txBody>
@@ -3131,7 +3131,7 @@
           <a:p/>
           <a:p>
             <a:r>
-              <a:t>Application snapshot: 370e60164da719fc506bd69c2796fb59823cc4ba</a:t>
+              <a:t>Application snapshot: dd387635e3c19ef8eca2369db67ac2cf4a0523c8</a:t>
             </a:r>
           </a:p>
           <a:p>
@@ -3151,7 +3151,7 @@
           </a:p>
           <a:p>
             <a:r>
-              <a:t>https://github.com/manikantbindass/CityPulse/blob/370e60164da719fc506bd69c2796fb59823cc4ba/docs/operations/scaling.md</a:t>
+              <a:t>https://github.com/manikantbindass/CityPulse/blob/dd387635e3c19ef8eca2369db67ac2cf4a0523c8/docs/operations/scaling.md</a:t>
             </a:r>
           </a:p>
           <a:p>
@@ -3161,7 +3161,7 @@
           </a:p>
           <a:p>
             <a:r>
-              <a:t>https://github.com/manikantbindass/CityPulse/blob/370e60164da719fc506bd69c2796fb59823cc4ba/docs/operations/recovery.md</a:t>
+              <a:t>https://github.com/manikantbindass/CityPulse/blob/dd387635e3c19ef8eca2369db67ac2cf4a0523c8/docs/operations/recovery.md</a:t>
             </a:r>
           </a:p>
         </p:txBody>
@@ -3237,7 +3237,7 @@
           <a:p/>
           <a:p>
             <a:r>
-              <a:t>Application snapshot: 370e60164da719fc506bd69c2796fb59823cc4ba</a:t>
+              <a:t>Application snapshot: dd387635e3c19ef8eca2369db67ac2cf4a0523c8</a:t>
             </a:r>
           </a:p>
           <a:p>
@@ -3257,7 +3257,7 @@
           </a:p>
           <a:p>
             <a:r>
-              <a:t>https://github.com/manikantbindass/CityPulse/blob/370e60164da719fc506bd69c2796fb59823cc4ba/.github/workflows/ci.yml</a:t>
+              <a:t>https://github.com/manikantbindass/CityPulse/blob/dd387635e3c19ef8eca2369db67ac2cf4a0523c8/.github/workflows/ci.yml</a:t>
             </a:r>
           </a:p>
           <a:p>
@@ -3267,7 +3267,7 @@
           </a:p>
           <a:p>
             <a:r>
-              <a:t>https://github.com/manikantbindass/CityPulse/blob/370e60164da719fc506bd69c2796fb59823cc4ba/.github/workflows/security.yml</a:t>
+              <a:t>https://github.com/manikantbindass/CityPulse/blob/dd387635e3c19ef8eca2369db67ac2cf4a0523c8/.github/workflows/security.yml</a:t>
             </a:r>
           </a:p>
           <a:p>
@@ -3277,7 +3277,7 @@
           </a:p>
           <a:p>
             <a:r>
-              <a:t>https://github.com/manikantbindass/CityPulse/blob/370e60164da719fc506bd69c2796fb59823cc4ba/scripts/monitoring_smoke.py</a:t>
+              <a:t>https://github.com/manikantbindass/CityPulse/blob/dd387635e3c19ef8eca2369db67ac2cf4a0523c8/scripts/monitoring_smoke.py</a:t>
             </a:r>
           </a:p>
         </p:txBody>
@@ -3353,7 +3353,7 @@
           <a:p/>
           <a:p>
             <a:r>
-              <a:t>Application snapshot: 370e60164da719fc506bd69c2796fb59823cc4ba</a:t>
+              <a:t>Application snapshot: dd387635e3c19ef8eca2369db67ac2cf4a0523c8</a:t>
             </a:r>
           </a:p>
           <a:p>
@@ -3378,7 +3378,7 @@
           </a:p>
           <a:p>
             <a:r>
-              <a:t>https://github.com/manikantbindass/CityPulse/blob/370e60164da719fc506bd69c2796fb59823cc4ba/apps/web/e2e/theme.spec.ts</a:t>
+              <a:t>https://github.com/manikantbindass/CityPulse/blob/dd387635e3c19ef8eca2369db67ac2cf4a0523c8/apps/web/e2e/theme.spec.ts</a:t>
             </a:r>
           </a:p>
         </p:txBody>
@@ -3454,7 +3454,7 @@
           <a:p/>
           <a:p>
             <a:r>
-              <a:t>Application snapshot: 370e60164da719fc506bd69c2796fb59823cc4ba</a:t>
+              <a:t>Application snapshot: dd387635e3c19ef8eca2369db67ac2cf4a0523c8</a:t>
             </a:r>
           </a:p>
           <a:p>
@@ -3474,7 +3474,7 @@
           </a:p>
           <a:p>
             <a:r>
-              <a:t>https://github.com/manikantbindass/CityPulse/blob/370e60164da719fc506bd69c2796fb59823cc4ba/scripts/smoke.py</a:t>
+              <a:t>https://github.com/manikantbindass/CityPulse/blob/dd387635e3c19ef8eca2369db67ac2cf4a0523c8/scripts/smoke.py</a:t>
             </a:r>
           </a:p>
           <a:p>
@@ -3484,7 +3484,7 @@
           </a:p>
           <a:p>
             <a:r>
-              <a:t>https://github.com/manikantbindass/CityPulse/blob/370e60164da719fc506bd69c2796fb59823cc4ba/docs/decision-engine.md</a:t>
+              <a:t>https://github.com/manikantbindass/CityPulse/blob/dd387635e3c19ef8eca2369db67ac2cf4a0523c8/docs/decision-engine.md</a:t>
             </a:r>
           </a:p>
           <a:p>
@@ -3494,7 +3494,7 @@
           </a:p>
           <a:p>
             <a:r>
-              <a:t>https://github.com/manikantbindass/CityPulse/blob/370e60164da719fc506bd69c2796fb59823cc4ba/docs/pulseai.md</a:t>
+              <a:t>https://github.com/manikantbindass/CityPulse/blob/dd387635e3c19ef8eca2369db67ac2cf4a0523c8/docs/pulseai.md</a:t>
             </a:r>
           </a:p>
         </p:txBody>
@@ -3570,7 +3570,7 @@
           <a:p/>
           <a:p>
             <a:r>
-              <a:t>Application snapshot: 370e60164da719fc506bd69c2796fb59823cc4ba</a:t>
+              <a:t>Application snapshot: dd387635e3c19ef8eca2369db67ac2cf4a0523c8</a:t>
             </a:r>
           </a:p>
           <a:p>
@@ -3590,7 +3590,7 @@
           </a:p>
           <a:p>
             <a:r>
-              <a:t>https://github.com/manikantbindass/CityPulse/blob/370e60164da719fc506bd69c2796fb59823cc4ba/docs/reports/operations/k6-local-ai.json</a:t>
+              <a:t>https://github.com/manikantbindass/CityPulse/blob/dd387635e3c19ef8eca2369db67ac2cf4a0523c8/docs/reports/operations/k6-local-ai.json</a:t>
             </a:r>
           </a:p>
           <a:p>
@@ -3600,7 +3600,7 @@
           </a:p>
           <a:p>
             <a:r>
-              <a:t>https://github.com/manikantbindass/CityPulse/blob/370e60164da719fc506bd69c2796fb59823cc4ba/docs/reports/decision-evaluation.json</a:t>
+              <a:t>https://github.com/manikantbindass/CityPulse/blob/dd387635e3c19ef8eca2369db67ac2cf4a0523c8/docs/reports/decision-evaluation.json</a:t>
             </a:r>
           </a:p>
         </p:txBody>
@@ -3676,7 +3676,7 @@
           <a:p/>
           <a:p>
             <a:r>
-              <a:t>Application snapshot: 370e60164da719fc506bd69c2796fb59823cc4ba</a:t>
+              <a:t>Application snapshot: dd387635e3c19ef8eca2369db67ac2cf4a0523c8</a:t>
             </a:r>
           </a:p>
           <a:p>
@@ -3696,7 +3696,7 @@
           </a:p>
           <a:p>
             <a:r>
-              <a:t>https://github.com/manikantbindass/CityPulse/blob/370e60164da719fc506bd69c2796fb59823cc4ba/docs/data-dictionary.md</a:t>
+              <a:t>https://github.com/manikantbindass/CityPulse/blob/dd387635e3c19ef8eca2369db67ac2cf4a0523c8/docs/data-dictionary.md</a:t>
             </a:r>
           </a:p>
           <a:p>
@@ -3706,7 +3706,7 @@
           </a:p>
           <a:p>
             <a:r>
-              <a:t>https://github.com/manikantbindass/CityPulse/blob/370e60164da719fc506bd69c2796fb59823cc4ba/services/api/src/main/java/io/citypulse/workspace/application/AnalyticsService.java</a:t>
+              <a:t>https://github.com/manikantbindass/CityPulse/blob/dd387635e3c19ef8eca2369db67ac2cf4a0523c8/services/api/src/main/java/io/citypulse/workspace/application/AnalyticsService.java</a:t>
             </a:r>
           </a:p>
         </p:txBody>
@@ -3782,7 +3782,7 @@
           <a:p/>
           <a:p>
             <a:r>
-              <a:t>Application snapshot: 370e60164da719fc506bd69c2796fb59823cc4ba</a:t>
+              <a:t>Application snapshot: dd387635e3c19ef8eca2369db67ac2cf4a0523c8</a:t>
             </a:r>
           </a:p>
           <a:p>
@@ -3802,7 +3802,7 @@
           </a:p>
           <a:p>
             <a:r>
-              <a:t>https://github.com/manikantbindass/CityPulse/blob/370e60164da719fc506bd69c2796fb59823cc4ba/docs/api/backend.md</a:t>
+              <a:t>https://github.com/manikantbindass/CityPulse/blob/dd387635e3c19ef8eca2369db67ac2cf4a0523c8/docs/api/backend.md</a:t>
             </a:r>
           </a:p>
           <a:p>
@@ -3812,7 +3812,7 @@
           </a:p>
           <a:p>
             <a:r>
-              <a:t>https://github.com/manikantbindass/CityPulse/blob/370e60164da719fc506bd69c2796fb59823cc4ba/docs/security/verification.md</a:t>
+              <a:t>https://github.com/manikantbindass/CityPulse/blob/dd387635e3c19ef8eca2369db67ac2cf4a0523c8/docs/security/verification.md</a:t>
             </a:r>
           </a:p>
           <a:p>
@@ -3822,7 +3822,7 @@
           </a:p>
           <a:p>
             <a:r>
-              <a:t>https://github.com/manikantbindass/CityPulse/blob/370e60164da719fc506bd69c2796fb59823cc4ba/docs/operations/scaling.md</a:t>
+              <a:t>https://github.com/manikantbindass/CityPulse/blob/dd387635e3c19ef8eca2369db67ac2cf4a0523c8/docs/operations/scaling.md</a:t>
             </a:r>
           </a:p>
         </p:txBody>
@@ -3898,7 +3898,7 @@
           <a:p/>
           <a:p>
             <a:r>
-              <a:t>Application snapshot: 370e60164da719fc506bd69c2796fb59823cc4ba</a:t>
+              <a:t>Application snapshot: dd387635e3c19ef8eca2369db67ac2cf4a0523c8</a:t>
             </a:r>
           </a:p>
           <a:p>
@@ -3918,7 +3918,7 @@
           </a:p>
           <a:p>
             <a:r>
-              <a:t>https://github.com/manikantbindass/CityPulse/blob/370e60164da719fc506bd69c2796fb59823cc4ba/README.md</a:t>
+              <a:t>https://github.com/manikantbindass/CityPulse/blob/dd387635e3c19ef8eca2369db67ac2cf4a0523c8/README.md</a:t>
             </a:r>
           </a:p>
           <a:p>
@@ -3928,7 +3928,7 @@
           </a:p>
           <a:p>
             <a:r>
-              <a:t>https://github.com/manikantbindass/CityPulse/blob/370e60164da719fc506bd69c2796fb59823cc4ba/docs/operations/scaling.md</a:t>
+              <a:t>https://github.com/manikantbindass/CityPulse/blob/dd387635e3c19ef8eca2369db67ac2cf4a0523c8/docs/operations/scaling.md</a:t>
             </a:r>
           </a:p>
           <a:p>
@@ -3938,7 +3938,7 @@
           </a:p>
           <a:p>
             <a:r>
-              <a:t>https://github.com/manikantbindass/CityPulse/blob/370e60164da719fc506bd69c2796fb59823cc4ba/docs/model-card.md</a:t>
+              <a:t>https://github.com/manikantbindass/CityPulse/blob/dd387635e3c19ef8eca2369db67ac2cf4a0523c8/docs/model-card.md</a:t>
             </a:r>
           </a:p>
         </p:txBody>
@@ -4014,7 +4014,7 @@
           <a:p/>
           <a:p>
             <a:r>
-              <a:t>Application snapshot: 370e60164da719fc506bd69c2796fb59823cc4ba</a:t>
+              <a:t>Application snapshot: dd387635e3c19ef8eca2369db67ac2cf4a0523c8</a:t>
             </a:r>
           </a:p>
           <a:p>
@@ -4039,7 +4039,7 @@
           </a:p>
           <a:p>
             <a:r>
-              <a:t>https://github.com/manikantbindass/CityPulse/blob/370e60164da719fc506bd69c2796fb59823cc4ba/README.md</a:t>
+              <a:t>https://github.com/manikantbindass/CityPulse/blob/dd387635e3c19ef8eca2369db67ac2cf4a0523c8/README.md</a:t>
             </a:r>
           </a:p>
         </p:txBody>
@@ -4115,7 +4115,7 @@
           <a:p/>
           <a:p>
             <a:r>
-              <a:t>Application snapshot: 370e60164da719fc506bd69c2796fb59823cc4ba</a:t>
+              <a:t>Application snapshot: dd387635e3c19ef8eca2369db67ac2cf4a0523c8</a:t>
             </a:r>
           </a:p>
           <a:p>
@@ -4135,7 +4135,7 @@
           </a:p>
           <a:p>
             <a:r>
-              <a:t>https://github.com/manikantbindass/CityPulse/blob/370e60164da719fc506bd69c2796fb59823cc4ba/README.md</a:t>
+              <a:t>https://github.com/manikantbindass/CityPulse/blob/dd387635e3c19ef8eca2369db67ac2cf4a0523c8/README.md</a:t>
             </a:r>
           </a:p>
         </p:txBody>
@@ -4211,7 +4211,7 @@
           <a:p/>
           <a:p>
             <a:r>
-              <a:t>Application snapshot: 370e60164da719fc506bd69c2796fb59823cc4ba</a:t>
+              <a:t>Application snapshot: dd387635e3c19ef8eca2369db67ac2cf4a0523c8</a:t>
             </a:r>
           </a:p>
           <a:p>
@@ -4302,7 +4302,7 @@
           <a:p/>
           <a:p>
             <a:r>
-              <a:t>Application snapshot: 370e60164da719fc506bd69c2796fb59823cc4ba</a:t>
+              <a:t>Application snapshot: dd387635e3c19ef8eca2369db67ac2cf4a0523c8</a:t>
             </a:r>
           </a:p>
           <a:p>
@@ -4322,7 +4322,7 @@
           </a:p>
           <a:p>
             <a:r>
-              <a:t>https://github.com/manikantbindass/CityPulse/blob/370e60164da719fc506bd69c2796fb59823cc4ba/README.md</a:t>
+              <a:t>https://github.com/manikantbindass/CityPulse/blob/dd387635e3c19ef8eca2369db67ac2cf4a0523c8/README.md</a:t>
             </a:r>
           </a:p>
           <a:p>
@@ -4332,7 +4332,7 @@
           </a:p>
           <a:p>
             <a:r>
-              <a:t>https://github.com/manikantbindass/CityPulse/blob/370e60164da719fc506bd69c2796fb59823cc4ba/docs/decision-engine.md</a:t>
+              <a:t>https://github.com/manikantbindass/CityPulse/blob/dd387635e3c19ef8eca2369db67ac2cf4a0523c8/docs/decision-engine.md</a:t>
             </a:r>
           </a:p>
         </p:txBody>
@@ -4408,7 +4408,7 @@
           <a:p/>
           <a:p>
             <a:r>
-              <a:t>Application snapshot: 370e60164da719fc506bd69c2796fb59823cc4ba</a:t>
+              <a:t>Application snapshot: dd387635e3c19ef8eca2369db67ac2cf4a0523c8</a:t>
             </a:r>
           </a:p>
           <a:p>
@@ -4428,7 +4428,7 @@
           </a:p>
           <a:p>
             <a:r>
-              <a:t>https://github.com/manikantbindass/CityPulse/blob/370e60164da719fc506bd69c2796fb59823cc4ba/docs/PRD.md</a:t>
+              <a:t>https://github.com/manikantbindass/CityPulse/blob/dd387635e3c19ef8eca2369db67ac2cf4a0523c8/docs/PRD.md</a:t>
             </a:r>
           </a:p>
           <a:p>
@@ -4509,7 +4509,7 @@
           <a:p/>
           <a:p>
             <a:r>
-              <a:t>Application snapshot: 370e60164da719fc506bd69c2796fb59823cc4ba</a:t>
+              <a:t>Application snapshot: dd387635e3c19ef8eca2369db67ac2cf4a0523c8</a:t>
             </a:r>
           </a:p>
           <a:p>
@@ -4529,7 +4529,7 @@
           </a:p>
           <a:p>
             <a:r>
-              <a:t>https://github.com/manikantbindass/CityPulse/blob/370e60164da719fc506bd69c2796fb59823cc4ba/docs/api/backend.md</a:t>
+              <a:t>https://github.com/manikantbindass/CityPulse/blob/dd387635e3c19ef8eca2369db67ac2cf4a0523c8/docs/api/backend.md</a:t>
             </a:r>
           </a:p>
           <a:p>
@@ -4539,7 +4539,7 @@
           </a:p>
           <a:p>
             <a:r>
-              <a:t>https://github.com/manikantbindass/CityPulse/blob/370e60164da719fc506bd69c2796fb59823cc4ba/docs/security/architecture.md</a:t>
+              <a:t>https://github.com/manikantbindass/CityPulse/blob/dd387635e3c19ef8eca2369db67ac2cf4a0523c8/docs/security/architecture.md</a:t>
             </a:r>
           </a:p>
         </p:txBody>
@@ -4615,7 +4615,7 @@
           <a:p/>
           <a:p>
             <a:r>
-              <a:t>Application snapshot: 370e60164da719fc506bd69c2796fb59823cc4ba</a:t>
+              <a:t>Application snapshot: dd387635e3c19ef8eca2369db67ac2cf4a0523c8</a:t>
             </a:r>
           </a:p>
           <a:p>
@@ -4635,7 +4635,7 @@
           </a:p>
           <a:p>
             <a:r>
-              <a:t>https://github.com/manikantbindass/CityPulse/blob/370e60164da719fc506bd69c2796fb59823cc4ba/README.md</a:t>
+              <a:t>https://github.com/manikantbindass/CityPulse/blob/dd387635e3c19ef8eca2369db67ac2cf4a0523c8/README.md</a:t>
             </a:r>
           </a:p>
           <a:p>
@@ -4645,7 +4645,7 @@
           </a:p>
           <a:p>
             <a:r>
-              <a:t>https://github.com/manikantbindass/CityPulse/blob/370e60164da719fc506bd69c2796fb59823cc4ba/docs/decision-engine.md</a:t>
+              <a:t>https://github.com/manikantbindass/CityPulse/blob/dd387635e3c19ef8eca2369db67ac2cf4a0523c8/docs/decision-engine.md</a:t>
             </a:r>
           </a:p>
         </p:txBody>
@@ -4721,7 +4721,7 @@
           <a:p/>
           <a:p>
             <a:r>
-              <a:t>Application snapshot: 370e60164da719fc506bd69c2796fb59823cc4ba</a:t>
+              <a:t>Application snapshot: dd387635e3c19ef8eca2369db67ac2cf4a0523c8</a:t>
             </a:r>
           </a:p>
           <a:p>
@@ -4741,7 +4741,7 @@
           </a:p>
           <a:p>
             <a:r>
-              <a:t>https://github.com/manikantbindass/CityPulse/blob/370e60164da719fc506bd69c2796fb59823cc4ba/docs/assets/readme-provenance.json</a:t>
+              <a:t>https://github.com/manikantbindass/CityPulse/blob/dd387635e3c19ef8eca2369db67ac2cf4a0523c8/docs/assets/readme-provenance.json</a:t>
             </a:r>
           </a:p>
         </p:txBody>

</xml_diff>

<commit_message>
docs: refresh tested JSON release contracts
</commit_message>
<xml_diff>
--- a/docs/presentations/CityPulse-Project-Presentation.pptx
+++ b/docs/presentations/CityPulse-Project-Presentation.pptx
@@ -1334,7 +1334,7 @@
           <a:p/>
           <a:p>
             <a:r>
-              <a:t>Application snapshot: dd387635e3c19ef8eca2369db67ac2cf4a0523c8</a:t>
+              <a:t>Application snapshot: 3aeefb3d5b88fc9d912e06464405f35e29c6a356</a:t>
             </a:r>
           </a:p>
           <a:p>
@@ -1354,7 +1354,7 @@
           </a:p>
           <a:p>
             <a:r>
-              <a:t>https://github.com/manikantbindass/CityPulse/blob/dd387635e3c19ef8eca2369db67ac2cf4a0523c8/README.md</a:t>
+              <a:t>https://github.com/manikantbindass/CityPulse/blob/3aeefb3d5b88fc9d912e06464405f35e29c6a356/README.md</a:t>
             </a:r>
           </a:p>
           <a:p>
@@ -1435,7 +1435,7 @@
           <a:p/>
           <a:p>
             <a:r>
-              <a:t>Application snapshot: dd387635e3c19ef8eca2369db67ac2cf4a0523c8</a:t>
+              <a:t>Application snapshot: 3aeefb3d5b88fc9d912e06464405f35e29c6a356</a:t>
             </a:r>
           </a:p>
           <a:p>
@@ -1455,7 +1455,7 @@
           </a:p>
           <a:p>
             <a:r>
-              <a:t>https://github.com/manikantbindass/CityPulse/blob/dd387635e3c19ef8eca2369db67ac2cf4a0523c8/apps/web/package.json</a:t>
+              <a:t>https://github.com/manikantbindass/CityPulse/blob/3aeefb3d5b88fc9d912e06464405f35e29c6a356/apps/web/package.json</a:t>
             </a:r>
           </a:p>
           <a:p>
@@ -1465,7 +1465,7 @@
           </a:p>
           <a:p>
             <a:r>
-              <a:t>https://github.com/manikantbindass/CityPulse/blob/dd387635e3c19ef8eca2369db67ac2cf4a0523c8/services/api/pom.xml</a:t>
+              <a:t>https://github.com/manikantbindass/CityPulse/blob/3aeefb3d5b88fc9d912e06464405f35e29c6a356/services/api/pom.xml</a:t>
             </a:r>
           </a:p>
           <a:p>
@@ -1475,7 +1475,7 @@
           </a:p>
           <a:p>
             <a:r>
-              <a:t>https://github.com/manikantbindass/CityPulse/blob/dd387635e3c19ef8eca2369db67ac2cf4a0523c8/services/ai-engine/pyproject.toml</a:t>
+              <a:t>https://github.com/manikantbindass/CityPulse/blob/3aeefb3d5b88fc9d912e06464405f35e29c6a356/services/ai-engine/pyproject.toml</a:t>
             </a:r>
           </a:p>
         </p:txBody>
@@ -1551,7 +1551,7 @@
           <a:p/>
           <a:p>
             <a:r>
-              <a:t>Application snapshot: dd387635e3c19ef8eca2369db67ac2cf4a0523c8</a:t>
+              <a:t>Application snapshot: 3aeefb3d5b88fc9d912e06464405f35e29c6a356</a:t>
             </a:r>
           </a:p>
           <a:p>
@@ -1576,7 +1576,7 @@
           </a:p>
           <a:p>
             <a:r>
-              <a:t>https://github.com/manikantbindass/CityPulse/blob/dd387635e3c19ef8eca2369db67ac2cf4a0523c8/compose.yaml</a:t>
+              <a:t>https://github.com/manikantbindass/CityPulse/blob/3aeefb3d5b88fc9d912e06464405f35e29c6a356/compose.yaml</a:t>
             </a:r>
           </a:p>
         </p:txBody>
@@ -1652,7 +1652,7 @@
           <a:p/>
           <a:p>
             <a:r>
-              <a:t>Application snapshot: dd387635e3c19ef8eca2369db67ac2cf4a0523c8</a:t>
+              <a:t>Application snapshot: 3aeefb3d5b88fc9d912e06464405f35e29c6a356</a:t>
             </a:r>
           </a:p>
           <a:p>
@@ -1672,7 +1672,7 @@
           </a:p>
           <a:p>
             <a:r>
-              <a:t>https://github.com/manikantbindass/CityPulse/blob/dd387635e3c19ef8eca2369db67ac2cf4a0523c8/apps/web/components/providers.tsx</a:t>
+              <a:t>https://github.com/manikantbindass/CityPulse/blob/3aeefb3d5b88fc9d912e06464405f35e29c6a356/apps/web/components/providers.tsx</a:t>
             </a:r>
           </a:p>
           <a:p>
@@ -1682,7 +1682,7 @@
           </a:p>
           <a:p>
             <a:r>
-              <a:t>https://github.com/manikantbindass/CityPulse/blob/dd387635e3c19ef8eca2369db67ac2cf4a0523c8/apps/web/e2e/theme.spec.ts</a:t>
+              <a:t>https://github.com/manikantbindass/CityPulse/blob/3aeefb3d5b88fc9d912e06464405f35e29c6a356/apps/web/e2e/theme.spec.ts</a:t>
             </a:r>
           </a:p>
         </p:txBody>
@@ -1758,7 +1758,7 @@
           <a:p/>
           <a:p>
             <a:r>
-              <a:t>Application snapshot: dd387635e3c19ef8eca2369db67ac2cf4a0523c8</a:t>
+              <a:t>Application snapshot: 3aeefb3d5b88fc9d912e06464405f35e29c6a356</a:t>
             </a:r>
           </a:p>
           <a:p>
@@ -1778,7 +1778,7 @@
           </a:p>
           <a:p>
             <a:r>
-              <a:t>https://github.com/manikantbindass/CityPulse/blob/dd387635e3c19ef8eca2369db67ac2cf4a0523c8/services/api/src/main/java/io/citypulse/identity/MembershipFilter.java</a:t>
+              <a:t>https://github.com/manikantbindass/CityPulse/blob/3aeefb3d5b88fc9d912e06464405f35e29c6a356/services/api/src/main/java/io/citypulse/identity/MembershipFilter.java</a:t>
             </a:r>
           </a:p>
           <a:p>
@@ -1788,7 +1788,7 @@
           </a:p>
           <a:p>
             <a:r>
-              <a:t>https://github.com/manikantbindass/CityPulse/blob/dd387635e3c19ef8eca2369db67ac2cf4a0523c8/docs/api/backend.md</a:t>
+              <a:t>https://github.com/manikantbindass/CityPulse/blob/3aeefb3d5b88fc9d912e06464405f35e29c6a356/docs/api/backend.md</a:t>
             </a:r>
           </a:p>
         </p:txBody>
@@ -1864,7 +1864,7 @@
           <a:p/>
           <a:p>
             <a:r>
-              <a:t>Application snapshot: dd387635e3c19ef8eca2369db67ac2cf4a0523c8</a:t>
+              <a:t>Application snapshot: 3aeefb3d5b88fc9d912e06464405f35e29c6a356</a:t>
             </a:r>
           </a:p>
           <a:p>
@@ -1884,7 +1884,7 @@
           </a:p>
           <a:p>
             <a:r>
-              <a:t>https://github.com/manikantbindass/CityPulse/blob/dd387635e3c19ef8eca2369db67ac2cf4a0523c8/services/api/src/main/resources/db/migration/V1__canonical_geospatial_schema.sql</a:t>
+              <a:t>https://github.com/manikantbindass/CityPulse/blob/3aeefb3d5b88fc9d912e06464405f35e29c6a356/services/api/src/main/resources/db/migration/V1__canonical_geospatial_schema.sql</a:t>
             </a:r>
           </a:p>
           <a:p>
@@ -1894,7 +1894,7 @@
           </a:p>
           <a:p>
             <a:r>
-              <a:t>https://github.com/manikantbindass/CityPulse/blob/dd387635e3c19ef8eca2369db67ac2cf4a0523c8/services/api/src/main/resources/db/migration/V2__tenant_operations.sql</a:t>
+              <a:t>https://github.com/manikantbindass/CityPulse/blob/3aeefb3d5b88fc9d912e06464405f35e29c6a356/services/api/src/main/resources/db/migration/V2__tenant_operations.sql</a:t>
             </a:r>
           </a:p>
         </p:txBody>
@@ -1970,7 +1970,7 @@
           <a:p/>
           <a:p>
             <a:r>
-              <a:t>Application snapshot: dd387635e3c19ef8eca2369db67ac2cf4a0523c8</a:t>
+              <a:t>Application snapshot: 3aeefb3d5b88fc9d912e06464405f35e29c6a356</a:t>
             </a:r>
           </a:p>
           <a:p>
@@ -1990,7 +1990,7 @@
           </a:p>
           <a:p>
             <a:r>
-              <a:t>https://github.com/manikantbindass/CityPulse/blob/dd387635e3c19ef8eca2369db67ac2cf4a0523c8/services/ingestion/citypulse_ingestion/pipeline.py</a:t>
+              <a:t>https://github.com/manikantbindass/CityPulse/blob/3aeefb3d5b88fc9d912e06464405f35e29c6a356/services/ingestion/citypulse_ingestion/pipeline.py</a:t>
             </a:r>
           </a:p>
           <a:p>
@@ -2000,7 +2000,7 @@
           </a:p>
           <a:p>
             <a:r>
-              <a:t>https://github.com/manikantbindass/CityPulse/blob/dd387635e3c19ef8eca2369db67ac2cf4a0523c8/scripts/data_pipeline.py</a:t>
+              <a:t>https://github.com/manikantbindass/CityPulse/blob/3aeefb3d5b88fc9d912e06464405f35e29c6a356/scripts/data_pipeline.py</a:t>
             </a:r>
           </a:p>
         </p:txBody>
@@ -2076,7 +2076,7 @@
           <a:p/>
           <a:p>
             <a:r>
-              <a:t>Application snapshot: dd387635e3c19ef8eca2369db67ac2cf4a0523c8</a:t>
+              <a:t>Application snapshot: 3aeefb3d5b88fc9d912e06464405f35e29c6a356</a:t>
             </a:r>
           </a:p>
           <a:p>
@@ -2096,7 +2096,7 @@
           </a:p>
           <a:p>
             <a:r>
-              <a:t>https://github.com/manikantbindass/CityPulse/blob/dd387635e3c19ef8eca2369db67ac2cf4a0523c8/services/ai-engine/citypulse_ai/modeling.py</a:t>
+              <a:t>https://github.com/manikantbindass/CityPulse/blob/3aeefb3d5b88fc9d912e06464405f35e29c6a356/services/ai-engine/citypulse_ai/modeling.py</a:t>
             </a:r>
           </a:p>
           <a:p>
@@ -2106,7 +2106,7 @@
           </a:p>
           <a:p>
             <a:r>
-              <a:t>https://github.com/manikantbindass/CityPulse/blob/dd387635e3c19ef8eca2369db67ac2cf4a0523c8/docs/reports/model-evaluation.json</a:t>
+              <a:t>https://github.com/manikantbindass/CityPulse/blob/3aeefb3d5b88fc9d912e06464405f35e29c6a356/docs/reports/model-evaluation.json</a:t>
             </a:r>
           </a:p>
         </p:txBody>
@@ -2182,7 +2182,7 @@
           <a:p/>
           <a:p>
             <a:r>
-              <a:t>Application snapshot: dd387635e3c19ef8eca2369db67ac2cf4a0523c8</a:t>
+              <a:t>Application snapshot: 3aeefb3d5b88fc9d912e06464405f35e29c6a356</a:t>
             </a:r>
           </a:p>
           <a:p>
@@ -2202,7 +2202,7 @@
           </a:p>
           <a:p>
             <a:r>
-              <a:t>https://github.com/manikantbindass/CityPulse/blob/dd387635e3c19ef8eca2369db67ac2cf4a0523c8/docs/reports/model-evaluation.json</a:t>
+              <a:t>https://github.com/manikantbindass/CityPulse/blob/3aeefb3d5b88fc9d912e06464405f35e29c6a356/docs/reports/model-evaluation.json</a:t>
             </a:r>
           </a:p>
           <a:p>
@@ -2212,7 +2212,7 @@
           </a:p>
           <a:p>
             <a:r>
-              <a:t>https://github.com/manikantbindass/CityPulse/blob/dd387635e3c19ef8eca2369db67ac2cf4a0523c8/docs/model-card.md</a:t>
+              <a:t>https://github.com/manikantbindass/CityPulse/blob/3aeefb3d5b88fc9d912e06464405f35e29c6a356/docs/model-card.md</a:t>
             </a:r>
           </a:p>
         </p:txBody>
@@ -2288,7 +2288,7 @@
           <a:p/>
           <a:p>
             <a:r>
-              <a:t>Application snapshot: dd387635e3c19ef8eca2369db67ac2cf4a0523c8</a:t>
+              <a:t>Application snapshot: 3aeefb3d5b88fc9d912e06464405f35e29c6a356</a:t>
             </a:r>
           </a:p>
           <a:p>
@@ -2313,7 +2313,7 @@
           </a:p>
           <a:p>
             <a:r>
-              <a:t>https://github.com/manikantbindass/CityPulse/blob/dd387635e3c19ef8eca2369db67ac2cf4a0523c8/docs/model-card.md</a:t>
+              <a:t>https://github.com/manikantbindass/CityPulse/blob/3aeefb3d5b88fc9d912e06464405f35e29c6a356/docs/model-card.md</a:t>
             </a:r>
           </a:p>
         </p:txBody>
@@ -2389,7 +2389,7 @@
           <a:p/>
           <a:p>
             <a:r>
-              <a:t>Application snapshot: dd387635e3c19ef8eca2369db67ac2cf4a0523c8</a:t>
+              <a:t>Application snapshot: 3aeefb3d5b88fc9d912e06464405f35e29c6a356</a:t>
             </a:r>
           </a:p>
           <a:p>
@@ -2409,7 +2409,7 @@
           </a:p>
           <a:p>
             <a:r>
-              <a:t>https://github.com/manikantbindass/CityPulse/blob/dd387635e3c19ef8eca2369db67ac2cf4a0523c8/docs/reports/decision-evaluation.json</a:t>
+              <a:t>https://github.com/manikantbindass/CityPulse/blob/3aeefb3d5b88fc9d912e06464405f35e29c6a356/docs/reports/decision-evaluation.json</a:t>
             </a:r>
           </a:p>
           <a:p>
@@ -2419,7 +2419,7 @@
           </a:p>
           <a:p>
             <a:r>
-              <a:t>https://github.com/manikantbindass/CityPulse/blob/dd387635e3c19ef8eca2369db67ac2cf4a0523c8/services/ai-engine/citypulse_ai/decisions.py</a:t>
+              <a:t>https://github.com/manikantbindass/CityPulse/blob/3aeefb3d5b88fc9d912e06464405f35e29c6a356/services/ai-engine/citypulse_ai/decisions.py</a:t>
             </a:r>
           </a:p>
         </p:txBody>
@@ -2495,7 +2495,7 @@
           <a:p/>
           <a:p>
             <a:r>
-              <a:t>Application snapshot: dd387635e3c19ef8eca2369db67ac2cf4a0523c8</a:t>
+              <a:t>Application snapshot: 3aeefb3d5b88fc9d912e06464405f35e29c6a356</a:t>
             </a:r>
           </a:p>
           <a:p>
@@ -2515,7 +2515,7 @@
           </a:p>
           <a:p>
             <a:r>
-              <a:t>https://github.com/manikantbindass/CityPulse/blob/dd387635e3c19ef8eca2369db67ac2cf4a0523c8/README.md</a:t>
+              <a:t>https://github.com/manikantbindass/CityPulse/blob/3aeefb3d5b88fc9d912e06464405f35e29c6a356/README.md</a:t>
             </a:r>
           </a:p>
           <a:p>
@@ -2525,7 +2525,7 @@
           </a:p>
           <a:p>
             <a:r>
-              <a:t>https://github.com/manikantbindass/CityPulse/blob/dd387635e3c19ef8eca2369db67ac2cf4a0523c8/compose.yaml</a:t>
+              <a:t>https://github.com/manikantbindass/CityPulse/blob/3aeefb3d5b88fc9d912e06464405f35e29c6a356/compose.yaml</a:t>
             </a:r>
           </a:p>
         </p:txBody>
@@ -2601,7 +2601,7 @@
           <a:p/>
           <a:p>
             <a:r>
-              <a:t>Application snapshot: dd387635e3c19ef8eca2369db67ac2cf4a0523c8</a:t>
+              <a:t>Application snapshot: 3aeefb3d5b88fc9d912e06464405f35e29c6a356</a:t>
             </a:r>
           </a:p>
           <a:p>
@@ -2621,7 +2621,7 @@
           </a:p>
           <a:p>
             <a:r>
-              <a:t>https://github.com/manikantbindass/CityPulse/blob/dd387635e3c19ef8eca2369db67ac2cf4a0523c8/services/api/src/main/java/io/citypulse/pulseai/PulseAiService.java</a:t>
+              <a:t>https://github.com/manikantbindass/CityPulse/blob/3aeefb3d5b88fc9d912e06464405f35e29c6a356/services/api/src/main/java/io/citypulse/pulseai/PulseAiService.java</a:t>
             </a:r>
           </a:p>
           <a:p>
@@ -2631,7 +2631,7 @@
           </a:p>
           <a:p>
             <a:r>
-              <a:t>https://github.com/manikantbindass/CityPulse/blob/dd387635e3c19ef8eca2369db67ac2cf4a0523c8/services/ai-engine/citypulse_ai/pulseai.py</a:t>
+              <a:t>https://github.com/manikantbindass/CityPulse/blob/3aeefb3d5b88fc9d912e06464405f35e29c6a356/services/ai-engine/citypulse_ai/pulseai.py</a:t>
             </a:r>
           </a:p>
         </p:txBody>
@@ -2707,7 +2707,7 @@
           <a:p/>
           <a:p>
             <a:r>
-              <a:t>Application snapshot: dd387635e3c19ef8eca2369db67ac2cf4a0523c8</a:t>
+              <a:t>Application snapshot: 3aeefb3d5b88fc9d912e06464405f35e29c6a356</a:t>
             </a:r>
           </a:p>
           <a:p>
@@ -2727,7 +2727,7 @@
           </a:p>
           <a:p>
             <a:r>
-              <a:t>https://github.com/manikantbindass/CityPulse/blob/dd387635e3c19ef8eca2369db67ac2cf4a0523c8/docs/blockchain.md</a:t>
+              <a:t>https://github.com/manikantbindass/CityPulse/blob/3aeefb3d5b88fc9d912e06464405f35e29c6a356/docs/blockchain.md</a:t>
             </a:r>
           </a:p>
           <a:p>
@@ -2737,7 +2737,7 @@
           </a:p>
           <a:p>
             <a:r>
-              <a:t>https://github.com/manikantbindass/CityPulse/blob/dd387635e3c19ef8eca2369db67ac2cf4a0523c8/blockchain/contracts/DatasetAttestationRegistry.sol</a:t>
+              <a:t>https://github.com/manikantbindass/CityPulse/blob/3aeefb3d5b88fc9d912e06464405f35e29c6a356/blockchain/contracts/DatasetAttestationRegistry.sol</a:t>
             </a:r>
           </a:p>
         </p:txBody>
@@ -2813,7 +2813,7 @@
           <a:p/>
           <a:p>
             <a:r>
-              <a:t>Application snapshot: dd387635e3c19ef8eca2369db67ac2cf4a0523c8</a:t>
+              <a:t>Application snapshot: 3aeefb3d5b88fc9d912e06464405f35e29c6a356</a:t>
             </a:r>
           </a:p>
           <a:p>
@@ -2833,7 +2833,7 @@
           </a:p>
           <a:p>
             <a:r>
-              <a:t>https://github.com/manikantbindass/CityPulse/blob/dd387635e3c19ef8eca2369db67ac2cf4a0523c8/docs/reports/blockchain-local-demo.json</a:t>
+              <a:t>https://github.com/manikantbindass/CityPulse/blob/3aeefb3d5b88fc9d912e06464405f35e29c6a356/docs/reports/blockchain-local-demo.json</a:t>
             </a:r>
           </a:p>
           <a:p>
@@ -2843,7 +2843,7 @@
           </a:p>
           <a:p>
             <a:r>
-              <a:t>https://github.com/manikantbindass/CityPulse/blob/dd387635e3c19ef8eca2369db67ac2cf4a0523c8/services/api/src/main/java/io/citypulse/workspace/application/ChainReceiptService.java</a:t>
+              <a:t>https://github.com/manikantbindass/CityPulse/blob/3aeefb3d5b88fc9d912e06464405f35e29c6a356/services/api/src/main/java/io/citypulse/workspace/application/ChainReceiptService.java</a:t>
             </a:r>
           </a:p>
         </p:txBody>
@@ -2919,7 +2919,7 @@
           <a:p/>
           <a:p>
             <a:r>
-              <a:t>Application snapshot: dd387635e3c19ef8eca2369db67ac2cf4a0523c8</a:t>
+              <a:t>Application snapshot: 3aeefb3d5b88fc9d912e06464405f35e29c6a356</a:t>
             </a:r>
           </a:p>
           <a:p>
@@ -2939,7 +2939,7 @@
           </a:p>
           <a:p>
             <a:r>
-              <a:t>https://github.com/manikantbindass/CityPulse/blob/dd387635e3c19ef8eca2369db67ac2cf4a0523c8/docs/security/architecture.md</a:t>
+              <a:t>https://github.com/manikantbindass/CityPulse/blob/3aeefb3d5b88fc9d912e06464405f35e29c6a356/docs/security/architecture.md</a:t>
             </a:r>
           </a:p>
           <a:p>
@@ -2949,7 +2949,7 @@
           </a:p>
           <a:p>
             <a:r>
-              <a:t>https://github.com/manikantbindass/CityPulse/blob/dd387635e3c19ef8eca2369db67ac2cf4a0523c8/docs/security/threat-model.md</a:t>
+              <a:t>https://github.com/manikantbindass/CityPulse/blob/3aeefb3d5b88fc9d912e06464405f35e29c6a356/docs/security/threat-model.md</a:t>
             </a:r>
           </a:p>
         </p:txBody>
@@ -3025,7 +3025,7 @@
           <a:p/>
           <a:p>
             <a:r>
-              <a:t>Application snapshot: dd387635e3c19ef8eca2369db67ac2cf4a0523c8</a:t>
+              <a:t>Application snapshot: 3aeefb3d5b88fc9d912e06464405f35e29c6a356</a:t>
             </a:r>
           </a:p>
           <a:p>
@@ -3045,7 +3045,7 @@
           </a:p>
           <a:p>
             <a:r>
-              <a:t>https://github.com/manikantbindass/CityPulse/blob/dd387635e3c19ef8eca2369db67ac2cf4a0523c8/infrastructure/terraform/main.tf.json</a:t>
+              <a:t>https://github.com/manikantbindass/CityPulse/blob/3aeefb3d5b88fc9d912e06464405f35e29c6a356/infrastructure/terraform/main.tf.json</a:t>
             </a:r>
           </a:p>
           <a:p>
@@ -3055,7 +3055,7 @@
           </a:p>
           <a:p>
             <a:r>
-              <a:t>https://github.com/manikantbindass/CityPulse/blob/dd387635e3c19ef8eca2369db67ac2cf4a0523c8/docs/operations/deployment.md</a:t>
+              <a:t>https://github.com/manikantbindass/CityPulse/blob/3aeefb3d5b88fc9d912e06464405f35e29c6a356/docs/operations/deployment.md</a:t>
             </a:r>
           </a:p>
         </p:txBody>
@@ -3131,7 +3131,7 @@
           <a:p/>
           <a:p>
             <a:r>
-              <a:t>Application snapshot: dd387635e3c19ef8eca2369db67ac2cf4a0523c8</a:t>
+              <a:t>Application snapshot: 3aeefb3d5b88fc9d912e06464405f35e29c6a356</a:t>
             </a:r>
           </a:p>
           <a:p>
@@ -3151,7 +3151,7 @@
           </a:p>
           <a:p>
             <a:r>
-              <a:t>https://github.com/manikantbindass/CityPulse/blob/dd387635e3c19ef8eca2369db67ac2cf4a0523c8/docs/operations/scaling.md</a:t>
+              <a:t>https://github.com/manikantbindass/CityPulse/blob/3aeefb3d5b88fc9d912e06464405f35e29c6a356/docs/operations/scaling.md</a:t>
             </a:r>
           </a:p>
           <a:p>
@@ -3161,7 +3161,7 @@
           </a:p>
           <a:p>
             <a:r>
-              <a:t>https://github.com/manikantbindass/CityPulse/blob/dd387635e3c19ef8eca2369db67ac2cf4a0523c8/docs/operations/recovery.md</a:t>
+              <a:t>https://github.com/manikantbindass/CityPulse/blob/3aeefb3d5b88fc9d912e06464405f35e29c6a356/docs/operations/recovery.md</a:t>
             </a:r>
           </a:p>
         </p:txBody>
@@ -3237,7 +3237,7 @@
           <a:p/>
           <a:p>
             <a:r>
-              <a:t>Application snapshot: dd387635e3c19ef8eca2369db67ac2cf4a0523c8</a:t>
+              <a:t>Application snapshot: 3aeefb3d5b88fc9d912e06464405f35e29c6a356</a:t>
             </a:r>
           </a:p>
           <a:p>
@@ -3257,7 +3257,7 @@
           </a:p>
           <a:p>
             <a:r>
-              <a:t>https://github.com/manikantbindass/CityPulse/blob/dd387635e3c19ef8eca2369db67ac2cf4a0523c8/.github/workflows/ci.yml</a:t>
+              <a:t>https://github.com/manikantbindass/CityPulse/blob/3aeefb3d5b88fc9d912e06464405f35e29c6a356/.github/workflows/ci.yml</a:t>
             </a:r>
           </a:p>
           <a:p>
@@ -3267,7 +3267,7 @@
           </a:p>
           <a:p>
             <a:r>
-              <a:t>https://github.com/manikantbindass/CityPulse/blob/dd387635e3c19ef8eca2369db67ac2cf4a0523c8/.github/workflows/security.yml</a:t>
+              <a:t>https://github.com/manikantbindass/CityPulse/blob/3aeefb3d5b88fc9d912e06464405f35e29c6a356/.github/workflows/security.yml</a:t>
             </a:r>
           </a:p>
           <a:p>
@@ -3277,7 +3277,7 @@
           </a:p>
           <a:p>
             <a:r>
-              <a:t>https://github.com/manikantbindass/CityPulse/blob/dd387635e3c19ef8eca2369db67ac2cf4a0523c8/scripts/monitoring_smoke.py</a:t>
+              <a:t>https://github.com/manikantbindass/CityPulse/blob/3aeefb3d5b88fc9d912e06464405f35e29c6a356/scripts/monitoring_smoke.py</a:t>
             </a:r>
           </a:p>
         </p:txBody>
@@ -3347,13 +3347,13 @@
           <a:lstStyle/>
           <a:p>
             <a:r>
-              <a:t>These counts have revision-linked CI evidence in the report. Linux Java has zero skips; local Docker tests skip because the engine was unavailable. Browser tests include accessibility and theme persistence. Zero fixable HIGH/CRITICAL findings is a scoped scan gate, not a clean bill of security. These counts are the verified earlier 2385ea7 CI baseline. The candidate discovers 30 Java tests; eight are skipped locally without Docker, while 22 execute. The new whole-stack browser scenario must be verified in candidate CI.</a:t>
+              <a:t>These counts have revision-linked CI evidence in the report. Linux Java has zero skips; local Docker tests skip because the engine was unavailable. Browser tests include accessibility and theme persistence. Zero fixable HIGH/CRITICAL findings is a scoped scan gate, not a clean bill of security. These counts are the verified earlier 2385ea7 CI baseline. The candidate discovers 31 Java tests; eight are skipped locally without Docker, while 23 execute. The new whole-stack browser scenario must be verified in candidate CI.</a:t>
             </a:r>
           </a:p>
           <a:p/>
           <a:p>
             <a:r>
-              <a:t>Application snapshot: dd387635e3c19ef8eca2369db67ac2cf4a0523c8</a:t>
+              <a:t>Application snapshot: 3aeefb3d5b88fc9d912e06464405f35e29c6a356</a:t>
             </a:r>
           </a:p>
           <a:p>
@@ -3378,7 +3378,7 @@
           </a:p>
           <a:p>
             <a:r>
-              <a:t>https://github.com/manikantbindass/CityPulse/blob/dd387635e3c19ef8eca2369db67ac2cf4a0523c8/apps/web/e2e/theme.spec.ts</a:t>
+              <a:t>https://github.com/manikantbindass/CityPulse/blob/3aeefb3d5b88fc9d912e06464405f35e29c6a356/apps/web/e2e/theme.spec.ts</a:t>
             </a:r>
           </a:p>
         </p:txBody>
@@ -3454,7 +3454,7 @@
           <a:p/>
           <a:p>
             <a:r>
-              <a:t>Application snapshot: dd387635e3c19ef8eca2369db67ac2cf4a0523c8</a:t>
+              <a:t>Application snapshot: 3aeefb3d5b88fc9d912e06464405f35e29c6a356</a:t>
             </a:r>
           </a:p>
           <a:p>
@@ -3474,7 +3474,7 @@
           </a:p>
           <a:p>
             <a:r>
-              <a:t>https://github.com/manikantbindass/CityPulse/blob/dd387635e3c19ef8eca2369db67ac2cf4a0523c8/scripts/smoke.py</a:t>
+              <a:t>https://github.com/manikantbindass/CityPulse/blob/3aeefb3d5b88fc9d912e06464405f35e29c6a356/scripts/smoke.py</a:t>
             </a:r>
           </a:p>
           <a:p>
@@ -3484,7 +3484,7 @@
           </a:p>
           <a:p>
             <a:r>
-              <a:t>https://github.com/manikantbindass/CityPulse/blob/dd387635e3c19ef8eca2369db67ac2cf4a0523c8/docs/decision-engine.md</a:t>
+              <a:t>https://github.com/manikantbindass/CityPulse/blob/3aeefb3d5b88fc9d912e06464405f35e29c6a356/docs/decision-engine.md</a:t>
             </a:r>
           </a:p>
           <a:p>
@@ -3494,7 +3494,7 @@
           </a:p>
           <a:p>
             <a:r>
-              <a:t>https://github.com/manikantbindass/CityPulse/blob/dd387635e3c19ef8eca2369db67ac2cf4a0523c8/docs/pulseai.md</a:t>
+              <a:t>https://github.com/manikantbindass/CityPulse/blob/3aeefb3d5b88fc9d912e06464405f35e29c6a356/docs/pulseai.md</a:t>
             </a:r>
           </a:p>
         </p:txBody>
@@ -3570,7 +3570,7 @@
           <a:p/>
           <a:p>
             <a:r>
-              <a:t>Application snapshot: dd387635e3c19ef8eca2369db67ac2cf4a0523c8</a:t>
+              <a:t>Application snapshot: 3aeefb3d5b88fc9d912e06464405f35e29c6a356</a:t>
             </a:r>
           </a:p>
           <a:p>
@@ -3590,7 +3590,7 @@
           </a:p>
           <a:p>
             <a:r>
-              <a:t>https://github.com/manikantbindass/CityPulse/blob/dd387635e3c19ef8eca2369db67ac2cf4a0523c8/docs/reports/operations/k6-local-ai.json</a:t>
+              <a:t>https://github.com/manikantbindass/CityPulse/blob/3aeefb3d5b88fc9d912e06464405f35e29c6a356/docs/reports/operations/k6-local-ai.json</a:t>
             </a:r>
           </a:p>
           <a:p>
@@ -3600,7 +3600,7 @@
           </a:p>
           <a:p>
             <a:r>
-              <a:t>https://github.com/manikantbindass/CityPulse/blob/dd387635e3c19ef8eca2369db67ac2cf4a0523c8/docs/reports/decision-evaluation.json</a:t>
+              <a:t>https://github.com/manikantbindass/CityPulse/blob/3aeefb3d5b88fc9d912e06464405f35e29c6a356/docs/reports/decision-evaluation.json</a:t>
             </a:r>
           </a:p>
         </p:txBody>
@@ -3676,7 +3676,7 @@
           <a:p/>
           <a:p>
             <a:r>
-              <a:t>Application snapshot: dd387635e3c19ef8eca2369db67ac2cf4a0523c8</a:t>
+              <a:t>Application snapshot: 3aeefb3d5b88fc9d912e06464405f35e29c6a356</a:t>
             </a:r>
           </a:p>
           <a:p>
@@ -3696,7 +3696,7 @@
           </a:p>
           <a:p>
             <a:r>
-              <a:t>https://github.com/manikantbindass/CityPulse/blob/dd387635e3c19ef8eca2369db67ac2cf4a0523c8/docs/data-dictionary.md</a:t>
+              <a:t>https://github.com/manikantbindass/CityPulse/blob/3aeefb3d5b88fc9d912e06464405f35e29c6a356/docs/data-dictionary.md</a:t>
             </a:r>
           </a:p>
           <a:p>
@@ -3706,7 +3706,7 @@
           </a:p>
           <a:p>
             <a:r>
-              <a:t>https://github.com/manikantbindass/CityPulse/blob/dd387635e3c19ef8eca2369db67ac2cf4a0523c8/services/api/src/main/java/io/citypulse/workspace/application/AnalyticsService.java</a:t>
+              <a:t>https://github.com/manikantbindass/CityPulse/blob/3aeefb3d5b88fc9d912e06464405f35e29c6a356/services/api/src/main/java/io/citypulse/workspace/application/AnalyticsService.java</a:t>
             </a:r>
           </a:p>
         </p:txBody>
@@ -3782,7 +3782,7 @@
           <a:p/>
           <a:p>
             <a:r>
-              <a:t>Application snapshot: dd387635e3c19ef8eca2369db67ac2cf4a0523c8</a:t>
+              <a:t>Application snapshot: 3aeefb3d5b88fc9d912e06464405f35e29c6a356</a:t>
             </a:r>
           </a:p>
           <a:p>
@@ -3802,7 +3802,7 @@
           </a:p>
           <a:p>
             <a:r>
-              <a:t>https://github.com/manikantbindass/CityPulse/blob/dd387635e3c19ef8eca2369db67ac2cf4a0523c8/docs/api/backend.md</a:t>
+              <a:t>https://github.com/manikantbindass/CityPulse/blob/3aeefb3d5b88fc9d912e06464405f35e29c6a356/docs/api/backend.md</a:t>
             </a:r>
           </a:p>
           <a:p>
@@ -3812,7 +3812,7 @@
           </a:p>
           <a:p>
             <a:r>
-              <a:t>https://github.com/manikantbindass/CityPulse/blob/dd387635e3c19ef8eca2369db67ac2cf4a0523c8/docs/security/verification.md</a:t>
+              <a:t>https://github.com/manikantbindass/CityPulse/blob/3aeefb3d5b88fc9d912e06464405f35e29c6a356/docs/security/verification.md</a:t>
             </a:r>
           </a:p>
           <a:p>
@@ -3822,7 +3822,7 @@
           </a:p>
           <a:p>
             <a:r>
-              <a:t>https://github.com/manikantbindass/CityPulse/blob/dd387635e3c19ef8eca2369db67ac2cf4a0523c8/docs/operations/scaling.md</a:t>
+              <a:t>https://github.com/manikantbindass/CityPulse/blob/3aeefb3d5b88fc9d912e06464405f35e29c6a356/docs/operations/scaling.md</a:t>
             </a:r>
           </a:p>
         </p:txBody>
@@ -3898,7 +3898,7 @@
           <a:p/>
           <a:p>
             <a:r>
-              <a:t>Application snapshot: dd387635e3c19ef8eca2369db67ac2cf4a0523c8</a:t>
+              <a:t>Application snapshot: 3aeefb3d5b88fc9d912e06464405f35e29c6a356</a:t>
             </a:r>
           </a:p>
           <a:p>
@@ -3918,7 +3918,7 @@
           </a:p>
           <a:p>
             <a:r>
-              <a:t>https://github.com/manikantbindass/CityPulse/blob/dd387635e3c19ef8eca2369db67ac2cf4a0523c8/README.md</a:t>
+              <a:t>https://github.com/manikantbindass/CityPulse/blob/3aeefb3d5b88fc9d912e06464405f35e29c6a356/README.md</a:t>
             </a:r>
           </a:p>
           <a:p>
@@ -3928,7 +3928,7 @@
           </a:p>
           <a:p>
             <a:r>
-              <a:t>https://github.com/manikantbindass/CityPulse/blob/dd387635e3c19ef8eca2369db67ac2cf4a0523c8/docs/operations/scaling.md</a:t>
+              <a:t>https://github.com/manikantbindass/CityPulse/blob/3aeefb3d5b88fc9d912e06464405f35e29c6a356/docs/operations/scaling.md</a:t>
             </a:r>
           </a:p>
           <a:p>
@@ -3938,7 +3938,7 @@
           </a:p>
           <a:p>
             <a:r>
-              <a:t>https://github.com/manikantbindass/CityPulse/blob/dd387635e3c19ef8eca2369db67ac2cf4a0523c8/docs/model-card.md</a:t>
+              <a:t>https://github.com/manikantbindass/CityPulse/blob/3aeefb3d5b88fc9d912e06464405f35e29c6a356/docs/model-card.md</a:t>
             </a:r>
           </a:p>
         </p:txBody>
@@ -4014,7 +4014,7 @@
           <a:p/>
           <a:p>
             <a:r>
-              <a:t>Application snapshot: dd387635e3c19ef8eca2369db67ac2cf4a0523c8</a:t>
+              <a:t>Application snapshot: 3aeefb3d5b88fc9d912e06464405f35e29c6a356</a:t>
             </a:r>
           </a:p>
           <a:p>
@@ -4039,7 +4039,7 @@
           </a:p>
           <a:p>
             <a:r>
-              <a:t>https://github.com/manikantbindass/CityPulse/blob/dd387635e3c19ef8eca2369db67ac2cf4a0523c8/README.md</a:t>
+              <a:t>https://github.com/manikantbindass/CityPulse/blob/3aeefb3d5b88fc9d912e06464405f35e29c6a356/README.md</a:t>
             </a:r>
           </a:p>
         </p:txBody>
@@ -4115,7 +4115,7 @@
           <a:p/>
           <a:p>
             <a:r>
-              <a:t>Application snapshot: dd387635e3c19ef8eca2369db67ac2cf4a0523c8</a:t>
+              <a:t>Application snapshot: 3aeefb3d5b88fc9d912e06464405f35e29c6a356</a:t>
             </a:r>
           </a:p>
           <a:p>
@@ -4135,7 +4135,7 @@
           </a:p>
           <a:p>
             <a:r>
-              <a:t>https://github.com/manikantbindass/CityPulse/blob/dd387635e3c19ef8eca2369db67ac2cf4a0523c8/README.md</a:t>
+              <a:t>https://github.com/manikantbindass/CityPulse/blob/3aeefb3d5b88fc9d912e06464405f35e29c6a356/README.md</a:t>
             </a:r>
           </a:p>
         </p:txBody>
@@ -4211,7 +4211,7 @@
           <a:p/>
           <a:p>
             <a:r>
-              <a:t>Application snapshot: dd387635e3c19ef8eca2369db67ac2cf4a0523c8</a:t>
+              <a:t>Application snapshot: 3aeefb3d5b88fc9d912e06464405f35e29c6a356</a:t>
             </a:r>
           </a:p>
           <a:p>
@@ -4302,7 +4302,7 @@
           <a:p/>
           <a:p>
             <a:r>
-              <a:t>Application snapshot: dd387635e3c19ef8eca2369db67ac2cf4a0523c8</a:t>
+              <a:t>Application snapshot: 3aeefb3d5b88fc9d912e06464405f35e29c6a356</a:t>
             </a:r>
           </a:p>
           <a:p>
@@ -4322,7 +4322,7 @@
           </a:p>
           <a:p>
             <a:r>
-              <a:t>https://github.com/manikantbindass/CityPulse/blob/dd387635e3c19ef8eca2369db67ac2cf4a0523c8/README.md</a:t>
+              <a:t>https://github.com/manikantbindass/CityPulse/blob/3aeefb3d5b88fc9d912e06464405f35e29c6a356/README.md</a:t>
             </a:r>
           </a:p>
           <a:p>
@@ -4332,7 +4332,7 @@
           </a:p>
           <a:p>
             <a:r>
-              <a:t>https://github.com/manikantbindass/CityPulse/blob/dd387635e3c19ef8eca2369db67ac2cf4a0523c8/docs/decision-engine.md</a:t>
+              <a:t>https://github.com/manikantbindass/CityPulse/blob/3aeefb3d5b88fc9d912e06464405f35e29c6a356/docs/decision-engine.md</a:t>
             </a:r>
           </a:p>
         </p:txBody>
@@ -4408,7 +4408,7 @@
           <a:p/>
           <a:p>
             <a:r>
-              <a:t>Application snapshot: dd387635e3c19ef8eca2369db67ac2cf4a0523c8</a:t>
+              <a:t>Application snapshot: 3aeefb3d5b88fc9d912e06464405f35e29c6a356</a:t>
             </a:r>
           </a:p>
           <a:p>
@@ -4428,7 +4428,7 @@
           </a:p>
           <a:p>
             <a:r>
-              <a:t>https://github.com/manikantbindass/CityPulse/blob/dd387635e3c19ef8eca2369db67ac2cf4a0523c8/docs/PRD.md</a:t>
+              <a:t>https://github.com/manikantbindass/CityPulse/blob/3aeefb3d5b88fc9d912e06464405f35e29c6a356/docs/PRD.md</a:t>
             </a:r>
           </a:p>
           <a:p>
@@ -4509,7 +4509,7 @@
           <a:p/>
           <a:p>
             <a:r>
-              <a:t>Application snapshot: dd387635e3c19ef8eca2369db67ac2cf4a0523c8</a:t>
+              <a:t>Application snapshot: 3aeefb3d5b88fc9d912e06464405f35e29c6a356</a:t>
             </a:r>
           </a:p>
           <a:p>
@@ -4529,7 +4529,7 @@
           </a:p>
           <a:p>
             <a:r>
-              <a:t>https://github.com/manikantbindass/CityPulse/blob/dd387635e3c19ef8eca2369db67ac2cf4a0523c8/docs/api/backend.md</a:t>
+              <a:t>https://github.com/manikantbindass/CityPulse/blob/3aeefb3d5b88fc9d912e06464405f35e29c6a356/docs/api/backend.md</a:t>
             </a:r>
           </a:p>
           <a:p>
@@ -4539,7 +4539,7 @@
           </a:p>
           <a:p>
             <a:r>
-              <a:t>https://github.com/manikantbindass/CityPulse/blob/dd387635e3c19ef8eca2369db67ac2cf4a0523c8/docs/security/architecture.md</a:t>
+              <a:t>https://github.com/manikantbindass/CityPulse/blob/3aeefb3d5b88fc9d912e06464405f35e29c6a356/docs/security/architecture.md</a:t>
             </a:r>
           </a:p>
         </p:txBody>
@@ -4615,7 +4615,7 @@
           <a:p/>
           <a:p>
             <a:r>
-              <a:t>Application snapshot: dd387635e3c19ef8eca2369db67ac2cf4a0523c8</a:t>
+              <a:t>Application snapshot: 3aeefb3d5b88fc9d912e06464405f35e29c6a356</a:t>
             </a:r>
           </a:p>
           <a:p>
@@ -4635,7 +4635,7 @@
           </a:p>
           <a:p>
             <a:r>
-              <a:t>https://github.com/manikantbindass/CityPulse/blob/dd387635e3c19ef8eca2369db67ac2cf4a0523c8/README.md</a:t>
+              <a:t>https://github.com/manikantbindass/CityPulse/blob/3aeefb3d5b88fc9d912e06464405f35e29c6a356/README.md</a:t>
             </a:r>
           </a:p>
           <a:p>
@@ -4645,7 +4645,7 @@
           </a:p>
           <a:p>
             <a:r>
-              <a:t>https://github.com/manikantbindass/CityPulse/blob/dd387635e3c19ef8eca2369db67ac2cf4a0523c8/docs/decision-engine.md</a:t>
+              <a:t>https://github.com/manikantbindass/CityPulse/blob/3aeefb3d5b88fc9d912e06464405f35e29c6a356/docs/decision-engine.md</a:t>
             </a:r>
           </a:p>
         </p:txBody>
@@ -4721,7 +4721,7 @@
           <a:p/>
           <a:p>
             <a:r>
-              <a:t>Application snapshot: dd387635e3c19ef8eca2369db67ac2cf4a0523c8</a:t>
+              <a:t>Application snapshot: 3aeefb3d5b88fc9d912e06464405f35e29c6a356</a:t>
             </a:r>
           </a:p>
           <a:p>
@@ -4741,7 +4741,7 @@
           </a:p>
           <a:p>
             <a:r>
-              <a:t>https://github.com/manikantbindass/CityPulse/blob/dd387635e3c19ef8eca2369db67ac2cf4a0523c8/docs/assets/readme-provenance.json</a:t>
+              <a:t>https://github.com/manikantbindass/CityPulse/blob/3aeefb3d5b88fc9d912e06464405f35e29c6a356/docs/assets/readme-provenance.json</a:t>
             </a:r>
           </a:p>
         </p:txBody>

</xml_diff>